<commit_message>
updated a supplementary figure
</commit_message>
<xml_diff>
--- a/figures/sup/fig4/fig4.pptx
+++ b/figures/sup/fig4/fig4.pptx
@@ -9,7 +9,7 @@
   </p:notesMasterIdLst>
   <p:sldIdLst>
     <p:sldId id="257" r:id="rId2"/>
-    <p:sldId id="256" r:id="rId3"/>
+    <p:sldId id="258" r:id="rId3"/>
   </p:sldIdLst>
   <p:sldSz cx="36576000" cy="32918400"/>
   <p:notesSz cx="7010400" cy="9296400"/>
@@ -258,7 +258,7 @@
       </p15:sldGuideLst>
     </p:ext>
     <p:ext uri="http://customooxmlschemas.google.com/">
-      <go:slidesCustomData xmlns="" xmlns:mc="http://schemas.openxmlformats.org/markup-compatibility/2006" xmlns:mv="urn:schemas-microsoft-com:mac:vml" xmlns:c="http://schemas.openxmlformats.org/drawingml/2006/chart" xmlns:dgm="http://schemas.openxmlformats.org/drawingml/2006/diagram" xmlns:o="urn:schemas-microsoft-com:office:office" xmlns:v="urn:schemas-microsoft-com:vml" xmlns:pvml="urn:schemas-microsoft-com:office:powerpoint" xmlns:com="http://schemas.openxmlformats.org/drawingml/2006/compatibility" xmlns:p14="http://schemas.microsoft.com/office/powerpoint/2010/main" xmlns:p15="http://schemas.microsoft.com/office/powerpoint/2012/main" xmlns:ahyp="http://schemas.microsoft.com/office/drawing/2018/hyperlinkcolor" xmlns:go="http://customooxmlschemas.google.com/" r:id="rId10" roundtripDataSignature="AMtx7mhiytGPk8UOxiAGs9KaAxakDbg4SQ=="/>
+      <go:slidesCustomData xmlns:go="http://customooxmlschemas.google.com/" xmlns:ahyp="http://schemas.microsoft.com/office/drawing/2018/hyperlinkcolor" xmlns:p15="http://schemas.microsoft.com/office/powerpoint/2012/main" xmlns:p14="http://schemas.microsoft.com/office/powerpoint/2010/main" xmlns:com="http://schemas.openxmlformats.org/drawingml/2006/compatibility" xmlns:pvml="urn:schemas-microsoft-com:office:powerpoint" xmlns:v="urn:schemas-microsoft-com:vml" xmlns:o="urn:schemas-microsoft-com:office:office" xmlns:dgm="http://schemas.openxmlformats.org/drawingml/2006/diagram" xmlns:c="http://schemas.openxmlformats.org/drawingml/2006/chart" xmlns:mv="urn:schemas-microsoft-com:mac:vml" xmlns:mc="http://schemas.openxmlformats.org/markup-compatibility/2006" xmlns="" r:id="rId10" roundtripDataSignature="AMtx7mhiytGPk8UOxiAGs9KaAxakDbg4SQ=="/>
     </p:ext>
   </p:extLst>
 </p:presentation>
@@ -1462,7 +1462,13 @@
   <p:cSld>
     <p:spTree>
       <p:nvGrpSpPr>
-        <p:cNvPr id="1" name="Shape 84"/>
+        <p:cNvPr id="1" name="Shape 84">
+          <a:extLst>
+            <a:ext uri="{FF2B5EF4-FFF2-40B4-BE49-F238E27FC236}">
+              <a16:creationId xmlns:a16="http://schemas.microsoft.com/office/drawing/2014/main" id="{22F89A7F-014F-27BE-3893-2262A7B39906}"/>
+            </a:ext>
+          </a:extLst>
+        </p:cNvPr>
         <p:cNvGrpSpPr/>
         <p:nvPr/>
       </p:nvGrpSpPr>
@@ -1476,7 +1482,13 @@
       </p:grpSpPr>
       <p:sp>
         <p:nvSpPr>
-          <p:cNvPr id="85" name="Google Shape;85;p1:notes"/>
+          <p:cNvPr id="85" name="Google Shape;85;p1:notes">
+            <a:extLst>
+              <a:ext uri="{FF2B5EF4-FFF2-40B4-BE49-F238E27FC236}">
+                <a16:creationId xmlns:a16="http://schemas.microsoft.com/office/drawing/2014/main" id="{450008AC-4CF3-ECD8-F098-34587F33C332}"/>
+              </a:ext>
+            </a:extLst>
+          </p:cNvPr>
           <p:cNvSpPr>
             <a:spLocks noGrp="1" noRot="1" noChangeAspect="1"/>
           </p:cNvSpPr>
@@ -1527,7 +1539,13 @@
       </p:sp>
       <p:sp>
         <p:nvSpPr>
-          <p:cNvPr id="86" name="Google Shape;86;p1:notes"/>
+          <p:cNvPr id="86" name="Google Shape;86;p1:notes">
+            <a:extLst>
+              <a:ext uri="{FF2B5EF4-FFF2-40B4-BE49-F238E27FC236}">
+                <a16:creationId xmlns:a16="http://schemas.microsoft.com/office/drawing/2014/main" id="{A188DEC1-C9B6-3233-752C-91BC48708C38}"/>
+              </a:ext>
+            </a:extLst>
+          </p:cNvPr>
           <p:cNvSpPr txBox="1">
             <a:spLocks noGrp="1"/>
           </p:cNvSpPr>
@@ -1569,7 +1587,13 @@
       </p:sp>
       <p:sp>
         <p:nvSpPr>
-          <p:cNvPr id="87" name="Google Shape;87;p1:notes"/>
+          <p:cNvPr id="87" name="Google Shape;87;p1:notes">
+            <a:extLst>
+              <a:ext uri="{FF2B5EF4-FFF2-40B4-BE49-F238E27FC236}">
+                <a16:creationId xmlns:a16="http://schemas.microsoft.com/office/drawing/2014/main" id="{47AB1E4A-2C99-7138-E554-62DB0BB81B74}"/>
+              </a:ext>
+            </a:extLst>
+          </p:cNvPr>
           <p:cNvSpPr txBox="1">
             <a:spLocks noGrp="1"/>
           </p:cNvSpPr>
@@ -1630,6 +1654,11 @@
         </p:txBody>
       </p:sp>
     </p:spTree>
+    <p:extLst>
+      <p:ext uri="{BB962C8B-B14F-4D97-AF65-F5344CB8AC3E}">
+        <p14:creationId xmlns:p14="http://schemas.microsoft.com/office/powerpoint/2010/main" val="340238506"/>
+      </p:ext>
+    </p:extLst>
   </p:cSld>
   <p:clrMapOvr>
     <a:masterClrMapping/>
@@ -11917,10 +11946,10 @@
       </p:graphicFrame>
       <p:pic>
         <p:nvPicPr>
-          <p:cNvPr id="3" name="Graphic 2">
+          <p:cNvPr id="5" name="Graphic 4">
             <a:extLst>
               <a:ext uri="{FF2B5EF4-FFF2-40B4-BE49-F238E27FC236}">
-                <a16:creationId xmlns:a16="http://schemas.microsoft.com/office/drawing/2014/main" id="{946DE017-C61A-312C-B65E-0CBC13258BE7}"/>
+                <a16:creationId xmlns:a16="http://schemas.microsoft.com/office/drawing/2014/main" id="{512870E0-C627-C93A-48DC-993AE1925C65}"/>
               </a:ext>
             </a:extLst>
           </p:cNvPr>
@@ -11937,15 +11966,15 @@
               </a:ext>
             </a:extLst>
           </a:blip>
-          <a:srcRect l="2500" r="5238"/>
+          <a:srcRect l="5807" r="3951"/>
           <a:stretch>
             <a:fillRect/>
           </a:stretch>
         </p:blipFill>
         <p:spPr>
           <a:xfrm>
-            <a:off x="914400" y="8250647"/>
-            <a:ext cx="33745714" cy="16417105"/>
+            <a:off x="2123768" y="8530378"/>
+            <a:ext cx="33006890" cy="15857644"/>
           </a:xfrm>
           <a:prstGeom prst="rect">
             <a:avLst/>
@@ -11978,7 +12007,13 @@
     </p:bg>
     <p:spTree>
       <p:nvGrpSpPr>
-        <p:cNvPr id="1" name="Shape 88"/>
+        <p:cNvPr id="1" name="Shape 88">
+          <a:extLst>
+            <a:ext uri="{FF2B5EF4-FFF2-40B4-BE49-F238E27FC236}">
+              <a16:creationId xmlns:a16="http://schemas.microsoft.com/office/drawing/2014/main" id="{84FD0798-82E0-CA48-5324-60F28A9A93B6}"/>
+            </a:ext>
+          </a:extLst>
+        </p:cNvPr>
         <p:cNvGrpSpPr/>
         <p:nvPr/>
       </p:nvGrpSpPr>
@@ -11992,10 +12027,10 @@
       </p:grpSpPr>
       <p:pic>
         <p:nvPicPr>
-          <p:cNvPr id="24" name="Picture 23">
+          <p:cNvPr id="3" name="Picture 2">
             <a:extLst>
               <a:ext uri="{FF2B5EF4-FFF2-40B4-BE49-F238E27FC236}">
-                <a16:creationId xmlns:a16="http://schemas.microsoft.com/office/drawing/2014/main" id="{318ACE6C-1E58-2372-301D-A00D8C993EB2}"/>
+                <a16:creationId xmlns:a16="http://schemas.microsoft.com/office/drawing/2014/main" id="{9E1EA5C3-12F7-38D7-605C-91C2A6068259}"/>
               </a:ext>
             </a:extLst>
           </p:cNvPr>
@@ -12006,15 +12041,15 @@
         </p:nvPicPr>
         <p:blipFill>
           <a:blip r:embed="rId3"/>
-          <a:srcRect l="18371" t="14791" r="26936" b="21594"/>
+          <a:srcRect l="18117" t="13297" r="26918" b="20441"/>
           <a:stretch>
             <a:fillRect/>
           </a:stretch>
         </p:blipFill>
         <p:spPr>
           <a:xfrm>
-            <a:off x="10320904" y="14225618"/>
-            <a:ext cx="6385946" cy="3696759"/>
+            <a:off x="16436340" y="17731740"/>
+            <a:ext cx="4025900" cy="2415540"/>
           </a:xfrm>
           <a:prstGeom prst="rect">
             <a:avLst/>
@@ -12023,10 +12058,10 @@
       </p:pic>
       <p:pic>
         <p:nvPicPr>
-          <p:cNvPr id="26" name="Picture 25">
+          <p:cNvPr id="4" name="Picture 3">
             <a:extLst>
               <a:ext uri="{FF2B5EF4-FFF2-40B4-BE49-F238E27FC236}">
-                <a16:creationId xmlns:a16="http://schemas.microsoft.com/office/drawing/2014/main" id="{C3F183E1-6DCC-B31E-7E04-53DF98C8318C}"/>
+                <a16:creationId xmlns:a16="http://schemas.microsoft.com/office/drawing/2014/main" id="{AD0BE06E-180B-95D5-D339-3031AFB68980}"/>
               </a:ext>
             </a:extLst>
           </p:cNvPr>
@@ -12037,15 +12072,15 @@
         </p:nvPicPr>
         <p:blipFill>
           <a:blip r:embed="rId4"/>
-          <a:srcRect l="18440" t="14545" r="26936" b="21594"/>
+          <a:srcRect l="18117" t="14276" r="26917" b="21447"/>
           <a:stretch>
             <a:fillRect/>
           </a:stretch>
         </p:blipFill>
         <p:spPr>
           <a:xfrm>
-            <a:off x="10329062" y="9182100"/>
-            <a:ext cx="6377788" cy="3711077"/>
+            <a:off x="16436340" y="14725650"/>
+            <a:ext cx="4025900" cy="2343150"/>
           </a:xfrm>
           <a:prstGeom prst="rect">
             <a:avLst/>
@@ -12054,10 +12089,10 @@
       </p:pic>
       <p:pic>
         <p:nvPicPr>
-          <p:cNvPr id="28" name="Picture 27">
+          <p:cNvPr id="6" name="Picture 5">
             <a:extLst>
               <a:ext uri="{FF2B5EF4-FFF2-40B4-BE49-F238E27FC236}">
-                <a16:creationId xmlns:a16="http://schemas.microsoft.com/office/drawing/2014/main" id="{E9A566FE-3B54-A440-91D1-5A36DE7A6A3B}"/>
+                <a16:creationId xmlns:a16="http://schemas.microsoft.com/office/drawing/2014/main" id="{4FB3EC84-83B4-7F5B-5503-E4ECF202A60A}"/>
               </a:ext>
             </a:extLst>
           </p:cNvPr>
@@ -12068,15 +12103,15 @@
         </p:nvPicPr>
         <p:blipFill>
           <a:blip r:embed="rId5"/>
-          <a:srcRect l="18371" t="14546" r="26936" b="21929"/>
+          <a:srcRect l="18009" t="14277" r="27025" b="21447"/>
           <a:stretch>
             <a:fillRect/>
           </a:stretch>
         </p:blipFill>
         <p:spPr>
           <a:xfrm>
-            <a:off x="19192870" y="9182100"/>
-            <a:ext cx="6385946" cy="3691628"/>
+            <a:off x="10750550" y="14725650"/>
+            <a:ext cx="4025900" cy="2343150"/>
           </a:xfrm>
           <a:prstGeom prst="rect">
             <a:avLst/>
@@ -12085,10 +12120,10 @@
       </p:pic>
       <p:pic>
         <p:nvPicPr>
-          <p:cNvPr id="30" name="Picture 29">
+          <p:cNvPr id="8" name="Picture 7">
             <a:extLst>
               <a:ext uri="{FF2B5EF4-FFF2-40B4-BE49-F238E27FC236}">
-                <a16:creationId xmlns:a16="http://schemas.microsoft.com/office/drawing/2014/main" id="{421B756D-B40B-DFAB-B7DB-B8E1C5693CC8}"/>
+                <a16:creationId xmlns:a16="http://schemas.microsoft.com/office/drawing/2014/main" id="{F0B9A416-3228-6F49-21C4-8A1EAD39919C}"/>
               </a:ext>
             </a:extLst>
           </p:cNvPr>
@@ -12099,15 +12134,15 @@
         </p:nvPicPr>
         <p:blipFill>
           <a:blip r:embed="rId6"/>
-          <a:srcRect l="18385" t="14481" r="26936" b="21984"/>
+          <a:srcRect l="18010" t="13297" r="27024" b="20441"/>
           <a:stretch>
             <a:fillRect/>
           </a:stretch>
         </p:blipFill>
         <p:spPr>
           <a:xfrm>
-            <a:off x="19194648" y="14207607"/>
-            <a:ext cx="6384168" cy="3692134"/>
+            <a:off x="10750550" y="17731740"/>
+            <a:ext cx="4025900" cy="2415540"/>
           </a:xfrm>
           <a:prstGeom prst="rect">
             <a:avLst/>
@@ -12116,10 +12151,10 @@
       </p:pic>
       <p:sp>
         <p:nvSpPr>
-          <p:cNvPr id="76" name="TextBox 75">
+          <p:cNvPr id="9" name="TextBox 8">
             <a:extLst>
               <a:ext uri="{FF2B5EF4-FFF2-40B4-BE49-F238E27FC236}">
-                <a16:creationId xmlns:a16="http://schemas.microsoft.com/office/drawing/2014/main" id="{939C6B43-D60B-3B1B-5F9B-E80C7751207F}"/>
+                <a16:creationId xmlns:a16="http://schemas.microsoft.com/office/drawing/2014/main" id="{C3DB9A94-0DF5-3B24-38F0-30430F819364}"/>
               </a:ext>
             </a:extLst>
           </p:cNvPr>
@@ -12128,8 +12163,296 @@
         </p:nvSpPr>
         <p:spPr>
           <a:xfrm>
-            <a:off x="16706850" y="14372111"/>
-            <a:ext cx="2487803" cy="307777"/>
+            <a:off x="10854853" y="20094892"/>
+            <a:ext cx="487045" cy="307777"/>
+          </a:xfrm>
+          <a:prstGeom prst="rect">
+            <a:avLst/>
+          </a:prstGeom>
+          <a:noFill/>
+        </p:spPr>
+        <p:txBody>
+          <a:bodyPr wrap="square" rtlCol="0">
+            <a:spAutoFit/>
+          </a:bodyPr>
+          <a:lstStyle/>
+          <a:p>
+            <a:pPr algn="ctr"/>
+            <a:r>
+              <a:rPr lang="en-US" dirty="0"/>
+              <a:t>-1</a:t>
+            </a:r>
+          </a:p>
+        </p:txBody>
+      </p:sp>
+      <p:sp>
+        <p:nvSpPr>
+          <p:cNvPr id="12" name="TextBox 11">
+            <a:extLst>
+              <a:ext uri="{FF2B5EF4-FFF2-40B4-BE49-F238E27FC236}">
+                <a16:creationId xmlns:a16="http://schemas.microsoft.com/office/drawing/2014/main" id="{6476F43E-0806-4351-1CB9-4E596A1B7831}"/>
+              </a:ext>
+            </a:extLst>
+          </p:cNvPr>
+          <p:cNvSpPr txBox="1"/>
+          <p:nvPr/>
+        </p:nvSpPr>
+        <p:spPr>
+          <a:xfrm>
+            <a:off x="11365712" y="20094892"/>
+            <a:ext cx="529902" cy="307777"/>
+          </a:xfrm>
+          <a:prstGeom prst="rect">
+            <a:avLst/>
+          </a:prstGeom>
+          <a:noFill/>
+        </p:spPr>
+        <p:txBody>
+          <a:bodyPr wrap="square" rtlCol="0">
+            <a:spAutoFit/>
+          </a:bodyPr>
+          <a:lstStyle/>
+          <a:p>
+            <a:pPr algn="ctr"/>
+            <a:r>
+              <a:rPr lang="en-US" dirty="0"/>
+              <a:t>-0.5</a:t>
+            </a:r>
+          </a:p>
+        </p:txBody>
+      </p:sp>
+      <p:sp>
+        <p:nvSpPr>
+          <p:cNvPr id="13" name="TextBox 12">
+            <a:extLst>
+              <a:ext uri="{FF2B5EF4-FFF2-40B4-BE49-F238E27FC236}">
+                <a16:creationId xmlns:a16="http://schemas.microsoft.com/office/drawing/2014/main" id="{54DAF426-C7AA-A1CE-0B39-11355876B77F}"/>
+              </a:ext>
+            </a:extLst>
+          </p:cNvPr>
+          <p:cNvSpPr txBox="1"/>
+          <p:nvPr/>
+        </p:nvSpPr>
+        <p:spPr>
+          <a:xfrm>
+            <a:off x="11902757" y="20094893"/>
+            <a:ext cx="529902" cy="307777"/>
+          </a:xfrm>
+          <a:prstGeom prst="rect">
+            <a:avLst/>
+          </a:prstGeom>
+          <a:noFill/>
+        </p:spPr>
+        <p:txBody>
+          <a:bodyPr wrap="square" rtlCol="0">
+            <a:spAutoFit/>
+          </a:bodyPr>
+          <a:lstStyle/>
+          <a:p>
+            <a:pPr algn="ctr"/>
+            <a:r>
+              <a:rPr lang="en-US" dirty="0"/>
+              <a:t>0</a:t>
+            </a:r>
+          </a:p>
+        </p:txBody>
+      </p:sp>
+      <p:sp>
+        <p:nvSpPr>
+          <p:cNvPr id="14" name="TextBox 13">
+            <a:extLst>
+              <a:ext uri="{FF2B5EF4-FFF2-40B4-BE49-F238E27FC236}">
+                <a16:creationId xmlns:a16="http://schemas.microsoft.com/office/drawing/2014/main" id="{5F51E2E9-9F1B-A4D5-6541-A86FCFF42FB1}"/>
+              </a:ext>
+            </a:extLst>
+          </p:cNvPr>
+          <p:cNvSpPr txBox="1"/>
+          <p:nvPr/>
+        </p:nvSpPr>
+        <p:spPr>
+          <a:xfrm>
+            <a:off x="12437421" y="20094891"/>
+            <a:ext cx="529902" cy="307777"/>
+          </a:xfrm>
+          <a:prstGeom prst="rect">
+            <a:avLst/>
+          </a:prstGeom>
+          <a:noFill/>
+        </p:spPr>
+        <p:txBody>
+          <a:bodyPr wrap="square" rtlCol="0">
+            <a:spAutoFit/>
+          </a:bodyPr>
+          <a:lstStyle/>
+          <a:p>
+            <a:pPr algn="ctr"/>
+            <a:r>
+              <a:rPr lang="en-US" dirty="0"/>
+              <a:t>0.5</a:t>
+            </a:r>
+          </a:p>
+        </p:txBody>
+      </p:sp>
+      <p:sp>
+        <p:nvSpPr>
+          <p:cNvPr id="15" name="TextBox 14">
+            <a:extLst>
+              <a:ext uri="{FF2B5EF4-FFF2-40B4-BE49-F238E27FC236}">
+                <a16:creationId xmlns:a16="http://schemas.microsoft.com/office/drawing/2014/main" id="{C8967058-3E1F-ABAF-C159-46AEC29C58CB}"/>
+              </a:ext>
+            </a:extLst>
+          </p:cNvPr>
+          <p:cNvSpPr txBox="1"/>
+          <p:nvPr/>
+        </p:nvSpPr>
+        <p:spPr>
+          <a:xfrm>
+            <a:off x="12902015" y="20094891"/>
+            <a:ext cx="487045" cy="307777"/>
+          </a:xfrm>
+          <a:prstGeom prst="rect">
+            <a:avLst/>
+          </a:prstGeom>
+          <a:noFill/>
+        </p:spPr>
+        <p:txBody>
+          <a:bodyPr wrap="square" rtlCol="0">
+            <a:spAutoFit/>
+          </a:bodyPr>
+          <a:lstStyle/>
+          <a:p>
+            <a:pPr algn="ctr"/>
+            <a:r>
+              <a:rPr lang="en-US" dirty="0"/>
+              <a:t>-1</a:t>
+            </a:r>
+          </a:p>
+        </p:txBody>
+      </p:sp>
+      <p:sp>
+        <p:nvSpPr>
+          <p:cNvPr id="16" name="TextBox 15">
+            <a:extLst>
+              <a:ext uri="{FF2B5EF4-FFF2-40B4-BE49-F238E27FC236}">
+                <a16:creationId xmlns:a16="http://schemas.microsoft.com/office/drawing/2014/main" id="{20A7AB48-DF5B-DEB0-D120-88B6102FC19E}"/>
+              </a:ext>
+            </a:extLst>
+          </p:cNvPr>
+          <p:cNvSpPr txBox="1"/>
+          <p:nvPr/>
+        </p:nvSpPr>
+        <p:spPr>
+          <a:xfrm>
+            <a:off x="13410493" y="20094891"/>
+            <a:ext cx="529902" cy="307777"/>
+          </a:xfrm>
+          <a:prstGeom prst="rect">
+            <a:avLst/>
+          </a:prstGeom>
+          <a:noFill/>
+        </p:spPr>
+        <p:txBody>
+          <a:bodyPr wrap="square" rtlCol="0">
+            <a:spAutoFit/>
+          </a:bodyPr>
+          <a:lstStyle/>
+          <a:p>
+            <a:pPr algn="ctr"/>
+            <a:r>
+              <a:rPr lang="en-US" dirty="0"/>
+              <a:t>-0.5</a:t>
+            </a:r>
+          </a:p>
+        </p:txBody>
+      </p:sp>
+      <p:sp>
+        <p:nvSpPr>
+          <p:cNvPr id="17" name="TextBox 16">
+            <a:extLst>
+              <a:ext uri="{FF2B5EF4-FFF2-40B4-BE49-F238E27FC236}">
+                <a16:creationId xmlns:a16="http://schemas.microsoft.com/office/drawing/2014/main" id="{E6F8B38B-55B8-D6C5-5852-678254C74BF8}"/>
+              </a:ext>
+            </a:extLst>
+          </p:cNvPr>
+          <p:cNvSpPr txBox="1"/>
+          <p:nvPr/>
+        </p:nvSpPr>
+        <p:spPr>
+          <a:xfrm>
+            <a:off x="13938014" y="20094892"/>
+            <a:ext cx="529902" cy="307777"/>
+          </a:xfrm>
+          <a:prstGeom prst="rect">
+            <a:avLst/>
+          </a:prstGeom>
+          <a:noFill/>
+        </p:spPr>
+        <p:txBody>
+          <a:bodyPr wrap="square" rtlCol="0">
+            <a:spAutoFit/>
+          </a:bodyPr>
+          <a:lstStyle/>
+          <a:p>
+            <a:pPr algn="ctr"/>
+            <a:r>
+              <a:rPr lang="en-US" dirty="0"/>
+              <a:t>0</a:t>
+            </a:r>
+          </a:p>
+        </p:txBody>
+      </p:sp>
+      <p:sp>
+        <p:nvSpPr>
+          <p:cNvPr id="18" name="TextBox 17">
+            <a:extLst>
+              <a:ext uri="{FF2B5EF4-FFF2-40B4-BE49-F238E27FC236}">
+                <a16:creationId xmlns:a16="http://schemas.microsoft.com/office/drawing/2014/main" id="{2AD900F9-6F3D-64F5-BE7F-B943CF786C36}"/>
+              </a:ext>
+            </a:extLst>
+          </p:cNvPr>
+          <p:cNvSpPr txBox="1"/>
+          <p:nvPr/>
+        </p:nvSpPr>
+        <p:spPr>
+          <a:xfrm>
+            <a:off x="14463152" y="20094890"/>
+            <a:ext cx="529902" cy="307777"/>
+          </a:xfrm>
+          <a:prstGeom prst="rect">
+            <a:avLst/>
+          </a:prstGeom>
+          <a:noFill/>
+        </p:spPr>
+        <p:txBody>
+          <a:bodyPr wrap="square" rtlCol="0">
+            <a:spAutoFit/>
+          </a:bodyPr>
+          <a:lstStyle/>
+          <a:p>
+            <a:pPr algn="ctr"/>
+            <a:r>
+              <a:rPr lang="en-US" dirty="0"/>
+              <a:t>0.5</a:t>
+            </a:r>
+          </a:p>
+        </p:txBody>
+      </p:sp>
+      <p:sp>
+        <p:nvSpPr>
+          <p:cNvPr id="19" name="TextBox 18">
+            <a:extLst>
+              <a:ext uri="{FF2B5EF4-FFF2-40B4-BE49-F238E27FC236}">
+                <a16:creationId xmlns:a16="http://schemas.microsoft.com/office/drawing/2014/main" id="{55878C9E-5E8F-6D64-B55F-2824523A0FF9}"/>
+              </a:ext>
+            </a:extLst>
+          </p:cNvPr>
+          <p:cNvSpPr txBox="1"/>
+          <p:nvPr/>
+        </p:nvSpPr>
+        <p:spPr>
+          <a:xfrm>
+            <a:off x="8325225" y="16556830"/>
+            <a:ext cx="2482930" cy="276999"/>
           </a:xfrm>
           <a:prstGeom prst="rect">
             <a:avLst/>
@@ -12144,18 +12467,18 @@
           <a:p>
             <a:pPr algn="r"/>
             <a:r>
-              <a:rPr lang="en-US" dirty="0"/>
-              <a:t>DNA age</a:t>
+              <a:rPr lang="en-US" sz="1200" dirty="0"/>
+              <a:t>All repeats age x prop.</a:t>
             </a:r>
           </a:p>
         </p:txBody>
       </p:sp>
       <p:sp>
         <p:nvSpPr>
-          <p:cNvPr id="93" name="TextBox 92">
+          <p:cNvPr id="20" name="TextBox 19">
             <a:extLst>
               <a:ext uri="{FF2B5EF4-FFF2-40B4-BE49-F238E27FC236}">
-                <a16:creationId xmlns:a16="http://schemas.microsoft.com/office/drawing/2014/main" id="{E1E55848-415D-8585-6F8E-2B3F923604B6}"/>
+                <a16:creationId xmlns:a16="http://schemas.microsoft.com/office/drawing/2014/main" id="{83678DE0-23FD-D292-31A1-EDB3A5260BA7}"/>
               </a:ext>
             </a:extLst>
           </p:cNvPr>
@@ -12164,8 +12487,8 @@
         </p:nvSpPr>
         <p:spPr>
           <a:xfrm>
-            <a:off x="16706850" y="14585670"/>
-            <a:ext cx="2487803" cy="307777"/>
+            <a:off x="8325223" y="16316325"/>
+            <a:ext cx="2482930" cy="276999"/>
           </a:xfrm>
           <a:prstGeom prst="rect">
             <a:avLst/>
@@ -12180,18 +12503,18 @@
           <a:p>
             <a:pPr algn="r"/>
             <a:r>
-              <a:rPr lang="en-US" dirty="0"/>
-              <a:t>DNA age x prop.</a:t>
+              <a:rPr lang="en-US" sz="1200" dirty="0"/>
+              <a:t>SINE proportion</a:t>
             </a:r>
           </a:p>
         </p:txBody>
       </p:sp>
       <p:sp>
         <p:nvSpPr>
-          <p:cNvPr id="94" name="TextBox 93">
+          <p:cNvPr id="21" name="TextBox 20">
             <a:extLst>
               <a:ext uri="{FF2B5EF4-FFF2-40B4-BE49-F238E27FC236}">
-                <a16:creationId xmlns:a16="http://schemas.microsoft.com/office/drawing/2014/main" id="{6A65F75F-7406-19B8-60BE-FC78FD47575E}"/>
+                <a16:creationId xmlns:a16="http://schemas.microsoft.com/office/drawing/2014/main" id="{53E1127D-8BEC-4AD7-2BCA-7A899FA72B83}"/>
               </a:ext>
             </a:extLst>
           </p:cNvPr>
@@ -12200,8 +12523,8 @@
         </p:nvSpPr>
         <p:spPr>
           <a:xfrm>
-            <a:off x="16708628" y="14791991"/>
-            <a:ext cx="2487803" cy="307777"/>
+            <a:off x="8325223" y="16077603"/>
+            <a:ext cx="2482930" cy="276999"/>
           </a:xfrm>
           <a:prstGeom prst="rect">
             <a:avLst/>
@@ -12216,18 +12539,18 @@
           <a:p>
             <a:pPr algn="r"/>
             <a:r>
-              <a:rPr lang="en-US" dirty="0"/>
-              <a:t>LINE age</a:t>
+              <a:rPr lang="en-US" sz="1200" dirty="0"/>
+              <a:t>LINE proportion</a:t>
             </a:r>
           </a:p>
         </p:txBody>
       </p:sp>
       <p:sp>
         <p:nvSpPr>
-          <p:cNvPr id="95" name="TextBox 94">
+          <p:cNvPr id="22" name="TextBox 21">
             <a:extLst>
               <a:ext uri="{FF2B5EF4-FFF2-40B4-BE49-F238E27FC236}">
-                <a16:creationId xmlns:a16="http://schemas.microsoft.com/office/drawing/2014/main" id="{6B70A642-5089-5511-DCC3-9BE2A5A9134D}"/>
+                <a16:creationId xmlns:a16="http://schemas.microsoft.com/office/drawing/2014/main" id="{CB1A28DF-50A9-DAB4-D43A-627F15397A76}"/>
               </a:ext>
             </a:extLst>
           </p:cNvPr>
@@ -12236,8 +12559,8 @@
         </p:nvSpPr>
         <p:spPr>
           <a:xfrm>
-            <a:off x="16706849" y="15002375"/>
-            <a:ext cx="2487803" cy="307777"/>
+            <a:off x="8325222" y="18758501"/>
+            <a:ext cx="2482930" cy="276999"/>
           </a:xfrm>
           <a:prstGeom prst="rect">
             <a:avLst/>
@@ -12252,18 +12575,18 @@
           <a:p>
             <a:pPr algn="r"/>
             <a:r>
-              <a:rPr lang="en-US" dirty="0"/>
-              <a:t>LTR age x prop.</a:t>
+              <a:rPr lang="en-US" sz="1200" dirty="0"/>
+              <a:t>Others proportion</a:t>
             </a:r>
           </a:p>
         </p:txBody>
       </p:sp>
       <p:sp>
         <p:nvSpPr>
-          <p:cNvPr id="96" name="TextBox 95">
+          <p:cNvPr id="23" name="TextBox 22">
             <a:extLst>
               <a:ext uri="{FF2B5EF4-FFF2-40B4-BE49-F238E27FC236}">
-                <a16:creationId xmlns:a16="http://schemas.microsoft.com/office/drawing/2014/main" id="{72373E00-0E2C-133A-462B-24CDA1F731A7}"/>
+                <a16:creationId xmlns:a16="http://schemas.microsoft.com/office/drawing/2014/main" id="{6530CD26-031C-A478-1796-8D8BB433750D}"/>
               </a:ext>
             </a:extLst>
           </p:cNvPr>
@@ -12272,8 +12595,8 @@
         </p:nvSpPr>
         <p:spPr>
           <a:xfrm>
-            <a:off x="16706849" y="15215730"/>
-            <a:ext cx="2487803" cy="307777"/>
+            <a:off x="8325222" y="15835045"/>
+            <a:ext cx="2482930" cy="276999"/>
           </a:xfrm>
           <a:prstGeom prst="rect">
             <a:avLst/>
@@ -12288,18 +12611,18 @@
           <a:p>
             <a:pPr algn="r"/>
             <a:r>
-              <a:rPr lang="en-US" dirty="0"/>
-              <a:t>Others age</a:t>
+              <a:rPr lang="en-US" sz="1200" dirty="0"/>
+              <a:t>DNA proportion</a:t>
             </a:r>
           </a:p>
         </p:txBody>
       </p:sp>
       <p:sp>
         <p:nvSpPr>
-          <p:cNvPr id="97" name="TextBox 96">
+          <p:cNvPr id="29" name="TextBox 28">
             <a:extLst>
               <a:ext uri="{FF2B5EF4-FFF2-40B4-BE49-F238E27FC236}">
-                <a16:creationId xmlns:a16="http://schemas.microsoft.com/office/drawing/2014/main" id="{BA4D181F-90F0-5E61-CAAD-BED1FC829F8E}"/>
+                <a16:creationId xmlns:a16="http://schemas.microsoft.com/office/drawing/2014/main" id="{B2F0E318-95F9-CA00-508F-6F616B0C3E5D}"/>
               </a:ext>
             </a:extLst>
           </p:cNvPr>
@@ -12308,8 +12631,512 @@
         </p:nvSpPr>
         <p:spPr>
           <a:xfrm>
-            <a:off x="16706848" y="15422236"/>
-            <a:ext cx="2487803" cy="307777"/>
+            <a:off x="10838183" y="17052130"/>
+            <a:ext cx="487045" cy="276999"/>
+          </a:xfrm>
+          <a:prstGeom prst="rect">
+            <a:avLst/>
+          </a:prstGeom>
+          <a:noFill/>
+        </p:spPr>
+        <p:txBody>
+          <a:bodyPr wrap="square" rtlCol="0">
+            <a:spAutoFit/>
+          </a:bodyPr>
+          <a:lstStyle/>
+          <a:p>
+            <a:pPr algn="ctr"/>
+            <a:r>
+              <a:rPr lang="en-US" sz="1200" dirty="0"/>
+              <a:t>-3</a:t>
+            </a:r>
+          </a:p>
+        </p:txBody>
+      </p:sp>
+      <p:sp>
+        <p:nvSpPr>
+          <p:cNvPr id="31" name="TextBox 30">
+            <a:extLst>
+              <a:ext uri="{FF2B5EF4-FFF2-40B4-BE49-F238E27FC236}">
+                <a16:creationId xmlns:a16="http://schemas.microsoft.com/office/drawing/2014/main" id="{8F9AD76D-AEF7-18F9-3A4C-5793C4301205}"/>
+              </a:ext>
+            </a:extLst>
+          </p:cNvPr>
+          <p:cNvSpPr txBox="1"/>
+          <p:nvPr/>
+        </p:nvSpPr>
+        <p:spPr>
+          <a:xfrm>
+            <a:off x="11086471" y="17051400"/>
+            <a:ext cx="487045" cy="276999"/>
+          </a:xfrm>
+          <a:prstGeom prst="rect">
+            <a:avLst/>
+          </a:prstGeom>
+          <a:noFill/>
+        </p:spPr>
+        <p:txBody>
+          <a:bodyPr wrap="square" rtlCol="0">
+            <a:spAutoFit/>
+          </a:bodyPr>
+          <a:lstStyle/>
+          <a:p>
+            <a:pPr algn="ctr"/>
+            <a:r>
+              <a:rPr lang="en-US" sz="1200" dirty="0"/>
+              <a:t>-2</a:t>
+            </a:r>
+          </a:p>
+        </p:txBody>
+      </p:sp>
+      <p:sp>
+        <p:nvSpPr>
+          <p:cNvPr id="32" name="TextBox 31">
+            <a:extLst>
+              <a:ext uri="{FF2B5EF4-FFF2-40B4-BE49-F238E27FC236}">
+                <a16:creationId xmlns:a16="http://schemas.microsoft.com/office/drawing/2014/main" id="{7F4760C6-605B-B996-3C9C-96837958D1AF}"/>
+              </a:ext>
+            </a:extLst>
+          </p:cNvPr>
+          <p:cNvSpPr txBox="1"/>
+          <p:nvPr/>
+        </p:nvSpPr>
+        <p:spPr>
+          <a:xfrm>
+            <a:off x="11334915" y="17052133"/>
+            <a:ext cx="487045" cy="276999"/>
+          </a:xfrm>
+          <a:prstGeom prst="rect">
+            <a:avLst/>
+          </a:prstGeom>
+          <a:noFill/>
+        </p:spPr>
+        <p:txBody>
+          <a:bodyPr wrap="square" rtlCol="0">
+            <a:spAutoFit/>
+          </a:bodyPr>
+          <a:lstStyle/>
+          <a:p>
+            <a:pPr algn="ctr"/>
+            <a:r>
+              <a:rPr lang="en-US" sz="1200" dirty="0"/>
+              <a:t>-1</a:t>
+            </a:r>
+          </a:p>
+        </p:txBody>
+      </p:sp>
+      <p:sp>
+        <p:nvSpPr>
+          <p:cNvPr id="33" name="TextBox 32">
+            <a:extLst>
+              <a:ext uri="{FF2B5EF4-FFF2-40B4-BE49-F238E27FC236}">
+                <a16:creationId xmlns:a16="http://schemas.microsoft.com/office/drawing/2014/main" id="{9F88F754-D880-0E84-4CE4-86C0BB307E23}"/>
+              </a:ext>
+            </a:extLst>
+          </p:cNvPr>
+          <p:cNvSpPr txBox="1"/>
+          <p:nvPr/>
+        </p:nvSpPr>
+        <p:spPr>
+          <a:xfrm>
+            <a:off x="11583040" y="17052131"/>
+            <a:ext cx="487045" cy="276999"/>
+          </a:xfrm>
+          <a:prstGeom prst="rect">
+            <a:avLst/>
+          </a:prstGeom>
+          <a:noFill/>
+        </p:spPr>
+        <p:txBody>
+          <a:bodyPr wrap="square" rtlCol="0">
+            <a:spAutoFit/>
+          </a:bodyPr>
+          <a:lstStyle/>
+          <a:p>
+            <a:pPr algn="ctr"/>
+            <a:r>
+              <a:rPr lang="en-US" sz="1200" dirty="0"/>
+              <a:t>0</a:t>
+            </a:r>
+          </a:p>
+        </p:txBody>
+      </p:sp>
+      <p:sp>
+        <p:nvSpPr>
+          <p:cNvPr id="34" name="TextBox 33">
+            <a:extLst>
+              <a:ext uri="{FF2B5EF4-FFF2-40B4-BE49-F238E27FC236}">
+                <a16:creationId xmlns:a16="http://schemas.microsoft.com/office/drawing/2014/main" id="{1B3AC1ED-3307-5480-7A52-88B5AC9D3158}"/>
+              </a:ext>
+            </a:extLst>
+          </p:cNvPr>
+          <p:cNvSpPr txBox="1"/>
+          <p:nvPr/>
+        </p:nvSpPr>
+        <p:spPr>
+          <a:xfrm>
+            <a:off x="11833705" y="17051399"/>
+            <a:ext cx="487045" cy="276999"/>
+          </a:xfrm>
+          <a:prstGeom prst="rect">
+            <a:avLst/>
+          </a:prstGeom>
+          <a:noFill/>
+        </p:spPr>
+        <p:txBody>
+          <a:bodyPr wrap="square" rtlCol="0">
+            <a:spAutoFit/>
+          </a:bodyPr>
+          <a:lstStyle/>
+          <a:p>
+            <a:pPr algn="ctr"/>
+            <a:r>
+              <a:rPr lang="en-US" sz="1200" dirty="0"/>
+              <a:t>1</a:t>
+            </a:r>
+          </a:p>
+        </p:txBody>
+      </p:sp>
+      <p:sp>
+        <p:nvSpPr>
+          <p:cNvPr id="35" name="TextBox 34">
+            <a:extLst>
+              <a:ext uri="{FF2B5EF4-FFF2-40B4-BE49-F238E27FC236}">
+                <a16:creationId xmlns:a16="http://schemas.microsoft.com/office/drawing/2014/main" id="{6C1C4B28-969B-42D2-CFAF-0A4EAE70CB5E}"/>
+              </a:ext>
+            </a:extLst>
+          </p:cNvPr>
+          <p:cNvSpPr txBox="1"/>
+          <p:nvPr/>
+        </p:nvSpPr>
+        <p:spPr>
+          <a:xfrm>
+            <a:off x="12079608" y="17052133"/>
+            <a:ext cx="487045" cy="276999"/>
+          </a:xfrm>
+          <a:prstGeom prst="rect">
+            <a:avLst/>
+          </a:prstGeom>
+          <a:noFill/>
+        </p:spPr>
+        <p:txBody>
+          <a:bodyPr wrap="square" rtlCol="0">
+            <a:spAutoFit/>
+          </a:bodyPr>
+          <a:lstStyle/>
+          <a:p>
+            <a:pPr algn="ctr"/>
+            <a:r>
+              <a:rPr lang="en-US" sz="1200" dirty="0"/>
+              <a:t>2</a:t>
+            </a:r>
+          </a:p>
+        </p:txBody>
+      </p:sp>
+      <p:sp>
+        <p:nvSpPr>
+          <p:cNvPr id="36" name="TextBox 35">
+            <a:extLst>
+              <a:ext uri="{FF2B5EF4-FFF2-40B4-BE49-F238E27FC236}">
+                <a16:creationId xmlns:a16="http://schemas.microsoft.com/office/drawing/2014/main" id="{BC7EC771-826A-9EAD-7957-A283ECA80DC7}"/>
+              </a:ext>
+            </a:extLst>
+          </p:cNvPr>
+          <p:cNvSpPr txBox="1"/>
+          <p:nvPr/>
+        </p:nvSpPr>
+        <p:spPr>
+          <a:xfrm>
+            <a:off x="12331069" y="17053232"/>
+            <a:ext cx="487045" cy="276999"/>
+          </a:xfrm>
+          <a:prstGeom prst="rect">
+            <a:avLst/>
+          </a:prstGeom>
+          <a:noFill/>
+        </p:spPr>
+        <p:txBody>
+          <a:bodyPr wrap="square" rtlCol="0">
+            <a:spAutoFit/>
+          </a:bodyPr>
+          <a:lstStyle/>
+          <a:p>
+            <a:pPr algn="ctr"/>
+            <a:r>
+              <a:rPr lang="en-US" sz="1200" dirty="0"/>
+              <a:t>3</a:t>
+            </a:r>
+          </a:p>
+        </p:txBody>
+      </p:sp>
+      <p:sp>
+        <p:nvSpPr>
+          <p:cNvPr id="37" name="TextBox 36">
+            <a:extLst>
+              <a:ext uri="{FF2B5EF4-FFF2-40B4-BE49-F238E27FC236}">
+                <a16:creationId xmlns:a16="http://schemas.microsoft.com/office/drawing/2014/main" id="{DF6EFD1C-5190-C41C-1403-A876221CC7AE}"/>
+              </a:ext>
+            </a:extLst>
+          </p:cNvPr>
+          <p:cNvSpPr txBox="1"/>
+          <p:nvPr/>
+        </p:nvSpPr>
+        <p:spPr>
+          <a:xfrm>
+            <a:off x="12888598" y="17051398"/>
+            <a:ext cx="487045" cy="276999"/>
+          </a:xfrm>
+          <a:prstGeom prst="rect">
+            <a:avLst/>
+          </a:prstGeom>
+          <a:noFill/>
+        </p:spPr>
+        <p:txBody>
+          <a:bodyPr wrap="square" rtlCol="0">
+            <a:spAutoFit/>
+          </a:bodyPr>
+          <a:lstStyle/>
+          <a:p>
+            <a:pPr algn="ctr"/>
+            <a:r>
+              <a:rPr lang="en-US" sz="1200" dirty="0"/>
+              <a:t>-3</a:t>
+            </a:r>
+          </a:p>
+        </p:txBody>
+      </p:sp>
+      <p:sp>
+        <p:nvSpPr>
+          <p:cNvPr id="38" name="TextBox 37">
+            <a:extLst>
+              <a:ext uri="{FF2B5EF4-FFF2-40B4-BE49-F238E27FC236}">
+                <a16:creationId xmlns:a16="http://schemas.microsoft.com/office/drawing/2014/main" id="{5F59CBD6-07CB-24EE-BBE0-D100DCA8EC6E}"/>
+              </a:ext>
+            </a:extLst>
+          </p:cNvPr>
+          <p:cNvSpPr txBox="1"/>
+          <p:nvPr/>
+        </p:nvSpPr>
+        <p:spPr>
+          <a:xfrm>
+            <a:off x="13132124" y="17050668"/>
+            <a:ext cx="487045" cy="276999"/>
+          </a:xfrm>
+          <a:prstGeom prst="rect">
+            <a:avLst/>
+          </a:prstGeom>
+          <a:noFill/>
+        </p:spPr>
+        <p:txBody>
+          <a:bodyPr wrap="square" rtlCol="0">
+            <a:spAutoFit/>
+          </a:bodyPr>
+          <a:lstStyle/>
+          <a:p>
+            <a:pPr algn="ctr"/>
+            <a:r>
+              <a:rPr lang="en-US" sz="1200" dirty="0"/>
+              <a:t>-2</a:t>
+            </a:r>
+          </a:p>
+        </p:txBody>
+      </p:sp>
+      <p:sp>
+        <p:nvSpPr>
+          <p:cNvPr id="39" name="TextBox 38">
+            <a:extLst>
+              <a:ext uri="{FF2B5EF4-FFF2-40B4-BE49-F238E27FC236}">
+                <a16:creationId xmlns:a16="http://schemas.microsoft.com/office/drawing/2014/main" id="{9F0EAD95-2022-6B09-A622-3A58A596D822}"/>
+              </a:ext>
+            </a:extLst>
+          </p:cNvPr>
+          <p:cNvSpPr txBox="1"/>
+          <p:nvPr/>
+        </p:nvSpPr>
+        <p:spPr>
+          <a:xfrm>
+            <a:off x="13378187" y="17051401"/>
+            <a:ext cx="487045" cy="276999"/>
+          </a:xfrm>
+          <a:prstGeom prst="rect">
+            <a:avLst/>
+          </a:prstGeom>
+          <a:noFill/>
+        </p:spPr>
+        <p:txBody>
+          <a:bodyPr wrap="square" rtlCol="0">
+            <a:spAutoFit/>
+          </a:bodyPr>
+          <a:lstStyle/>
+          <a:p>
+            <a:pPr algn="ctr"/>
+            <a:r>
+              <a:rPr lang="en-US" sz="1200" dirty="0"/>
+              <a:t>-1</a:t>
+            </a:r>
+          </a:p>
+        </p:txBody>
+      </p:sp>
+      <p:sp>
+        <p:nvSpPr>
+          <p:cNvPr id="40" name="TextBox 39">
+            <a:extLst>
+              <a:ext uri="{FF2B5EF4-FFF2-40B4-BE49-F238E27FC236}">
+                <a16:creationId xmlns:a16="http://schemas.microsoft.com/office/drawing/2014/main" id="{51EEF0E3-77B3-9ABE-C4A6-2DD978217FEF}"/>
+              </a:ext>
+            </a:extLst>
+          </p:cNvPr>
+          <p:cNvSpPr txBox="1"/>
+          <p:nvPr/>
+        </p:nvSpPr>
+        <p:spPr>
+          <a:xfrm>
+            <a:off x="13621550" y="17051399"/>
+            <a:ext cx="487045" cy="276999"/>
+          </a:xfrm>
+          <a:prstGeom prst="rect">
+            <a:avLst/>
+          </a:prstGeom>
+          <a:noFill/>
+        </p:spPr>
+        <p:txBody>
+          <a:bodyPr wrap="square" rtlCol="0">
+            <a:spAutoFit/>
+          </a:bodyPr>
+          <a:lstStyle/>
+          <a:p>
+            <a:pPr algn="ctr"/>
+            <a:r>
+              <a:rPr lang="en-US" sz="1200" dirty="0"/>
+              <a:t>0</a:t>
+            </a:r>
+          </a:p>
+        </p:txBody>
+      </p:sp>
+      <p:sp>
+        <p:nvSpPr>
+          <p:cNvPr id="41" name="TextBox 40">
+            <a:extLst>
+              <a:ext uri="{FF2B5EF4-FFF2-40B4-BE49-F238E27FC236}">
+                <a16:creationId xmlns:a16="http://schemas.microsoft.com/office/drawing/2014/main" id="{ED2E5F74-2960-D796-B0D5-C2E9830DFC81}"/>
+              </a:ext>
+            </a:extLst>
+          </p:cNvPr>
+          <p:cNvSpPr txBox="1"/>
+          <p:nvPr/>
+        </p:nvSpPr>
+        <p:spPr>
+          <a:xfrm>
+            <a:off x="13869834" y="17050667"/>
+            <a:ext cx="487045" cy="276999"/>
+          </a:xfrm>
+          <a:prstGeom prst="rect">
+            <a:avLst/>
+          </a:prstGeom>
+          <a:noFill/>
+        </p:spPr>
+        <p:txBody>
+          <a:bodyPr wrap="square" rtlCol="0">
+            <a:spAutoFit/>
+          </a:bodyPr>
+          <a:lstStyle/>
+          <a:p>
+            <a:pPr algn="ctr"/>
+            <a:r>
+              <a:rPr lang="en-US" sz="1200" dirty="0"/>
+              <a:t>1</a:t>
+            </a:r>
+          </a:p>
+        </p:txBody>
+      </p:sp>
+      <p:sp>
+        <p:nvSpPr>
+          <p:cNvPr id="42" name="TextBox 41">
+            <a:extLst>
+              <a:ext uri="{FF2B5EF4-FFF2-40B4-BE49-F238E27FC236}">
+                <a16:creationId xmlns:a16="http://schemas.microsoft.com/office/drawing/2014/main" id="{4784BC33-9765-AA29-B6C0-0DCCC15B30FC}"/>
+              </a:ext>
+            </a:extLst>
+          </p:cNvPr>
+          <p:cNvSpPr txBox="1"/>
+          <p:nvPr/>
+        </p:nvSpPr>
+        <p:spPr>
+          <a:xfrm>
+            <a:off x="14110973" y="17051401"/>
+            <a:ext cx="487045" cy="276999"/>
+          </a:xfrm>
+          <a:prstGeom prst="rect">
+            <a:avLst/>
+          </a:prstGeom>
+          <a:noFill/>
+        </p:spPr>
+        <p:txBody>
+          <a:bodyPr wrap="square" rtlCol="0">
+            <a:spAutoFit/>
+          </a:bodyPr>
+          <a:lstStyle/>
+          <a:p>
+            <a:pPr algn="ctr"/>
+            <a:r>
+              <a:rPr lang="en-US" sz="1200" dirty="0"/>
+              <a:t>2</a:t>
+            </a:r>
+          </a:p>
+        </p:txBody>
+      </p:sp>
+      <p:sp>
+        <p:nvSpPr>
+          <p:cNvPr id="43" name="TextBox 42">
+            <a:extLst>
+              <a:ext uri="{FF2B5EF4-FFF2-40B4-BE49-F238E27FC236}">
+                <a16:creationId xmlns:a16="http://schemas.microsoft.com/office/drawing/2014/main" id="{60ADDB80-FD43-DDA1-D4B1-998C7FB9B0A2}"/>
+              </a:ext>
+            </a:extLst>
+          </p:cNvPr>
+          <p:cNvSpPr txBox="1"/>
+          <p:nvPr/>
+        </p:nvSpPr>
+        <p:spPr>
+          <a:xfrm>
+            <a:off x="14357672" y="17052500"/>
+            <a:ext cx="487045" cy="276999"/>
+          </a:xfrm>
+          <a:prstGeom prst="rect">
+            <a:avLst/>
+          </a:prstGeom>
+          <a:noFill/>
+        </p:spPr>
+        <p:txBody>
+          <a:bodyPr wrap="square" rtlCol="0">
+            <a:spAutoFit/>
+          </a:bodyPr>
+          <a:lstStyle/>
+          <a:p>
+            <a:pPr algn="ctr"/>
+            <a:r>
+              <a:rPr lang="en-US" sz="1200" dirty="0"/>
+              <a:t>3</a:t>
+            </a:r>
+          </a:p>
+        </p:txBody>
+      </p:sp>
+      <p:sp>
+        <p:nvSpPr>
+          <p:cNvPr id="44" name="TextBox 43">
+            <a:extLst>
+              <a:ext uri="{FF2B5EF4-FFF2-40B4-BE49-F238E27FC236}">
+                <a16:creationId xmlns:a16="http://schemas.microsoft.com/office/drawing/2014/main" id="{82DBB987-F924-67EF-FAEB-D3748F3EA5F7}"/>
+              </a:ext>
+            </a:extLst>
+          </p:cNvPr>
+          <p:cNvSpPr txBox="1"/>
+          <p:nvPr/>
+        </p:nvSpPr>
+        <p:spPr>
+          <a:xfrm>
+            <a:off x="8325221" y="15594534"/>
+            <a:ext cx="2482930" cy="276999"/>
           </a:xfrm>
           <a:prstGeom prst="rect">
             <a:avLst/>
@@ -12324,18 +13151,18 @@
           <a:p>
             <a:pPr algn="r"/>
             <a:r>
-              <a:rPr lang="en-US" dirty="0"/>
-              <a:t>Others age x prop.</a:t>
+              <a:rPr lang="en-US" sz="1200" dirty="0"/>
+              <a:t>All repeats age</a:t>
             </a:r>
           </a:p>
         </p:txBody>
       </p:sp>
       <p:sp>
         <p:nvSpPr>
-          <p:cNvPr id="98" name="TextBox 97">
+          <p:cNvPr id="45" name="TextBox 44">
             <a:extLst>
               <a:ext uri="{FF2B5EF4-FFF2-40B4-BE49-F238E27FC236}">
-                <a16:creationId xmlns:a16="http://schemas.microsoft.com/office/drawing/2014/main" id="{00B877AF-38AD-9DBC-2C45-7629250CBBEA}"/>
+                <a16:creationId xmlns:a16="http://schemas.microsoft.com/office/drawing/2014/main" id="{EE5FD4FA-08A4-D8EE-61A9-6AC4EABEB648}"/>
               </a:ext>
             </a:extLst>
           </p:cNvPr>
@@ -12344,8 +13171,8 @@
         </p:nvSpPr>
         <p:spPr>
           <a:xfrm>
-            <a:off x="16706848" y="15629241"/>
-            <a:ext cx="2487803" cy="307777"/>
+            <a:off x="8325219" y="15354024"/>
+            <a:ext cx="2482930" cy="276999"/>
           </a:xfrm>
           <a:prstGeom prst="rect">
             <a:avLst/>
@@ -12360,18 +13187,18 @@
           <a:p>
             <a:pPr algn="r"/>
             <a:r>
-              <a:rPr lang="en-US" dirty="0"/>
-              <a:t>SINE age</a:t>
+              <a:rPr lang="en-US" sz="1200" dirty="0"/>
+              <a:t>SINE age x prop.</a:t>
             </a:r>
           </a:p>
         </p:txBody>
       </p:sp>
       <p:sp>
         <p:nvSpPr>
-          <p:cNvPr id="99" name="TextBox 98">
+          <p:cNvPr id="47" name="TextBox 46">
             <a:extLst>
               <a:ext uri="{FF2B5EF4-FFF2-40B4-BE49-F238E27FC236}">
-                <a16:creationId xmlns:a16="http://schemas.microsoft.com/office/drawing/2014/main" id="{4668BB68-638E-1D9F-91BC-423998C045A3}"/>
+                <a16:creationId xmlns:a16="http://schemas.microsoft.com/office/drawing/2014/main" id="{F8CAD825-FA0E-037B-DD0F-44D9F3ED2945}"/>
               </a:ext>
             </a:extLst>
           </p:cNvPr>
@@ -12380,8 +13207,8 @@
         </p:nvSpPr>
         <p:spPr>
           <a:xfrm>
-            <a:off x="16706848" y="15838922"/>
-            <a:ext cx="2487803" cy="307777"/>
+            <a:off x="8325218" y="15113512"/>
+            <a:ext cx="2482930" cy="276999"/>
           </a:xfrm>
           <a:prstGeom prst="rect">
             <a:avLst/>
@@ -12396,18 +13223,18 @@
           <a:p>
             <a:pPr algn="r"/>
             <a:r>
-              <a:rPr lang="en-US" dirty="0"/>
-              <a:t>All repeats age</a:t>
+              <a:rPr lang="en-US" sz="1200" dirty="0"/>
+              <a:t>SINE age</a:t>
             </a:r>
           </a:p>
         </p:txBody>
       </p:sp>
       <p:sp>
         <p:nvSpPr>
-          <p:cNvPr id="100" name="TextBox 99">
+          <p:cNvPr id="48" name="TextBox 47">
             <a:extLst>
               <a:ext uri="{FF2B5EF4-FFF2-40B4-BE49-F238E27FC236}">
-                <a16:creationId xmlns:a16="http://schemas.microsoft.com/office/drawing/2014/main" id="{CFF3CD41-47FA-440C-7D98-635A279140AC}"/>
+                <a16:creationId xmlns:a16="http://schemas.microsoft.com/office/drawing/2014/main" id="{50618BD4-B3A0-5361-34A4-33C504CF2692}"/>
               </a:ext>
             </a:extLst>
           </p:cNvPr>
@@ -12416,8 +13243,8 @@
         </p:nvSpPr>
         <p:spPr>
           <a:xfrm>
-            <a:off x="16706848" y="16049306"/>
-            <a:ext cx="2487803" cy="307777"/>
+            <a:off x="8325215" y="14873002"/>
+            <a:ext cx="2482930" cy="276999"/>
           </a:xfrm>
           <a:prstGeom prst="rect">
             <a:avLst/>
@@ -12432,18 +13259,18 @@
           <a:p>
             <a:pPr algn="r"/>
             <a:r>
-              <a:rPr lang="en-US" dirty="0"/>
-              <a:t>Unknown age</a:t>
+              <a:rPr lang="en-US" sz="1200" dirty="0"/>
+              <a:t>LTR age x prop.</a:t>
             </a:r>
           </a:p>
         </p:txBody>
       </p:sp>
       <p:sp>
         <p:nvSpPr>
-          <p:cNvPr id="101" name="TextBox 100">
+          <p:cNvPr id="49" name="TextBox 48">
             <a:extLst>
               <a:ext uri="{FF2B5EF4-FFF2-40B4-BE49-F238E27FC236}">
-                <a16:creationId xmlns:a16="http://schemas.microsoft.com/office/drawing/2014/main" id="{EB59AF06-345B-5710-5C06-AAC5E80D94BB}"/>
+                <a16:creationId xmlns:a16="http://schemas.microsoft.com/office/drawing/2014/main" id="{47548CC9-1A78-F580-1D7E-E754DFC1029A}"/>
               </a:ext>
             </a:extLst>
           </p:cNvPr>
@@ -12452,8 +13279,8 @@
         </p:nvSpPr>
         <p:spPr>
           <a:xfrm>
-            <a:off x="16706847" y="16255233"/>
-            <a:ext cx="2487803" cy="307777"/>
+            <a:off x="14005191" y="15026342"/>
+            <a:ext cx="2482930" cy="276999"/>
           </a:xfrm>
           <a:prstGeom prst="rect">
             <a:avLst/>
@@ -12468,18 +13295,18 @@
           <a:p>
             <a:pPr algn="r"/>
             <a:r>
-              <a:rPr lang="en-US" dirty="0"/>
-              <a:t>Unknown age x prop.</a:t>
+              <a:rPr lang="en-US" sz="1200" dirty="0"/>
+              <a:t>LINE age x prop.</a:t>
             </a:r>
           </a:p>
         </p:txBody>
       </p:sp>
       <p:sp>
         <p:nvSpPr>
-          <p:cNvPr id="102" name="TextBox 101">
+          <p:cNvPr id="52" name="TextBox 51">
             <a:extLst>
               <a:ext uri="{FF2B5EF4-FFF2-40B4-BE49-F238E27FC236}">
-                <a16:creationId xmlns:a16="http://schemas.microsoft.com/office/drawing/2014/main" id="{F150C5D2-2ACD-00EF-51EF-9211CDC7D71E}"/>
+                <a16:creationId xmlns:a16="http://schemas.microsoft.com/office/drawing/2014/main" id="{3DA2468F-052F-33B6-4DA1-A545AB43024F}"/>
               </a:ext>
             </a:extLst>
           </p:cNvPr>
@@ -12488,8 +13315,8 @@
         </p:nvSpPr>
         <p:spPr>
           <a:xfrm>
-            <a:off x="16708622" y="16469765"/>
-            <a:ext cx="2487803" cy="307777"/>
+            <a:off x="14005189" y="15485925"/>
+            <a:ext cx="2482930" cy="276999"/>
           </a:xfrm>
           <a:prstGeom prst="rect">
             <a:avLst/>
@@ -12504,18 +13331,18 @@
           <a:p>
             <a:pPr algn="r"/>
             <a:r>
-              <a:rPr lang="en-US" dirty="0"/>
-              <a:t>LINE proportion</a:t>
+              <a:rPr lang="en-US" sz="1200" dirty="0"/>
+              <a:t>SINE age x prop.</a:t>
             </a:r>
           </a:p>
         </p:txBody>
       </p:sp>
       <p:sp>
         <p:nvSpPr>
-          <p:cNvPr id="103" name="TextBox 102">
+          <p:cNvPr id="53" name="TextBox 52">
             <a:extLst>
               <a:ext uri="{FF2B5EF4-FFF2-40B4-BE49-F238E27FC236}">
-                <a16:creationId xmlns:a16="http://schemas.microsoft.com/office/drawing/2014/main" id="{CD5E684C-F46B-6DCD-2F11-F6359C49EFCE}"/>
+                <a16:creationId xmlns:a16="http://schemas.microsoft.com/office/drawing/2014/main" id="{3ADECA43-A00F-4DEE-D415-0AA776115B7A}"/>
               </a:ext>
             </a:extLst>
           </p:cNvPr>
@@ -12524,8 +13351,8 @@
         </p:nvSpPr>
         <p:spPr>
           <a:xfrm>
-            <a:off x="16706846" y="16678383"/>
-            <a:ext cx="2487803" cy="307777"/>
+            <a:off x="14005188" y="15945511"/>
+            <a:ext cx="2482930" cy="276999"/>
           </a:xfrm>
           <a:prstGeom prst="rect">
             <a:avLst/>
@@ -12540,18 +13367,18 @@
           <a:p>
             <a:pPr algn="r"/>
             <a:r>
-              <a:rPr lang="en-US" dirty="0"/>
-              <a:t>LTR proportion</a:t>
+              <a:rPr lang="en-US" sz="1200" dirty="0"/>
+              <a:t>DNA proportion</a:t>
             </a:r>
           </a:p>
         </p:txBody>
       </p:sp>
       <p:sp>
         <p:nvSpPr>
-          <p:cNvPr id="104" name="TextBox 103">
+          <p:cNvPr id="54" name="TextBox 53">
             <a:extLst>
               <a:ext uri="{FF2B5EF4-FFF2-40B4-BE49-F238E27FC236}">
-                <a16:creationId xmlns:a16="http://schemas.microsoft.com/office/drawing/2014/main" id="{05D3EC8F-6E39-821E-EC84-4864C80D2187}"/>
+                <a16:creationId xmlns:a16="http://schemas.microsoft.com/office/drawing/2014/main" id="{222C249D-26BF-BABE-5592-E5BB238277EB}"/>
               </a:ext>
             </a:extLst>
           </p:cNvPr>
@@ -12560,8 +13387,8 @@
         </p:nvSpPr>
         <p:spPr>
           <a:xfrm>
-            <a:off x="16706846" y="16885388"/>
-            <a:ext cx="2487803" cy="307777"/>
+            <a:off x="14005185" y="16405095"/>
+            <a:ext cx="2482930" cy="276999"/>
           </a:xfrm>
           <a:prstGeom prst="rect">
             <a:avLst/>
@@ -12576,18 +13403,18 @@
           <a:p>
             <a:pPr algn="r"/>
             <a:r>
-              <a:rPr lang="en-US" dirty="0"/>
-              <a:t>Others proportion</a:t>
+              <a:rPr lang="en-US" sz="1200" dirty="0"/>
+              <a:t>LINE proportion</a:t>
             </a:r>
           </a:p>
         </p:txBody>
       </p:sp>
       <p:sp>
         <p:nvSpPr>
-          <p:cNvPr id="105" name="TextBox 104">
+          <p:cNvPr id="55" name="TextBox 54">
             <a:extLst>
               <a:ext uri="{FF2B5EF4-FFF2-40B4-BE49-F238E27FC236}">
-                <a16:creationId xmlns:a16="http://schemas.microsoft.com/office/drawing/2014/main" id="{E9F448CD-9517-E59E-ED0F-E7696A9CBF51}"/>
+                <a16:creationId xmlns:a16="http://schemas.microsoft.com/office/drawing/2014/main" id="{D4D4359E-F0C1-FF29-2E51-28A1086C20E3}"/>
               </a:ext>
             </a:extLst>
           </p:cNvPr>
@@ -12596,8 +13423,440 @@
         </p:nvSpPr>
         <p:spPr>
           <a:xfrm>
-            <a:off x="16706846" y="17094877"/>
-            <a:ext cx="2487803" cy="307777"/>
+            <a:off x="16383480" y="17053047"/>
+            <a:ext cx="487045" cy="276999"/>
+          </a:xfrm>
+          <a:prstGeom prst="rect">
+            <a:avLst/>
+          </a:prstGeom>
+          <a:noFill/>
+        </p:spPr>
+        <p:txBody>
+          <a:bodyPr wrap="square" rtlCol="0">
+            <a:spAutoFit/>
+          </a:bodyPr>
+          <a:lstStyle/>
+          <a:p>
+            <a:pPr algn="ctr"/>
+            <a:r>
+              <a:rPr lang="en-US" sz="1200" dirty="0"/>
+              <a:t>-1</a:t>
+            </a:r>
+          </a:p>
+        </p:txBody>
+      </p:sp>
+      <p:sp>
+        <p:nvSpPr>
+          <p:cNvPr id="56" name="TextBox 55">
+            <a:extLst>
+              <a:ext uri="{FF2B5EF4-FFF2-40B4-BE49-F238E27FC236}">
+                <a16:creationId xmlns:a16="http://schemas.microsoft.com/office/drawing/2014/main" id="{031CA754-BD25-BE7E-33DC-FE41046F03DB}"/>
+              </a:ext>
+            </a:extLst>
+          </p:cNvPr>
+          <p:cNvSpPr txBox="1"/>
+          <p:nvPr/>
+        </p:nvSpPr>
+        <p:spPr>
+          <a:xfrm>
+            <a:off x="16709714" y="17053047"/>
+            <a:ext cx="487045" cy="276999"/>
+          </a:xfrm>
+          <a:prstGeom prst="rect">
+            <a:avLst/>
+          </a:prstGeom>
+          <a:noFill/>
+        </p:spPr>
+        <p:txBody>
+          <a:bodyPr wrap="square" rtlCol="0">
+            <a:spAutoFit/>
+          </a:bodyPr>
+          <a:lstStyle/>
+          <a:p>
+            <a:pPr algn="ctr"/>
+            <a:r>
+              <a:rPr lang="en-US" sz="1200" dirty="0"/>
+              <a:t>0</a:t>
+            </a:r>
+          </a:p>
+        </p:txBody>
+      </p:sp>
+      <p:sp>
+        <p:nvSpPr>
+          <p:cNvPr id="57" name="TextBox 56">
+            <a:extLst>
+              <a:ext uri="{FF2B5EF4-FFF2-40B4-BE49-F238E27FC236}">
+                <a16:creationId xmlns:a16="http://schemas.microsoft.com/office/drawing/2014/main" id="{CBBF6DC7-E9C1-10BA-5B61-84E3700059FC}"/>
+              </a:ext>
+            </a:extLst>
+          </p:cNvPr>
+          <p:cNvSpPr txBox="1"/>
+          <p:nvPr/>
+        </p:nvSpPr>
+        <p:spPr>
+          <a:xfrm>
+            <a:off x="17033566" y="17053047"/>
+            <a:ext cx="487045" cy="276999"/>
+          </a:xfrm>
+          <a:prstGeom prst="rect">
+            <a:avLst/>
+          </a:prstGeom>
+          <a:noFill/>
+        </p:spPr>
+        <p:txBody>
+          <a:bodyPr wrap="square" rtlCol="0">
+            <a:spAutoFit/>
+          </a:bodyPr>
+          <a:lstStyle/>
+          <a:p>
+            <a:pPr algn="ctr"/>
+            <a:r>
+              <a:rPr lang="en-US" sz="1200" dirty="0"/>
+              <a:t>1</a:t>
+            </a:r>
+          </a:p>
+        </p:txBody>
+      </p:sp>
+      <p:sp>
+        <p:nvSpPr>
+          <p:cNvPr id="58" name="TextBox 57">
+            <a:extLst>
+              <a:ext uri="{FF2B5EF4-FFF2-40B4-BE49-F238E27FC236}">
+                <a16:creationId xmlns:a16="http://schemas.microsoft.com/office/drawing/2014/main" id="{6C0C3990-058F-FF18-6D28-C07EDA22A125}"/>
+              </a:ext>
+            </a:extLst>
+          </p:cNvPr>
+          <p:cNvSpPr txBox="1"/>
+          <p:nvPr/>
+        </p:nvSpPr>
+        <p:spPr>
+          <a:xfrm>
+            <a:off x="17359800" y="17053046"/>
+            <a:ext cx="487045" cy="276999"/>
+          </a:xfrm>
+          <a:prstGeom prst="rect">
+            <a:avLst/>
+          </a:prstGeom>
+          <a:noFill/>
+        </p:spPr>
+        <p:txBody>
+          <a:bodyPr wrap="square" rtlCol="0">
+            <a:spAutoFit/>
+          </a:bodyPr>
+          <a:lstStyle/>
+          <a:p>
+            <a:pPr algn="ctr"/>
+            <a:r>
+              <a:rPr lang="en-US" sz="1200" dirty="0"/>
+              <a:t>2</a:t>
+            </a:r>
+          </a:p>
+        </p:txBody>
+      </p:sp>
+      <p:sp>
+        <p:nvSpPr>
+          <p:cNvPr id="59" name="TextBox 58">
+            <a:extLst>
+              <a:ext uri="{FF2B5EF4-FFF2-40B4-BE49-F238E27FC236}">
+                <a16:creationId xmlns:a16="http://schemas.microsoft.com/office/drawing/2014/main" id="{50E97D97-D3C6-EF0F-0411-536D389C7021}"/>
+              </a:ext>
+            </a:extLst>
+          </p:cNvPr>
+          <p:cNvSpPr txBox="1"/>
+          <p:nvPr/>
+        </p:nvSpPr>
+        <p:spPr>
+          <a:xfrm>
+            <a:off x="17686033" y="17053045"/>
+            <a:ext cx="487045" cy="276999"/>
+          </a:xfrm>
+          <a:prstGeom prst="rect">
+            <a:avLst/>
+          </a:prstGeom>
+          <a:noFill/>
+        </p:spPr>
+        <p:txBody>
+          <a:bodyPr wrap="square" rtlCol="0">
+            <a:spAutoFit/>
+          </a:bodyPr>
+          <a:lstStyle/>
+          <a:p>
+            <a:pPr algn="ctr"/>
+            <a:r>
+              <a:rPr lang="en-US" sz="1200" dirty="0"/>
+              <a:t>3</a:t>
+            </a:r>
+          </a:p>
+        </p:txBody>
+      </p:sp>
+      <p:sp>
+        <p:nvSpPr>
+          <p:cNvPr id="60" name="TextBox 59">
+            <a:extLst>
+              <a:ext uri="{FF2B5EF4-FFF2-40B4-BE49-F238E27FC236}">
+                <a16:creationId xmlns:a16="http://schemas.microsoft.com/office/drawing/2014/main" id="{CAF7EEC0-794B-E4C5-44B2-2C6199E61577}"/>
+              </a:ext>
+            </a:extLst>
+          </p:cNvPr>
+          <p:cNvSpPr txBox="1"/>
+          <p:nvPr/>
+        </p:nvSpPr>
+        <p:spPr>
+          <a:xfrm>
+            <a:off x="18012268" y="17050663"/>
+            <a:ext cx="487045" cy="276999"/>
+          </a:xfrm>
+          <a:prstGeom prst="rect">
+            <a:avLst/>
+          </a:prstGeom>
+          <a:noFill/>
+        </p:spPr>
+        <p:txBody>
+          <a:bodyPr wrap="square" rtlCol="0">
+            <a:spAutoFit/>
+          </a:bodyPr>
+          <a:lstStyle/>
+          <a:p>
+            <a:pPr algn="ctr"/>
+            <a:r>
+              <a:rPr lang="en-US" sz="1200" dirty="0"/>
+              <a:t>4</a:t>
+            </a:r>
+          </a:p>
+        </p:txBody>
+      </p:sp>
+      <p:sp>
+        <p:nvSpPr>
+          <p:cNvPr id="61" name="TextBox 60">
+            <a:extLst>
+              <a:ext uri="{FF2B5EF4-FFF2-40B4-BE49-F238E27FC236}">
+                <a16:creationId xmlns:a16="http://schemas.microsoft.com/office/drawing/2014/main" id="{F4CA420A-57C7-7CFE-1268-695EFB630DA5}"/>
+              </a:ext>
+            </a:extLst>
+          </p:cNvPr>
+          <p:cNvSpPr txBox="1"/>
+          <p:nvPr/>
+        </p:nvSpPr>
+        <p:spPr>
+          <a:xfrm>
+            <a:off x="18433102" y="17051962"/>
+            <a:ext cx="487045" cy="276999"/>
+          </a:xfrm>
+          <a:prstGeom prst="rect">
+            <a:avLst/>
+          </a:prstGeom>
+          <a:noFill/>
+        </p:spPr>
+        <p:txBody>
+          <a:bodyPr wrap="square" rtlCol="0">
+            <a:spAutoFit/>
+          </a:bodyPr>
+          <a:lstStyle/>
+          <a:p>
+            <a:pPr algn="ctr"/>
+            <a:r>
+              <a:rPr lang="en-US" sz="1200" dirty="0"/>
+              <a:t>-1</a:t>
+            </a:r>
+          </a:p>
+        </p:txBody>
+      </p:sp>
+      <p:sp>
+        <p:nvSpPr>
+          <p:cNvPr id="62" name="TextBox 61">
+            <a:extLst>
+              <a:ext uri="{FF2B5EF4-FFF2-40B4-BE49-F238E27FC236}">
+                <a16:creationId xmlns:a16="http://schemas.microsoft.com/office/drawing/2014/main" id="{B57219CD-3C6A-1C5B-FE2A-2FB45AFE962F}"/>
+              </a:ext>
+            </a:extLst>
+          </p:cNvPr>
+          <p:cNvSpPr txBox="1"/>
+          <p:nvPr/>
+        </p:nvSpPr>
+        <p:spPr>
+          <a:xfrm>
+            <a:off x="18754574" y="17051962"/>
+            <a:ext cx="487045" cy="276999"/>
+          </a:xfrm>
+          <a:prstGeom prst="rect">
+            <a:avLst/>
+          </a:prstGeom>
+          <a:noFill/>
+        </p:spPr>
+        <p:txBody>
+          <a:bodyPr wrap="square" rtlCol="0">
+            <a:spAutoFit/>
+          </a:bodyPr>
+          <a:lstStyle/>
+          <a:p>
+            <a:pPr algn="ctr"/>
+            <a:r>
+              <a:rPr lang="en-US" sz="1200" dirty="0"/>
+              <a:t>0</a:t>
+            </a:r>
+          </a:p>
+        </p:txBody>
+      </p:sp>
+      <p:sp>
+        <p:nvSpPr>
+          <p:cNvPr id="63" name="TextBox 62">
+            <a:extLst>
+              <a:ext uri="{FF2B5EF4-FFF2-40B4-BE49-F238E27FC236}">
+                <a16:creationId xmlns:a16="http://schemas.microsoft.com/office/drawing/2014/main" id="{97E987C9-BA65-8A82-13BA-FB8FB04FF3AE}"/>
+              </a:ext>
+            </a:extLst>
+          </p:cNvPr>
+          <p:cNvSpPr txBox="1"/>
+          <p:nvPr/>
+        </p:nvSpPr>
+        <p:spPr>
+          <a:xfrm>
+            <a:off x="19076045" y="17051962"/>
+            <a:ext cx="487045" cy="276999"/>
+          </a:xfrm>
+          <a:prstGeom prst="rect">
+            <a:avLst/>
+          </a:prstGeom>
+          <a:noFill/>
+        </p:spPr>
+        <p:txBody>
+          <a:bodyPr wrap="square" rtlCol="0">
+            <a:spAutoFit/>
+          </a:bodyPr>
+          <a:lstStyle/>
+          <a:p>
+            <a:pPr algn="ctr"/>
+            <a:r>
+              <a:rPr lang="en-US" sz="1200" dirty="0"/>
+              <a:t>1</a:t>
+            </a:r>
+          </a:p>
+        </p:txBody>
+      </p:sp>
+      <p:sp>
+        <p:nvSpPr>
+          <p:cNvPr id="64" name="TextBox 63">
+            <a:extLst>
+              <a:ext uri="{FF2B5EF4-FFF2-40B4-BE49-F238E27FC236}">
+                <a16:creationId xmlns:a16="http://schemas.microsoft.com/office/drawing/2014/main" id="{EDBDF14A-5CBF-4E8B-C03C-0648DE940DD9}"/>
+              </a:ext>
+            </a:extLst>
+          </p:cNvPr>
+          <p:cNvSpPr txBox="1"/>
+          <p:nvPr/>
+        </p:nvSpPr>
+        <p:spPr>
+          <a:xfrm>
+            <a:off x="19395136" y="17051961"/>
+            <a:ext cx="487045" cy="276999"/>
+          </a:xfrm>
+          <a:prstGeom prst="rect">
+            <a:avLst/>
+          </a:prstGeom>
+          <a:noFill/>
+        </p:spPr>
+        <p:txBody>
+          <a:bodyPr wrap="square" rtlCol="0">
+            <a:spAutoFit/>
+          </a:bodyPr>
+          <a:lstStyle/>
+          <a:p>
+            <a:pPr algn="ctr"/>
+            <a:r>
+              <a:rPr lang="en-US" sz="1200" dirty="0"/>
+              <a:t>2</a:t>
+            </a:r>
+          </a:p>
+        </p:txBody>
+      </p:sp>
+      <p:sp>
+        <p:nvSpPr>
+          <p:cNvPr id="65" name="TextBox 64">
+            <a:extLst>
+              <a:ext uri="{FF2B5EF4-FFF2-40B4-BE49-F238E27FC236}">
+                <a16:creationId xmlns:a16="http://schemas.microsoft.com/office/drawing/2014/main" id="{B6ABF042-2FF5-1687-0B64-4BF9E025DBDA}"/>
+              </a:ext>
+            </a:extLst>
+          </p:cNvPr>
+          <p:cNvSpPr txBox="1"/>
+          <p:nvPr/>
+        </p:nvSpPr>
+        <p:spPr>
+          <a:xfrm>
+            <a:off x="19716604" y="17051960"/>
+            <a:ext cx="487045" cy="276999"/>
+          </a:xfrm>
+          <a:prstGeom prst="rect">
+            <a:avLst/>
+          </a:prstGeom>
+          <a:noFill/>
+        </p:spPr>
+        <p:txBody>
+          <a:bodyPr wrap="square" rtlCol="0">
+            <a:spAutoFit/>
+          </a:bodyPr>
+          <a:lstStyle/>
+          <a:p>
+            <a:pPr algn="ctr"/>
+            <a:r>
+              <a:rPr lang="en-US" sz="1200" dirty="0"/>
+              <a:t>3</a:t>
+            </a:r>
+          </a:p>
+        </p:txBody>
+      </p:sp>
+      <p:sp>
+        <p:nvSpPr>
+          <p:cNvPr id="66" name="TextBox 65">
+            <a:extLst>
+              <a:ext uri="{FF2B5EF4-FFF2-40B4-BE49-F238E27FC236}">
+                <a16:creationId xmlns:a16="http://schemas.microsoft.com/office/drawing/2014/main" id="{3457BBF8-1CB8-3643-4AF3-AA88E368D4A0}"/>
+              </a:ext>
+            </a:extLst>
+          </p:cNvPr>
+          <p:cNvSpPr txBox="1"/>
+          <p:nvPr/>
+        </p:nvSpPr>
+        <p:spPr>
+          <a:xfrm>
+            <a:off x="20035697" y="17049578"/>
+            <a:ext cx="487045" cy="276999"/>
+          </a:xfrm>
+          <a:prstGeom prst="rect">
+            <a:avLst/>
+          </a:prstGeom>
+          <a:noFill/>
+        </p:spPr>
+        <p:txBody>
+          <a:bodyPr wrap="square" rtlCol="0">
+            <a:spAutoFit/>
+          </a:bodyPr>
+          <a:lstStyle/>
+          <a:p>
+            <a:pPr algn="ctr"/>
+            <a:r>
+              <a:rPr lang="en-US" sz="1200" dirty="0"/>
+              <a:t>4</a:t>
+            </a:r>
+          </a:p>
+        </p:txBody>
+      </p:sp>
+      <p:sp>
+        <p:nvSpPr>
+          <p:cNvPr id="69" name="TextBox 68">
+            <a:extLst>
+              <a:ext uri="{FF2B5EF4-FFF2-40B4-BE49-F238E27FC236}">
+                <a16:creationId xmlns:a16="http://schemas.microsoft.com/office/drawing/2014/main" id="{855DC7E3-924B-A2B4-7879-6D957742F466}"/>
+              </a:ext>
+            </a:extLst>
+          </p:cNvPr>
+          <p:cNvSpPr txBox="1"/>
+          <p:nvPr/>
+        </p:nvSpPr>
+        <p:spPr>
+          <a:xfrm>
+            <a:off x="14003887" y="17936624"/>
+            <a:ext cx="2482930" cy="276999"/>
           </a:xfrm>
           <a:prstGeom prst="rect">
             <a:avLst/>
@@ -12612,18 +13871,18 @@
           <a:p>
             <a:pPr algn="r"/>
             <a:r>
-              <a:rPr lang="en-US" dirty="0"/>
-              <a:t>SINE proportion</a:t>
+              <a:rPr lang="en-US" sz="1200" dirty="0"/>
+              <a:t>LTR age</a:t>
             </a:r>
           </a:p>
         </p:txBody>
       </p:sp>
       <p:sp>
         <p:nvSpPr>
-          <p:cNvPr id="106" name="TextBox 105">
+          <p:cNvPr id="70" name="TextBox 69">
             <a:extLst>
               <a:ext uri="{FF2B5EF4-FFF2-40B4-BE49-F238E27FC236}">
-                <a16:creationId xmlns:a16="http://schemas.microsoft.com/office/drawing/2014/main" id="{1819C32A-9F00-D7B1-7BF9-6C1A50DDF6D6}"/>
+                <a16:creationId xmlns:a16="http://schemas.microsoft.com/office/drawing/2014/main" id="{04D600C2-3216-B1C7-805F-AE9DBF047042}"/>
               </a:ext>
             </a:extLst>
           </p:cNvPr>
@@ -12632,8 +13891,8 @@
         </p:nvSpPr>
         <p:spPr>
           <a:xfrm>
-            <a:off x="16706845" y="17305408"/>
-            <a:ext cx="2487803" cy="307777"/>
+            <a:off x="14003886" y="18210468"/>
+            <a:ext cx="2482930" cy="276999"/>
           </a:xfrm>
           <a:prstGeom prst="rect">
             <a:avLst/>
@@ -12648,18 +13907,18 @@
           <a:p>
             <a:pPr algn="r"/>
             <a:r>
-              <a:rPr lang="en-US" dirty="0"/>
-              <a:t>Unknown proportion</a:t>
+              <a:rPr lang="en-US" sz="1200" dirty="0"/>
+              <a:t>SINE age</a:t>
             </a:r>
           </a:p>
         </p:txBody>
       </p:sp>
       <p:sp>
         <p:nvSpPr>
-          <p:cNvPr id="108" name="TextBox 107">
+          <p:cNvPr id="71" name="TextBox 70">
             <a:extLst>
               <a:ext uri="{FF2B5EF4-FFF2-40B4-BE49-F238E27FC236}">
-                <a16:creationId xmlns:a16="http://schemas.microsoft.com/office/drawing/2014/main" id="{38898794-FEC8-FD34-28F4-8093F0869D21}"/>
+                <a16:creationId xmlns:a16="http://schemas.microsoft.com/office/drawing/2014/main" id="{5A00AA73-DE1B-0771-EC87-C3B16FA7158F}"/>
               </a:ext>
             </a:extLst>
           </p:cNvPr>
@@ -12668,8 +13927,8 @@
         </p:nvSpPr>
         <p:spPr>
           <a:xfrm>
-            <a:off x="16705067" y="11875543"/>
-            <a:ext cx="2487803" cy="369332"/>
+            <a:off x="14003884" y="18484311"/>
+            <a:ext cx="2482930" cy="276999"/>
           </a:xfrm>
           <a:prstGeom prst="rect">
             <a:avLst/>
@@ -12684,18 +13943,18 @@
           <a:p>
             <a:pPr algn="r"/>
             <a:r>
-              <a:rPr lang="en-US" sz="1800" dirty="0"/>
-              <a:t>LINE proportion</a:t>
+              <a:rPr lang="en-US" sz="1200" dirty="0"/>
+              <a:t>All repeats age</a:t>
             </a:r>
           </a:p>
         </p:txBody>
       </p:sp>
       <p:sp>
         <p:nvSpPr>
-          <p:cNvPr id="109" name="TextBox 108">
+          <p:cNvPr id="72" name="TextBox 71">
             <a:extLst>
               <a:ext uri="{FF2B5EF4-FFF2-40B4-BE49-F238E27FC236}">
-                <a16:creationId xmlns:a16="http://schemas.microsoft.com/office/drawing/2014/main" id="{C90CFF59-4196-EC7A-5570-F91559CE3A8E}"/>
+                <a16:creationId xmlns:a16="http://schemas.microsoft.com/office/drawing/2014/main" id="{E4B139EE-7752-248A-1BC0-0FE087EB4BE9}"/>
               </a:ext>
             </a:extLst>
           </p:cNvPr>
@@ -12704,8 +13963,8 @@
         </p:nvSpPr>
         <p:spPr>
           <a:xfrm>
-            <a:off x="16705067" y="11143804"/>
-            <a:ext cx="2487803" cy="369332"/>
+            <a:off x="14003880" y="18758156"/>
+            <a:ext cx="2482930" cy="276999"/>
           </a:xfrm>
           <a:prstGeom prst="rect">
             <a:avLst/>
@@ -12720,18 +13979,18 @@
           <a:p>
             <a:pPr algn="r"/>
             <a:r>
-              <a:rPr lang="en-US" sz="1800" dirty="0"/>
-              <a:t>DNA proportion</a:t>
+              <a:rPr lang="en-US" sz="1200" dirty="0"/>
+              <a:t>Unknown age</a:t>
             </a:r>
           </a:p>
         </p:txBody>
       </p:sp>
       <p:sp>
         <p:nvSpPr>
-          <p:cNvPr id="110" name="TextBox 109">
+          <p:cNvPr id="73" name="TextBox 72">
             <a:extLst>
               <a:ext uri="{FF2B5EF4-FFF2-40B4-BE49-F238E27FC236}">
-                <a16:creationId xmlns:a16="http://schemas.microsoft.com/office/drawing/2014/main" id="{B544D9A0-56E5-D542-FF0C-3852BBAD7190}"/>
+                <a16:creationId xmlns:a16="http://schemas.microsoft.com/office/drawing/2014/main" id="{DC01B55F-8D4D-5F0F-EC60-B8E1CD2EEB3A}"/>
               </a:ext>
             </a:extLst>
           </p:cNvPr>
@@ -12740,8 +13999,8 @@
         </p:nvSpPr>
         <p:spPr>
           <a:xfrm>
-            <a:off x="16705067" y="10415216"/>
-            <a:ext cx="2487803" cy="369332"/>
+            <a:off x="14003876" y="19029620"/>
+            <a:ext cx="2482930" cy="276999"/>
           </a:xfrm>
           <a:prstGeom prst="rect">
             <a:avLst/>
@@ -12756,18 +14015,18 @@
           <a:p>
             <a:pPr algn="r"/>
             <a:r>
-              <a:rPr lang="en-US" sz="1800" dirty="0"/>
-              <a:t>SINE age x prop.</a:t>
+              <a:rPr lang="en-US" sz="1200" dirty="0"/>
+              <a:t>LTR proportion</a:t>
             </a:r>
           </a:p>
         </p:txBody>
       </p:sp>
       <p:sp>
         <p:nvSpPr>
-          <p:cNvPr id="111" name="TextBox 110">
+          <p:cNvPr id="74" name="TextBox 73">
             <a:extLst>
               <a:ext uri="{FF2B5EF4-FFF2-40B4-BE49-F238E27FC236}">
-                <a16:creationId xmlns:a16="http://schemas.microsoft.com/office/drawing/2014/main" id="{315F07EE-C69C-86EF-B4C3-8F5A2BE0C7EF}"/>
+                <a16:creationId xmlns:a16="http://schemas.microsoft.com/office/drawing/2014/main" id="{FC89F880-71D3-5EE3-F70A-6451306561A4}"/>
               </a:ext>
             </a:extLst>
           </p:cNvPr>
@@ -12776,8 +14035,8 @@
         </p:nvSpPr>
         <p:spPr>
           <a:xfrm>
-            <a:off x="16705067" y="9682389"/>
-            <a:ext cx="2487803" cy="369332"/>
+            <a:off x="14003872" y="19303465"/>
+            <a:ext cx="2482930" cy="276999"/>
           </a:xfrm>
           <a:prstGeom prst="rect">
             <a:avLst/>
@@ -12792,18 +14051,18 @@
           <a:p>
             <a:pPr algn="r"/>
             <a:r>
-              <a:rPr lang="en-US" sz="1800" dirty="0"/>
-              <a:t>LINE age x prop.</a:t>
+              <a:rPr lang="en-US" sz="1200" dirty="0"/>
+              <a:t>Others proportion</a:t>
             </a:r>
           </a:p>
         </p:txBody>
       </p:sp>
       <p:sp>
         <p:nvSpPr>
-          <p:cNvPr id="112" name="TextBox 111">
+          <p:cNvPr id="75" name="TextBox 74">
             <a:extLst>
               <a:ext uri="{FF2B5EF4-FFF2-40B4-BE49-F238E27FC236}">
-                <a16:creationId xmlns:a16="http://schemas.microsoft.com/office/drawing/2014/main" id="{7C85B920-D38F-E181-DF07-CBD636DCDF32}"/>
+                <a16:creationId xmlns:a16="http://schemas.microsoft.com/office/drawing/2014/main" id="{B3F0BC77-FD47-F29E-4404-8078A005D133}"/>
               </a:ext>
             </a:extLst>
           </p:cNvPr>
@@ -12812,8 +14071,8 @@
         </p:nvSpPr>
         <p:spPr>
           <a:xfrm>
-            <a:off x="7841262" y="12085238"/>
-            <a:ext cx="2487803" cy="369332"/>
+            <a:off x="14003871" y="19577309"/>
+            <a:ext cx="2482930" cy="276999"/>
           </a:xfrm>
           <a:prstGeom prst="rect">
             <a:avLst/>
@@ -12828,18 +14087,18 @@
           <a:p>
             <a:pPr algn="r"/>
             <a:r>
-              <a:rPr lang="en-US" sz="1800" dirty="0"/>
-              <a:t>SINE proportion</a:t>
+              <a:rPr lang="en-US" sz="1200" dirty="0"/>
+              <a:t>Unknown proportion</a:t>
             </a:r>
           </a:p>
         </p:txBody>
       </p:sp>
       <p:sp>
         <p:nvSpPr>
-          <p:cNvPr id="113" name="TextBox 112">
+          <p:cNvPr id="77" name="TextBox 76">
             <a:extLst>
               <a:ext uri="{FF2B5EF4-FFF2-40B4-BE49-F238E27FC236}">
-                <a16:creationId xmlns:a16="http://schemas.microsoft.com/office/drawing/2014/main" id="{229A31CA-E605-F9FC-8580-08AED5276117}"/>
+                <a16:creationId xmlns:a16="http://schemas.microsoft.com/office/drawing/2014/main" id="{5B02B4B4-2DE8-C2C1-9104-CBED7E6D1A72}"/>
               </a:ext>
             </a:extLst>
           </p:cNvPr>
@@ -12848,8 +14107,8 @@
         </p:nvSpPr>
         <p:spPr>
           <a:xfrm>
-            <a:off x="7843223" y="11650003"/>
-            <a:ext cx="2487803" cy="369332"/>
+            <a:off x="16441102" y="20094600"/>
+            <a:ext cx="487045" cy="276999"/>
           </a:xfrm>
           <a:prstGeom prst="rect">
             <a:avLst/>
@@ -12862,20 +14121,20 @@
           </a:bodyPr>
           <a:lstStyle/>
           <a:p>
-            <a:pPr algn="r"/>
+            <a:pPr algn="ctr"/>
             <a:r>
-              <a:rPr lang="en-US" sz="1800" dirty="0"/>
-              <a:t>LINE proportion</a:t>
+              <a:rPr lang="en-US" sz="1200" dirty="0"/>
+              <a:t>-1</a:t>
             </a:r>
           </a:p>
         </p:txBody>
       </p:sp>
       <p:sp>
         <p:nvSpPr>
-          <p:cNvPr id="114" name="TextBox 113">
+          <p:cNvPr id="78" name="TextBox 77">
             <a:extLst>
               <a:ext uri="{FF2B5EF4-FFF2-40B4-BE49-F238E27FC236}">
-                <a16:creationId xmlns:a16="http://schemas.microsoft.com/office/drawing/2014/main" id="{10124EE6-EAA2-3E08-0874-B9ADD82C92AF}"/>
+                <a16:creationId xmlns:a16="http://schemas.microsoft.com/office/drawing/2014/main" id="{07FB9354-0C3D-AF16-172F-D7554E5B8757}"/>
               </a:ext>
             </a:extLst>
           </p:cNvPr>
@@ -12884,8 +14143,8 @@
         </p:nvSpPr>
         <p:spPr>
           <a:xfrm>
-            <a:off x="7841262" y="11214768"/>
-            <a:ext cx="2487803" cy="369332"/>
+            <a:off x="16845917" y="20092218"/>
+            <a:ext cx="487045" cy="276999"/>
           </a:xfrm>
           <a:prstGeom prst="rect">
             <a:avLst/>
@@ -12898,20 +14157,20 @@
           </a:bodyPr>
           <a:lstStyle/>
           <a:p>
-            <a:pPr algn="r"/>
+            <a:pPr algn="ctr"/>
             <a:r>
-              <a:rPr lang="en-US" sz="1800" dirty="0"/>
-              <a:t>DNA proportion</a:t>
+              <a:rPr lang="en-US" sz="1200" dirty="0"/>
+              <a:t>-0.5</a:t>
             </a:r>
           </a:p>
         </p:txBody>
       </p:sp>
       <p:sp>
         <p:nvSpPr>
-          <p:cNvPr id="115" name="TextBox 114">
+          <p:cNvPr id="79" name="TextBox 78">
             <a:extLst>
               <a:ext uri="{FF2B5EF4-FFF2-40B4-BE49-F238E27FC236}">
-                <a16:creationId xmlns:a16="http://schemas.microsoft.com/office/drawing/2014/main" id="{53A789F0-9989-C6C4-9A3E-50211C600F71}"/>
+                <a16:creationId xmlns:a16="http://schemas.microsoft.com/office/drawing/2014/main" id="{A3401E04-8426-4FD4-D11A-7762241B186E}"/>
               </a:ext>
             </a:extLst>
           </p:cNvPr>
@@ -12920,8 +14179,8 @@
         </p:nvSpPr>
         <p:spPr>
           <a:xfrm>
-            <a:off x="7841261" y="10779533"/>
-            <a:ext cx="2487803" cy="369332"/>
+            <a:off x="17250733" y="20094600"/>
+            <a:ext cx="487045" cy="276999"/>
           </a:xfrm>
           <a:prstGeom prst="rect">
             <a:avLst/>
@@ -12934,20 +14193,20 @@
           </a:bodyPr>
           <a:lstStyle/>
           <a:p>
-            <a:pPr algn="r"/>
+            <a:pPr algn="ctr"/>
             <a:r>
-              <a:rPr lang="en-US" sz="1800" dirty="0"/>
-              <a:t>All repeats age</a:t>
+              <a:rPr lang="en-US" sz="1200" dirty="0"/>
+              <a:t>-0</a:t>
             </a:r>
           </a:p>
         </p:txBody>
       </p:sp>
       <p:sp>
         <p:nvSpPr>
-          <p:cNvPr id="116" name="TextBox 115">
+          <p:cNvPr id="80" name="TextBox 79">
             <a:extLst>
               <a:ext uri="{FF2B5EF4-FFF2-40B4-BE49-F238E27FC236}">
-                <a16:creationId xmlns:a16="http://schemas.microsoft.com/office/drawing/2014/main" id="{1615377D-50C0-F060-F63D-C46C25C5B236}"/>
+                <a16:creationId xmlns:a16="http://schemas.microsoft.com/office/drawing/2014/main" id="{5BA714A7-2198-5CFF-D9C8-B4B6C7A82815}"/>
               </a:ext>
             </a:extLst>
           </p:cNvPr>
@@ -12956,8 +14215,8 @@
         </p:nvSpPr>
         <p:spPr>
           <a:xfrm>
-            <a:off x="7841260" y="10343777"/>
-            <a:ext cx="2487803" cy="369332"/>
+            <a:off x="17653171" y="20092219"/>
+            <a:ext cx="487045" cy="276999"/>
           </a:xfrm>
           <a:prstGeom prst="rect">
             <a:avLst/>
@@ -12970,20 +14229,20 @@
           </a:bodyPr>
           <a:lstStyle/>
           <a:p>
-            <a:pPr algn="r"/>
+            <a:pPr algn="ctr"/>
             <a:r>
-              <a:rPr lang="en-US" sz="1800" dirty="0"/>
-              <a:t>SINE age x prop.</a:t>
+              <a:rPr lang="en-US" sz="1200" dirty="0"/>
+              <a:t>0.5</a:t>
             </a:r>
           </a:p>
         </p:txBody>
       </p:sp>
       <p:sp>
         <p:nvSpPr>
-          <p:cNvPr id="117" name="TextBox 116">
+          <p:cNvPr id="81" name="TextBox 80">
             <a:extLst>
               <a:ext uri="{FF2B5EF4-FFF2-40B4-BE49-F238E27FC236}">
-                <a16:creationId xmlns:a16="http://schemas.microsoft.com/office/drawing/2014/main" id="{48BC15BA-5DF1-7D87-11F8-62101FE505BA}"/>
+                <a16:creationId xmlns:a16="http://schemas.microsoft.com/office/drawing/2014/main" id="{7789159D-E86D-A776-928C-F187E37843D7}"/>
               </a:ext>
             </a:extLst>
           </p:cNvPr>
@@ -12992,8 +14251,8 @@
         </p:nvSpPr>
         <p:spPr>
           <a:xfrm>
-            <a:off x="7841260" y="9907419"/>
-            <a:ext cx="2487803" cy="369332"/>
+            <a:off x="18057987" y="20094598"/>
+            <a:ext cx="487045" cy="276999"/>
           </a:xfrm>
           <a:prstGeom prst="rect">
             <a:avLst/>
@@ -13006,20 +14265,20 @@
           </a:bodyPr>
           <a:lstStyle/>
           <a:p>
-            <a:pPr algn="r"/>
+            <a:pPr algn="ctr"/>
             <a:r>
-              <a:rPr lang="en-US" sz="1800" dirty="0"/>
-              <a:t>SINE age</a:t>
+              <a:rPr lang="en-US" sz="1200" dirty="0"/>
+              <a:t>1</a:t>
             </a:r>
           </a:p>
         </p:txBody>
       </p:sp>
       <p:sp>
         <p:nvSpPr>
-          <p:cNvPr id="118" name="TextBox 117">
+          <p:cNvPr id="86" name="TextBox 85">
             <a:extLst>
               <a:ext uri="{FF2B5EF4-FFF2-40B4-BE49-F238E27FC236}">
-                <a16:creationId xmlns:a16="http://schemas.microsoft.com/office/drawing/2014/main" id="{5C876687-0AFC-AD68-E32B-7BB5189198D7}"/>
+                <a16:creationId xmlns:a16="http://schemas.microsoft.com/office/drawing/2014/main" id="{33CE45A6-3053-1897-E518-3E69567F5CE3}"/>
               </a:ext>
             </a:extLst>
           </p:cNvPr>
@@ -13028,8 +14287,8 @@
         </p:nvSpPr>
         <p:spPr>
           <a:xfrm>
-            <a:off x="7841259" y="9469803"/>
-            <a:ext cx="2487803" cy="369332"/>
+            <a:off x="18492826" y="20094605"/>
+            <a:ext cx="487045" cy="276999"/>
           </a:xfrm>
           <a:prstGeom prst="rect">
             <a:avLst/>
@@ -13042,20 +14301,20 @@
           </a:bodyPr>
           <a:lstStyle/>
           <a:p>
-            <a:pPr algn="r"/>
+            <a:pPr algn="ctr"/>
             <a:r>
-              <a:rPr lang="en-US" sz="1800" dirty="0"/>
-              <a:t>LTR age x prop.</a:t>
+              <a:rPr lang="en-US" sz="1200" dirty="0"/>
+              <a:t>-1</a:t>
             </a:r>
           </a:p>
         </p:txBody>
       </p:sp>
       <p:sp>
         <p:nvSpPr>
-          <p:cNvPr id="119" name="TextBox 118">
+          <p:cNvPr id="87" name="TextBox 86">
             <a:extLst>
               <a:ext uri="{FF2B5EF4-FFF2-40B4-BE49-F238E27FC236}">
-                <a16:creationId xmlns:a16="http://schemas.microsoft.com/office/drawing/2014/main" id="{728CACD8-4266-26C9-8DEB-A7A1DE4F7273}"/>
+                <a16:creationId xmlns:a16="http://schemas.microsoft.com/office/drawing/2014/main" id="{965702ED-C700-7F94-A24E-593E1C1F9F11}"/>
               </a:ext>
             </a:extLst>
           </p:cNvPr>
@@ -13064,8 +14323,8 @@
         </p:nvSpPr>
         <p:spPr>
           <a:xfrm>
-            <a:off x="7841259" y="15808716"/>
-            <a:ext cx="2487803" cy="369332"/>
+            <a:off x="18890498" y="20092223"/>
+            <a:ext cx="487045" cy="276999"/>
           </a:xfrm>
           <a:prstGeom prst="rect">
             <a:avLst/>
@@ -13078,20 +14337,128 @@
           </a:bodyPr>
           <a:lstStyle/>
           <a:p>
-            <a:pPr algn="r"/>
+            <a:pPr algn="ctr"/>
             <a:r>
-              <a:rPr lang="en-US" sz="1800" dirty="0"/>
-              <a:t>Others proportion</a:t>
+              <a:rPr lang="en-US" sz="1200" dirty="0"/>
+              <a:t>-0.5</a:t>
+            </a:r>
+          </a:p>
+        </p:txBody>
+      </p:sp>
+      <p:sp>
+        <p:nvSpPr>
+          <p:cNvPr id="88" name="TextBox 87">
+            <a:extLst>
+              <a:ext uri="{FF2B5EF4-FFF2-40B4-BE49-F238E27FC236}">
+                <a16:creationId xmlns:a16="http://schemas.microsoft.com/office/drawing/2014/main" id="{F2F54D34-AF2C-6A2E-922E-6593281BDF97}"/>
+              </a:ext>
+            </a:extLst>
+          </p:cNvPr>
+          <p:cNvSpPr txBox="1"/>
+          <p:nvPr/>
+        </p:nvSpPr>
+        <p:spPr>
+          <a:xfrm>
+            <a:off x="19288170" y="20094605"/>
+            <a:ext cx="487045" cy="276999"/>
+          </a:xfrm>
+          <a:prstGeom prst="rect">
+            <a:avLst/>
+          </a:prstGeom>
+          <a:noFill/>
+        </p:spPr>
+        <p:txBody>
+          <a:bodyPr wrap="square" rtlCol="0">
+            <a:spAutoFit/>
+          </a:bodyPr>
+          <a:lstStyle/>
+          <a:p>
+            <a:pPr algn="ctr"/>
+            <a:r>
+              <a:rPr lang="en-US" sz="1200" dirty="0"/>
+              <a:t>-0</a:t>
+            </a:r>
+          </a:p>
+        </p:txBody>
+      </p:sp>
+      <p:sp>
+        <p:nvSpPr>
+          <p:cNvPr id="89" name="TextBox 88">
+            <a:extLst>
+              <a:ext uri="{FF2B5EF4-FFF2-40B4-BE49-F238E27FC236}">
+                <a16:creationId xmlns:a16="http://schemas.microsoft.com/office/drawing/2014/main" id="{C0077FF4-E62F-61AA-EA96-72B167D4343E}"/>
+              </a:ext>
+            </a:extLst>
+          </p:cNvPr>
+          <p:cNvSpPr txBox="1"/>
+          <p:nvPr/>
+        </p:nvSpPr>
+        <p:spPr>
+          <a:xfrm>
+            <a:off x="19685847" y="20092224"/>
+            <a:ext cx="487045" cy="276999"/>
+          </a:xfrm>
+          <a:prstGeom prst="rect">
+            <a:avLst/>
+          </a:prstGeom>
+          <a:noFill/>
+        </p:spPr>
+        <p:txBody>
+          <a:bodyPr wrap="square" rtlCol="0">
+            <a:spAutoFit/>
+          </a:bodyPr>
+          <a:lstStyle/>
+          <a:p>
+            <a:pPr algn="ctr"/>
+            <a:r>
+              <a:rPr lang="en-US" sz="1200" dirty="0"/>
+              <a:t>0.5</a:t>
+            </a:r>
+          </a:p>
+        </p:txBody>
+      </p:sp>
+      <p:sp>
+        <p:nvSpPr>
+          <p:cNvPr id="90" name="TextBox 89">
+            <a:extLst>
+              <a:ext uri="{FF2B5EF4-FFF2-40B4-BE49-F238E27FC236}">
+                <a16:creationId xmlns:a16="http://schemas.microsoft.com/office/drawing/2014/main" id="{4D6C20B1-C1C1-A731-DFEA-B1917EF6368C}"/>
+              </a:ext>
+            </a:extLst>
+          </p:cNvPr>
+          <p:cNvSpPr txBox="1"/>
+          <p:nvPr/>
+        </p:nvSpPr>
+        <p:spPr>
+          <a:xfrm>
+            <a:off x="20085898" y="20094603"/>
+            <a:ext cx="487045" cy="276999"/>
+          </a:xfrm>
+          <a:prstGeom prst="rect">
+            <a:avLst/>
+          </a:prstGeom>
+          <a:noFill/>
+        </p:spPr>
+        <p:txBody>
+          <a:bodyPr wrap="square" rtlCol="0">
+            <a:spAutoFit/>
+          </a:bodyPr>
+          <a:lstStyle/>
+          <a:p>
+            <a:pPr algn="ctr"/>
+            <a:r>
+              <a:rPr lang="en-US" sz="1200" dirty="0"/>
+              <a:t>1</a:t>
             </a:r>
           </a:p>
         </p:txBody>
       </p:sp>
       <p:pic>
         <p:nvPicPr>
-          <p:cNvPr id="120" name="Picture 119">
+          <p:cNvPr id="91" name="Picture 90">
             <a:extLst>
               <a:ext uri="{FF2B5EF4-FFF2-40B4-BE49-F238E27FC236}">
-                <a16:creationId xmlns:a16="http://schemas.microsoft.com/office/drawing/2014/main" id="{6BF62B03-76DD-5EB0-2350-8C1AE3C543BD}"/>
+                <a16:creationId xmlns:a16="http://schemas.microsoft.com/office/drawing/2014/main" id="{A0C902C3-2067-E287-4C51-FF6F78DCDD6D}"/>
               </a:ext>
             </a:extLst>
           </p:cNvPr>
@@ -13109,8 +14476,8 @@
         </p:blipFill>
         <p:spPr>
           <a:xfrm>
-            <a:off x="25375433" y="10343777"/>
-            <a:ext cx="3194187" cy="1498907"/>
+            <a:off x="20435891" y="15531457"/>
+            <a:ext cx="2001201" cy="939085"/>
           </a:xfrm>
           <a:prstGeom prst="rect">
             <a:avLst/>
@@ -13119,10 +14486,10 @@
       </p:pic>
       <p:grpSp>
         <p:nvGrpSpPr>
-          <p:cNvPr id="193" name="Group 192">
+          <p:cNvPr id="92" name="Group 91">
             <a:extLst>
               <a:ext uri="{FF2B5EF4-FFF2-40B4-BE49-F238E27FC236}">
-                <a16:creationId xmlns:a16="http://schemas.microsoft.com/office/drawing/2014/main" id="{16CF8CBC-D2A7-DEB6-43BC-768B89739AB3}"/>
+                <a16:creationId xmlns:a16="http://schemas.microsoft.com/office/drawing/2014/main" id="{7A52061A-A51B-B12E-DA82-902F964F6682}"/>
               </a:ext>
             </a:extLst>
           </p:cNvPr>
@@ -13131,18 +14498,18 @@
         </p:nvGrpSpPr>
         <p:grpSpPr>
           <a:xfrm>
-            <a:off x="25967960" y="12113015"/>
-            <a:ext cx="2618621" cy="5837070"/>
-            <a:chOff x="26196264" y="12193271"/>
-            <a:chExt cx="2618621" cy="5837070"/>
+            <a:off x="20790247" y="16606570"/>
+            <a:ext cx="1852487" cy="3722165"/>
+            <a:chOff x="26169337" y="12140059"/>
+            <a:chExt cx="2956820" cy="5941082"/>
           </a:xfrm>
         </p:grpSpPr>
         <p:sp>
           <p:nvSpPr>
-            <p:cNvPr id="122" name="TextBox 121">
+            <p:cNvPr id="107" name="TextBox 106">
               <a:extLst>
                 <a:ext uri="{FF2B5EF4-FFF2-40B4-BE49-F238E27FC236}">
-                  <a16:creationId xmlns:a16="http://schemas.microsoft.com/office/drawing/2014/main" id="{3081E5F0-4263-1175-30EF-85D92F9B8011}"/>
+                  <a16:creationId xmlns:a16="http://schemas.microsoft.com/office/drawing/2014/main" id="{77F321F3-2B93-CA1F-FF04-7B6A413B1D2A}"/>
                 </a:ext>
               </a:extLst>
             </p:cNvPr>
@@ -13151,8 +14518,8 @@
           </p:nvSpPr>
           <p:spPr>
             <a:xfrm>
-              <a:off x="27737927" y="17507121"/>
-              <a:ext cx="1076958" cy="523220"/>
+              <a:off x="27737926" y="17442511"/>
+              <a:ext cx="1388231" cy="638630"/>
             </a:xfrm>
             <a:prstGeom prst="rect">
               <a:avLst/>
@@ -13166,7 +14533,7 @@
             <a:lstStyle/>
             <a:p>
               <a:r>
-                <a:rPr lang="en-US" sz="2800" dirty="0"/>
+                <a:rPr lang="en-US" sz="2000" dirty="0"/>
                 <a:t>0.5</a:t>
               </a:r>
             </a:p>
@@ -13174,10 +14541,10 @@
         </p:sp>
         <p:sp>
           <p:nvSpPr>
-            <p:cNvPr id="123" name="TextBox 122">
+            <p:cNvPr id="121" name="TextBox 120">
               <a:extLst>
                 <a:ext uri="{FF2B5EF4-FFF2-40B4-BE49-F238E27FC236}">
-                  <a16:creationId xmlns:a16="http://schemas.microsoft.com/office/drawing/2014/main" id="{3EDA5315-CAE9-FD83-C900-C1A33A61CF91}"/>
+                  <a16:creationId xmlns:a16="http://schemas.microsoft.com/office/drawing/2014/main" id="{D9FC5866-1475-F9A0-237A-FAD01903EA5A}"/>
                 </a:ext>
               </a:extLst>
             </p:cNvPr>
@@ -13186,8 +14553,8 @@
           </p:nvSpPr>
           <p:spPr>
             <a:xfrm>
-              <a:off x="27737927" y="12193271"/>
-              <a:ext cx="1076958" cy="523220"/>
+              <a:off x="27737926" y="12140059"/>
+              <a:ext cx="1388231" cy="638630"/>
             </a:xfrm>
             <a:prstGeom prst="rect">
               <a:avLst/>
@@ -13201,7 +14568,7 @@
             <a:lstStyle/>
             <a:p>
               <a:r>
-                <a:rPr lang="en-US" sz="2800" dirty="0"/>
+                <a:rPr lang="en-US" sz="2000" dirty="0"/>
                 <a:t>1</a:t>
               </a:r>
             </a:p>
@@ -13209,10 +14576,10 @@
         </p:sp>
         <p:sp>
           <p:nvSpPr>
-            <p:cNvPr id="124" name="TextBox 123">
+            <p:cNvPr id="125" name="TextBox 124">
               <a:extLst>
                 <a:ext uri="{FF2B5EF4-FFF2-40B4-BE49-F238E27FC236}">
-                  <a16:creationId xmlns:a16="http://schemas.microsoft.com/office/drawing/2014/main" id="{FC0FD309-454B-75BD-2355-2C1822A07440}"/>
+                  <a16:creationId xmlns:a16="http://schemas.microsoft.com/office/drawing/2014/main" id="{C30DDDD0-4271-85FB-BD52-2708330B8AA2}"/>
                 </a:ext>
               </a:extLst>
             </p:cNvPr>
@@ -13221,8 +14588,8 @@
           </p:nvSpPr>
           <p:spPr>
             <a:xfrm>
-              <a:off x="27737927" y="14845178"/>
-              <a:ext cx="1076958" cy="523220"/>
+              <a:off x="27737926" y="14791967"/>
+              <a:ext cx="1388231" cy="638630"/>
             </a:xfrm>
             <a:prstGeom prst="rect">
               <a:avLst/>
@@ -13236,7 +14603,7 @@
             <a:lstStyle/>
             <a:p>
               <a:r>
-                <a:rPr lang="en-US" sz="2800" dirty="0"/>
+                <a:rPr lang="en-US" sz="2000" dirty="0"/>
                 <a:t>0.75</a:t>
               </a:r>
             </a:p>
@@ -13244,10 +14611,10 @@
         </p:sp>
         <p:pic>
           <p:nvPicPr>
-            <p:cNvPr id="126" name="Picture 125">
+            <p:cNvPr id="158" name="Picture 157">
               <a:extLst>
                 <a:ext uri="{FF2B5EF4-FFF2-40B4-BE49-F238E27FC236}">
-                  <a16:creationId xmlns:a16="http://schemas.microsoft.com/office/drawing/2014/main" id="{E782AADA-9C34-46C4-111D-837C0D8FDF0D}"/>
+                  <a16:creationId xmlns:a16="http://schemas.microsoft.com/office/drawing/2014/main" id="{79932096-4C5E-66A6-8E15-1426709506DC}"/>
                 </a:ext>
               </a:extLst>
             </p:cNvPr>
@@ -13275,10 +14642,10 @@
         </p:pic>
         <p:sp>
           <p:nvSpPr>
-            <p:cNvPr id="127" name="TextBox 126">
+            <p:cNvPr id="159" name="TextBox 158">
               <a:extLst>
                 <a:ext uri="{FF2B5EF4-FFF2-40B4-BE49-F238E27FC236}">
-                  <a16:creationId xmlns:a16="http://schemas.microsoft.com/office/drawing/2014/main" id="{F42C09AD-0AF7-0CF8-B180-AD38F49D012D}"/>
+                  <a16:creationId xmlns:a16="http://schemas.microsoft.com/office/drawing/2014/main" id="{DE3864F8-5A10-9CFE-4607-A3B0F422BCFC}"/>
                 </a:ext>
               </a:extLst>
             </p:cNvPr>
@@ -13287,8 +14654,8 @@
           </p:nvSpPr>
           <p:spPr>
             <a:xfrm rot="16200000">
-              <a:off x="24233222" y="14818483"/>
-              <a:ext cx="4510860" cy="584775"/>
+              <a:off x="24233222" y="14791554"/>
+              <a:ext cx="4510860" cy="638630"/>
             </a:xfrm>
             <a:prstGeom prst="rect">
               <a:avLst/>
@@ -13303,7 +14670,7 @@
             <a:p>
               <a:pPr algn="ctr"/>
               <a:r>
-                <a:rPr lang="en-US" sz="3200" dirty="0"/>
+                <a:rPr lang="en-US" sz="2000" dirty="0"/>
                 <a:t>Variable importance</a:t>
               </a:r>
             </a:p>
@@ -13311,10 +14678,10 @@
         </p:sp>
         <p:cxnSp>
           <p:nvCxnSpPr>
-            <p:cNvPr id="128" name="Straight Connector 127">
+            <p:cNvPr id="160" name="Straight Connector 159">
               <a:extLst>
                 <a:ext uri="{FF2B5EF4-FFF2-40B4-BE49-F238E27FC236}">
-                  <a16:creationId xmlns:a16="http://schemas.microsoft.com/office/drawing/2014/main" id="{056D2A61-49C7-0CB8-90D1-AB9EFE005112}"/>
+                  <a16:creationId xmlns:a16="http://schemas.microsoft.com/office/drawing/2014/main" id="{14574362-D58C-9B74-0B9D-84F2494E841F}"/>
                 </a:ext>
               </a:extLst>
             </p:cNvPr>
@@ -13331,7 +14698,7 @@
             <a:prstGeom prst="line">
               <a:avLst/>
             </a:prstGeom>
-            <a:ln w="38100">
+            <a:ln w="28575">
               <a:solidFill>
                 <a:schemeClr val="tx1"/>
               </a:solidFill>
@@ -13354,10 +14721,10 @@
         </p:cxnSp>
         <p:cxnSp>
           <p:nvCxnSpPr>
-            <p:cNvPr id="129" name="Straight Connector 128">
+            <p:cNvPr id="161" name="Straight Connector 160">
               <a:extLst>
                 <a:ext uri="{FF2B5EF4-FFF2-40B4-BE49-F238E27FC236}">
-                  <a16:creationId xmlns:a16="http://schemas.microsoft.com/office/drawing/2014/main" id="{B2DB2A54-8D0A-5E85-FF08-92067FFC4EE9}"/>
+                  <a16:creationId xmlns:a16="http://schemas.microsoft.com/office/drawing/2014/main" id="{7D1C05B6-4D84-855F-D831-C0BB04181013}"/>
                 </a:ext>
               </a:extLst>
             </p:cNvPr>
@@ -13368,13 +14735,13 @@
           </p:nvCxnSpPr>
           <p:spPr>
             <a:xfrm flipH="1">
-              <a:off x="27538126" y="17766462"/>
+              <a:off x="27538125" y="17762661"/>
               <a:ext cx="178857" cy="0"/>
             </a:xfrm>
             <a:prstGeom prst="line">
               <a:avLst/>
             </a:prstGeom>
-            <a:ln w="38100">
+            <a:ln w="28575">
               <a:solidFill>
                 <a:schemeClr val="tx1"/>
               </a:solidFill>
@@ -13397,10 +14764,10 @@
         </p:cxnSp>
         <p:cxnSp>
           <p:nvCxnSpPr>
-            <p:cNvPr id="130" name="Straight Connector 129">
+            <p:cNvPr id="162" name="Straight Connector 161">
               <a:extLst>
                 <a:ext uri="{FF2B5EF4-FFF2-40B4-BE49-F238E27FC236}">
-                  <a16:creationId xmlns:a16="http://schemas.microsoft.com/office/drawing/2014/main" id="{6BC2F607-59A1-A2FF-2F10-20F5671F2E9C}"/>
+                  <a16:creationId xmlns:a16="http://schemas.microsoft.com/office/drawing/2014/main" id="{2C63D014-50B5-FD86-0CA5-90D92D71B40D}"/>
                 </a:ext>
               </a:extLst>
             </p:cNvPr>
@@ -13411,13 +14778,13 @@
           </p:nvCxnSpPr>
           <p:spPr>
             <a:xfrm flipH="1">
-              <a:off x="27538124" y="12455115"/>
+              <a:off x="27538124" y="12458916"/>
               <a:ext cx="178857" cy="0"/>
             </a:xfrm>
             <a:prstGeom prst="line">
               <a:avLst/>
             </a:prstGeom>
-            <a:ln w="38100">
+            <a:ln w="28575">
               <a:solidFill>
                 <a:schemeClr val="tx1"/>
               </a:solidFill>
@@ -13440,10 +14807,10 @@
         </p:cxnSp>
         <p:cxnSp>
           <p:nvCxnSpPr>
-            <p:cNvPr id="131" name="Straight Connector 130">
+            <p:cNvPr id="192" name="Straight Connector 191">
               <a:extLst>
                 <a:ext uri="{FF2B5EF4-FFF2-40B4-BE49-F238E27FC236}">
-                  <a16:creationId xmlns:a16="http://schemas.microsoft.com/office/drawing/2014/main" id="{D72FAD55-F0F6-6124-8552-9332E99BF7BD}"/>
+                  <a16:creationId xmlns:a16="http://schemas.microsoft.com/office/drawing/2014/main" id="{7225533E-D572-0CE0-E276-79222D070DA0}"/>
                 </a:ext>
               </a:extLst>
             </p:cNvPr>
@@ -13460,7 +14827,7 @@
             <a:prstGeom prst="line">
               <a:avLst/>
             </a:prstGeom>
-            <a:ln w="38100">
+            <a:ln w="28575">
               <a:solidFill>
                 <a:schemeClr val="tx1"/>
               </a:solidFill>
@@ -13484,10 +14851,10 @@
       </p:grpSp>
       <p:sp>
         <p:nvSpPr>
-          <p:cNvPr id="132" name="TextBox 131">
+          <p:cNvPr id="194" name="TextBox 193">
             <a:extLst>
               <a:ext uri="{FF2B5EF4-FFF2-40B4-BE49-F238E27FC236}">
-                <a16:creationId xmlns:a16="http://schemas.microsoft.com/office/drawing/2014/main" id="{C4EE4003-A8E8-0FDC-1FDB-C4CE696377D1}"/>
+                <a16:creationId xmlns:a16="http://schemas.microsoft.com/office/drawing/2014/main" id="{01428F5F-F3A5-0721-C78B-32DA422DB683}"/>
               </a:ext>
             </a:extLst>
           </p:cNvPr>
@@ -13496,8 +14863,8 @@
         </p:nvSpPr>
         <p:spPr>
           <a:xfrm>
-            <a:off x="25915153" y="9196867"/>
-            <a:ext cx="3596182" cy="1077218"/>
+            <a:off x="20774033" y="14812903"/>
+            <a:ext cx="2253056" cy="677108"/>
           </a:xfrm>
           <a:prstGeom prst="rect">
             <a:avLst/>
@@ -13511,13 +14878,13 @@
           <a:lstStyle/>
           <a:p>
             <a:r>
-              <a:rPr lang="en-US" sz="3200" dirty="0"/>
+              <a:rPr lang="en-US" sz="1900" dirty="0"/>
               <a:t>Response</a:t>
             </a:r>
           </a:p>
           <a:p>
             <a:r>
-              <a:rPr lang="en-US" sz="3200" dirty="0"/>
+              <a:rPr lang="en-US" sz="1900" dirty="0"/>
               <a:t>metric</a:t>
             </a:r>
           </a:p>
@@ -13525,10 +14892,10 @@
       </p:sp>
       <p:sp>
         <p:nvSpPr>
-          <p:cNvPr id="133" name="TextBox 132">
+          <p:cNvPr id="2" name="TextBox 1">
             <a:extLst>
               <a:ext uri="{FF2B5EF4-FFF2-40B4-BE49-F238E27FC236}">
-                <a16:creationId xmlns:a16="http://schemas.microsoft.com/office/drawing/2014/main" id="{60D1E9A0-C5D8-4F09-FC55-2EBBD7DA0873}"/>
+                <a16:creationId xmlns:a16="http://schemas.microsoft.com/office/drawing/2014/main" id="{5CEC8067-8826-CD99-7273-64094B2C0A44}"/>
               </a:ext>
             </a:extLst>
           </p:cNvPr>
@@ -13537,8 +14904,8 @@
         </p:nvSpPr>
         <p:spPr>
           <a:xfrm>
-            <a:off x="19192689" y="12873728"/>
-            <a:ext cx="545402" cy="430887"/>
+            <a:off x="11282685" y="20453693"/>
+            <a:ext cx="3128962" cy="307777"/>
           </a:xfrm>
           <a:prstGeom prst="rect">
             <a:avLst/>
@@ -13553,18 +14920,23 @@
           <a:p>
             <a:pPr algn="ctr"/>
             <a:r>
-              <a:rPr lang="en-US" sz="2200" dirty="0"/>
-              <a:t>-1</a:t>
+              <a:rPr lang="en-US" dirty="0"/>
+              <a:t>Sign-aligned </a:t>
             </a:r>
+            <a:r>
+              <a:rPr lang="el-GR" dirty="0"/>
+              <a:t>β</a:t>
+            </a:r>
+            <a:endParaRPr lang="en-US" dirty="0"/>
           </a:p>
         </p:txBody>
       </p:sp>
       <p:sp>
         <p:nvSpPr>
-          <p:cNvPr id="134" name="TextBox 133">
+          <p:cNvPr id="5" name="TextBox 4">
             <a:extLst>
               <a:ext uri="{FF2B5EF4-FFF2-40B4-BE49-F238E27FC236}">
-                <a16:creationId xmlns:a16="http://schemas.microsoft.com/office/drawing/2014/main" id="{5C920CF1-60A0-92D1-6E31-BD651AD91923}"/>
+                <a16:creationId xmlns:a16="http://schemas.microsoft.com/office/drawing/2014/main" id="{8035113F-4EB3-347E-02BD-44950EF85269}"/>
               </a:ext>
             </a:extLst>
           </p:cNvPr>
@@ -13573,8 +14945,8 @@
         </p:nvSpPr>
         <p:spPr>
           <a:xfrm>
-            <a:off x="19710214" y="12873728"/>
-            <a:ext cx="545402" cy="430887"/>
+            <a:off x="16965300" y="20453693"/>
+            <a:ext cx="3128962" cy="307777"/>
           </a:xfrm>
           <a:prstGeom prst="rect">
             <a:avLst/>
@@ -13589,18 +14961,23 @@
           <a:p>
             <a:pPr algn="ctr"/>
             <a:r>
-              <a:rPr lang="en-US" sz="2200" dirty="0"/>
-              <a:t>0</a:t>
+              <a:rPr lang="en-US" dirty="0"/>
+              <a:t>Sign-aligned </a:t>
             </a:r>
+            <a:r>
+              <a:rPr lang="el-GR" dirty="0"/>
+              <a:t>β</a:t>
+            </a:r>
+            <a:endParaRPr lang="en-US" dirty="0"/>
           </a:p>
         </p:txBody>
       </p:sp>
       <p:sp>
         <p:nvSpPr>
-          <p:cNvPr id="135" name="TextBox 134">
+          <p:cNvPr id="7" name="TextBox 6">
             <a:extLst>
               <a:ext uri="{FF2B5EF4-FFF2-40B4-BE49-F238E27FC236}">
-                <a16:creationId xmlns:a16="http://schemas.microsoft.com/office/drawing/2014/main" id="{12523B9F-5B67-DA9D-1EF2-FBEE5FD82282}"/>
+                <a16:creationId xmlns:a16="http://schemas.microsoft.com/office/drawing/2014/main" id="{A7C881BB-F81D-5B2F-69D0-C79EBCA1B22D}"/>
               </a:ext>
             </a:extLst>
           </p:cNvPr>
@@ -13609,8 +14986,48 @@
         </p:nvSpPr>
         <p:spPr>
           <a:xfrm>
-            <a:off x="20230733" y="12873728"/>
-            <a:ext cx="545402" cy="430887"/>
+            <a:off x="15704345" y="17516077"/>
+            <a:ext cx="2797722" cy="307777"/>
+          </a:xfrm>
+          <a:prstGeom prst="rect">
+            <a:avLst/>
+          </a:prstGeom>
+          <a:noFill/>
+        </p:spPr>
+        <p:txBody>
+          <a:bodyPr wrap="square" rtlCol="0">
+            <a:spAutoFit/>
+          </a:bodyPr>
+          <a:lstStyle/>
+          <a:p>
+            <a:pPr algn="r"/>
+            <a:r>
+              <a:rPr lang="en-US" dirty="0" err="1"/>
+              <a:t>Sauropsida</a:t>
+            </a:r>
+            <a:r>
+              <a:rPr lang="en-US" dirty="0"/>
+              <a:t> main model set</a:t>
+            </a:r>
+          </a:p>
+        </p:txBody>
+      </p:sp>
+      <p:sp>
+        <p:nvSpPr>
+          <p:cNvPr id="10" name="TextBox 9">
+            <a:extLst>
+              <a:ext uri="{FF2B5EF4-FFF2-40B4-BE49-F238E27FC236}">
+                <a16:creationId xmlns:a16="http://schemas.microsoft.com/office/drawing/2014/main" id="{7F58AD4A-CC46-74BC-4093-1D5D58052330}"/>
+              </a:ext>
+            </a:extLst>
+          </p:cNvPr>
+          <p:cNvSpPr txBox="1"/>
+          <p:nvPr/>
+        </p:nvSpPr>
+        <p:spPr>
+          <a:xfrm>
+            <a:off x="18538558" y="17512854"/>
+            <a:ext cx="1954517" cy="307777"/>
           </a:xfrm>
           <a:prstGeom prst="rect">
             <a:avLst/>
@@ -13625,18 +15042,18 @@
           <a:p>
             <a:pPr algn="ctr"/>
             <a:r>
-              <a:rPr lang="en-US" sz="2200" dirty="0"/>
-              <a:t>1</a:t>
+              <a:rPr lang="en-US" dirty="0"/>
+              <a:t>All repeats predictors</a:t>
             </a:r>
           </a:p>
         </p:txBody>
       </p:sp>
       <p:sp>
         <p:nvSpPr>
-          <p:cNvPr id="136" name="TextBox 135">
+          <p:cNvPr id="11" name="TextBox 10">
             <a:extLst>
               <a:ext uri="{FF2B5EF4-FFF2-40B4-BE49-F238E27FC236}">
-                <a16:creationId xmlns:a16="http://schemas.microsoft.com/office/drawing/2014/main" id="{AEEC13D6-783E-236A-F9E8-70997A74EC93}"/>
+                <a16:creationId xmlns:a16="http://schemas.microsoft.com/office/drawing/2014/main" id="{878785A8-7BCF-AF9F-7910-EC6A0B90807A}"/>
               </a:ext>
             </a:extLst>
           </p:cNvPr>
@@ -13645,8 +15062,44 @@
         </p:nvSpPr>
         <p:spPr>
           <a:xfrm>
-            <a:off x="20751433" y="12873728"/>
-            <a:ext cx="545402" cy="430887"/>
+            <a:off x="10022199" y="17507995"/>
+            <a:ext cx="2797722" cy="307777"/>
+          </a:xfrm>
+          <a:prstGeom prst="rect">
+            <a:avLst/>
+          </a:prstGeom>
+          <a:noFill/>
+        </p:spPr>
+        <p:txBody>
+          <a:bodyPr wrap="square" rtlCol="0">
+            <a:spAutoFit/>
+          </a:bodyPr>
+          <a:lstStyle/>
+          <a:p>
+            <a:pPr algn="r"/>
+            <a:r>
+              <a:rPr lang="en-US" dirty="0"/>
+              <a:t>Actinopterygii main model set</a:t>
+            </a:r>
+          </a:p>
+        </p:txBody>
+      </p:sp>
+      <p:sp>
+        <p:nvSpPr>
+          <p:cNvPr id="24" name="TextBox 23">
+            <a:extLst>
+              <a:ext uri="{FF2B5EF4-FFF2-40B4-BE49-F238E27FC236}">
+                <a16:creationId xmlns:a16="http://schemas.microsoft.com/office/drawing/2014/main" id="{942686A0-7720-BB05-3901-CF97BD4A543E}"/>
+              </a:ext>
+            </a:extLst>
+          </p:cNvPr>
+          <p:cNvSpPr txBox="1"/>
+          <p:nvPr/>
+        </p:nvSpPr>
+        <p:spPr>
+          <a:xfrm>
+            <a:off x="12856412" y="17504772"/>
+            <a:ext cx="1954517" cy="307777"/>
           </a:xfrm>
           <a:prstGeom prst="rect">
             <a:avLst/>
@@ -13661,18 +15114,18 @@
           <a:p>
             <a:pPr algn="ctr"/>
             <a:r>
-              <a:rPr lang="en-US" sz="2200" dirty="0"/>
-              <a:t>2</a:t>
+              <a:rPr lang="en-US" dirty="0"/>
+              <a:t>All repeats predictors</a:t>
             </a:r>
           </a:p>
         </p:txBody>
       </p:sp>
       <p:sp>
         <p:nvSpPr>
-          <p:cNvPr id="137" name="TextBox 136">
+          <p:cNvPr id="25" name="TextBox 24">
             <a:extLst>
               <a:ext uri="{FF2B5EF4-FFF2-40B4-BE49-F238E27FC236}">
-                <a16:creationId xmlns:a16="http://schemas.microsoft.com/office/drawing/2014/main" id="{9BB986EF-0883-849C-B92B-498FCE6FA2B1}"/>
+                <a16:creationId xmlns:a16="http://schemas.microsoft.com/office/drawing/2014/main" id="{0147AE2E-2929-9D86-0084-9B3F841421CB}"/>
               </a:ext>
             </a:extLst>
           </p:cNvPr>
@@ -13681,8 +15134,44 @@
         </p:nvSpPr>
         <p:spPr>
           <a:xfrm>
-            <a:off x="21268777" y="12873728"/>
-            <a:ext cx="545402" cy="430887"/>
+            <a:off x="10019814" y="14467134"/>
+            <a:ext cx="2797722" cy="307777"/>
+          </a:xfrm>
+          <a:prstGeom prst="rect">
+            <a:avLst/>
+          </a:prstGeom>
+          <a:noFill/>
+        </p:spPr>
+        <p:txBody>
+          <a:bodyPr wrap="square" rtlCol="0">
+            <a:spAutoFit/>
+          </a:bodyPr>
+          <a:lstStyle/>
+          <a:p>
+            <a:pPr algn="r"/>
+            <a:r>
+              <a:rPr lang="en-US" dirty="0"/>
+              <a:t>All species main model set</a:t>
+            </a:r>
+          </a:p>
+        </p:txBody>
+      </p:sp>
+      <p:sp>
+        <p:nvSpPr>
+          <p:cNvPr id="26" name="TextBox 25">
+            <a:extLst>
+              <a:ext uri="{FF2B5EF4-FFF2-40B4-BE49-F238E27FC236}">
+                <a16:creationId xmlns:a16="http://schemas.microsoft.com/office/drawing/2014/main" id="{C93A5B39-8F60-85A4-31AA-5762F919C800}"/>
+              </a:ext>
+            </a:extLst>
+          </p:cNvPr>
+          <p:cNvSpPr txBox="1"/>
+          <p:nvPr/>
+        </p:nvSpPr>
+        <p:spPr>
+          <a:xfrm>
+            <a:off x="12854027" y="14463911"/>
+            <a:ext cx="1954517" cy="307777"/>
           </a:xfrm>
           <a:prstGeom prst="rect">
             <a:avLst/>
@@ -13697,18 +15186,18 @@
           <a:p>
             <a:pPr algn="ctr"/>
             <a:r>
-              <a:rPr lang="en-US" sz="2200" dirty="0"/>
-              <a:t>3</a:t>
+              <a:rPr lang="en-US" dirty="0"/>
+              <a:t>All repeats predictors</a:t>
             </a:r>
           </a:p>
         </p:txBody>
       </p:sp>
       <p:sp>
         <p:nvSpPr>
-          <p:cNvPr id="138" name="TextBox 137">
+          <p:cNvPr id="30" name="TextBox 29">
             <a:extLst>
               <a:ext uri="{FF2B5EF4-FFF2-40B4-BE49-F238E27FC236}">
-                <a16:creationId xmlns:a16="http://schemas.microsoft.com/office/drawing/2014/main" id="{A88B4DB5-778D-BDDE-9C40-1F799D5FAA6D}"/>
+                <a16:creationId xmlns:a16="http://schemas.microsoft.com/office/drawing/2014/main" id="{68A936E3-726E-C2E7-17CC-E398FC4D63C9}"/>
               </a:ext>
             </a:extLst>
           </p:cNvPr>
@@ -13717,8 +15206,44 @@
         </p:nvSpPr>
         <p:spPr>
           <a:xfrm>
-            <a:off x="21789477" y="12873728"/>
-            <a:ext cx="545402" cy="430887"/>
+            <a:off x="15700231" y="14460199"/>
+            <a:ext cx="2797722" cy="307777"/>
+          </a:xfrm>
+          <a:prstGeom prst="rect">
+            <a:avLst/>
+          </a:prstGeom>
+          <a:noFill/>
+        </p:spPr>
+        <p:txBody>
+          <a:bodyPr wrap="square" rtlCol="0">
+            <a:spAutoFit/>
+          </a:bodyPr>
+          <a:lstStyle/>
+          <a:p>
+            <a:pPr algn="r"/>
+            <a:r>
+              <a:rPr lang="en-US" dirty="0"/>
+              <a:t>Mammalia main model set</a:t>
+            </a:r>
+          </a:p>
+        </p:txBody>
+      </p:sp>
+      <p:sp>
+        <p:nvSpPr>
+          <p:cNvPr id="46" name="TextBox 45">
+            <a:extLst>
+              <a:ext uri="{FF2B5EF4-FFF2-40B4-BE49-F238E27FC236}">
+                <a16:creationId xmlns:a16="http://schemas.microsoft.com/office/drawing/2014/main" id="{E4ABC90B-3EA6-9049-767F-C98D8B1E62A4}"/>
+              </a:ext>
+            </a:extLst>
+          </p:cNvPr>
+          <p:cNvSpPr txBox="1"/>
+          <p:nvPr/>
+        </p:nvSpPr>
+        <p:spPr>
+          <a:xfrm>
+            <a:off x="18534444" y="14456976"/>
+            <a:ext cx="1954517" cy="307777"/>
           </a:xfrm>
           <a:prstGeom prst="rect">
             <a:avLst/>
@@ -13733,1741 +15258,18 @@
           <a:p>
             <a:pPr algn="ctr"/>
             <a:r>
-              <a:rPr lang="en-US" sz="2200" dirty="0"/>
-              <a:t>4</a:t>
-            </a:r>
-          </a:p>
-        </p:txBody>
-      </p:sp>
-      <p:sp>
-        <p:nvSpPr>
-          <p:cNvPr id="139" name="TextBox 138">
-            <a:extLst>
-              <a:ext uri="{FF2B5EF4-FFF2-40B4-BE49-F238E27FC236}">
-                <a16:creationId xmlns:a16="http://schemas.microsoft.com/office/drawing/2014/main" id="{5BE086E4-A0BD-4A0D-226B-955572E42368}"/>
-              </a:ext>
-            </a:extLst>
-          </p:cNvPr>
-          <p:cNvSpPr txBox="1"/>
-          <p:nvPr/>
-        </p:nvSpPr>
-        <p:spPr>
-          <a:xfrm>
-            <a:off x="22465274" y="12873728"/>
-            <a:ext cx="545402" cy="430887"/>
-          </a:xfrm>
-          <a:prstGeom prst="rect">
-            <a:avLst/>
-          </a:prstGeom>
-          <a:noFill/>
-        </p:spPr>
-        <p:txBody>
-          <a:bodyPr wrap="square" rtlCol="0">
-            <a:spAutoFit/>
-          </a:bodyPr>
-          <a:lstStyle/>
-          <a:p>
-            <a:pPr algn="ctr"/>
-            <a:r>
-              <a:rPr lang="en-US" sz="2200" dirty="0"/>
-              <a:t>-1</a:t>
-            </a:r>
-          </a:p>
-        </p:txBody>
-      </p:sp>
-      <p:sp>
-        <p:nvSpPr>
-          <p:cNvPr id="140" name="TextBox 139">
-            <a:extLst>
-              <a:ext uri="{FF2B5EF4-FFF2-40B4-BE49-F238E27FC236}">
-                <a16:creationId xmlns:a16="http://schemas.microsoft.com/office/drawing/2014/main" id="{12A13680-888B-D3F0-4C78-BFE9FE19A1BD}"/>
-              </a:ext>
-            </a:extLst>
-          </p:cNvPr>
-          <p:cNvSpPr txBox="1"/>
-          <p:nvPr/>
-        </p:nvSpPr>
-        <p:spPr>
-          <a:xfrm>
-            <a:off x="22975656" y="12873728"/>
-            <a:ext cx="545402" cy="430887"/>
-          </a:xfrm>
-          <a:prstGeom prst="rect">
-            <a:avLst/>
-          </a:prstGeom>
-          <a:noFill/>
-        </p:spPr>
-        <p:txBody>
-          <a:bodyPr wrap="square" rtlCol="0">
-            <a:spAutoFit/>
-          </a:bodyPr>
-          <a:lstStyle/>
-          <a:p>
-            <a:pPr algn="ctr"/>
-            <a:r>
-              <a:rPr lang="en-US" sz="2200" dirty="0"/>
-              <a:t>0</a:t>
-            </a:r>
-          </a:p>
-        </p:txBody>
-      </p:sp>
-      <p:sp>
-        <p:nvSpPr>
-          <p:cNvPr id="141" name="TextBox 140">
-            <a:extLst>
-              <a:ext uri="{FF2B5EF4-FFF2-40B4-BE49-F238E27FC236}">
-                <a16:creationId xmlns:a16="http://schemas.microsoft.com/office/drawing/2014/main" id="{69C42779-A672-6E1C-0B38-1966D0A7864D}"/>
-              </a:ext>
-            </a:extLst>
-          </p:cNvPr>
-          <p:cNvSpPr txBox="1"/>
-          <p:nvPr/>
-        </p:nvSpPr>
-        <p:spPr>
-          <a:xfrm>
-            <a:off x="23489032" y="12873728"/>
-            <a:ext cx="545402" cy="430887"/>
-          </a:xfrm>
-          <a:prstGeom prst="rect">
-            <a:avLst/>
-          </a:prstGeom>
-          <a:noFill/>
-        </p:spPr>
-        <p:txBody>
-          <a:bodyPr wrap="square" rtlCol="0">
-            <a:spAutoFit/>
-          </a:bodyPr>
-          <a:lstStyle/>
-          <a:p>
-            <a:pPr algn="ctr"/>
-            <a:r>
-              <a:rPr lang="en-US" sz="2200" dirty="0"/>
-              <a:t>1</a:t>
-            </a:r>
-          </a:p>
-        </p:txBody>
-      </p:sp>
-      <p:sp>
-        <p:nvSpPr>
-          <p:cNvPr id="142" name="TextBox 141">
-            <a:extLst>
-              <a:ext uri="{FF2B5EF4-FFF2-40B4-BE49-F238E27FC236}">
-                <a16:creationId xmlns:a16="http://schemas.microsoft.com/office/drawing/2014/main" id="{9FE7BA4E-9E4B-BAEB-CB57-BDA3FF9156EB}"/>
-              </a:ext>
-            </a:extLst>
-          </p:cNvPr>
-          <p:cNvSpPr txBox="1"/>
-          <p:nvPr/>
-        </p:nvSpPr>
-        <p:spPr>
-          <a:xfrm>
-            <a:off x="24000208" y="12873728"/>
-            <a:ext cx="545402" cy="430887"/>
-          </a:xfrm>
-          <a:prstGeom prst="rect">
-            <a:avLst/>
-          </a:prstGeom>
-          <a:noFill/>
-        </p:spPr>
-        <p:txBody>
-          <a:bodyPr wrap="square" rtlCol="0">
-            <a:spAutoFit/>
-          </a:bodyPr>
-          <a:lstStyle/>
-          <a:p>
-            <a:pPr algn="ctr"/>
-            <a:r>
-              <a:rPr lang="en-US" sz="2200" dirty="0"/>
-              <a:t>2</a:t>
-            </a:r>
-          </a:p>
-        </p:txBody>
-      </p:sp>
-      <p:sp>
-        <p:nvSpPr>
-          <p:cNvPr id="143" name="TextBox 142">
-            <a:extLst>
-              <a:ext uri="{FF2B5EF4-FFF2-40B4-BE49-F238E27FC236}">
-                <a16:creationId xmlns:a16="http://schemas.microsoft.com/office/drawing/2014/main" id="{60A5A40A-3B21-1F6E-937D-CA80085F3B66}"/>
-              </a:ext>
-            </a:extLst>
-          </p:cNvPr>
-          <p:cNvSpPr txBox="1"/>
-          <p:nvPr/>
-        </p:nvSpPr>
-        <p:spPr>
-          <a:xfrm>
-            <a:off x="24512790" y="12873728"/>
-            <a:ext cx="545402" cy="430887"/>
-          </a:xfrm>
-          <a:prstGeom prst="rect">
-            <a:avLst/>
-          </a:prstGeom>
-          <a:noFill/>
-        </p:spPr>
-        <p:txBody>
-          <a:bodyPr wrap="square" rtlCol="0">
-            <a:spAutoFit/>
-          </a:bodyPr>
-          <a:lstStyle/>
-          <a:p>
-            <a:pPr algn="ctr"/>
-            <a:r>
-              <a:rPr lang="en-US" sz="2200" dirty="0"/>
-              <a:t>3</a:t>
-            </a:r>
-          </a:p>
-        </p:txBody>
-      </p:sp>
-      <p:sp>
-        <p:nvSpPr>
-          <p:cNvPr id="144" name="TextBox 143">
-            <a:extLst>
-              <a:ext uri="{FF2B5EF4-FFF2-40B4-BE49-F238E27FC236}">
-                <a16:creationId xmlns:a16="http://schemas.microsoft.com/office/drawing/2014/main" id="{F8DD27A5-785F-A2D9-1516-36E058D94CE0}"/>
-              </a:ext>
-            </a:extLst>
-          </p:cNvPr>
-          <p:cNvSpPr txBox="1"/>
-          <p:nvPr/>
-        </p:nvSpPr>
-        <p:spPr>
-          <a:xfrm>
-            <a:off x="25026342" y="12873728"/>
-            <a:ext cx="545402" cy="430887"/>
-          </a:xfrm>
-          <a:prstGeom prst="rect">
-            <a:avLst/>
-          </a:prstGeom>
-          <a:noFill/>
-        </p:spPr>
-        <p:txBody>
-          <a:bodyPr wrap="square" rtlCol="0">
-            <a:spAutoFit/>
-          </a:bodyPr>
-          <a:lstStyle/>
-          <a:p>
-            <a:pPr algn="ctr"/>
-            <a:r>
-              <a:rPr lang="en-US" sz="2200" dirty="0"/>
-              <a:t>4</a:t>
-            </a:r>
-          </a:p>
-        </p:txBody>
-      </p:sp>
-      <p:sp>
-        <p:nvSpPr>
-          <p:cNvPr id="145" name="TextBox 144">
-            <a:extLst>
-              <a:ext uri="{FF2B5EF4-FFF2-40B4-BE49-F238E27FC236}">
-                <a16:creationId xmlns:a16="http://schemas.microsoft.com/office/drawing/2014/main" id="{203A0E21-B553-337B-9AC2-29EB46A50158}"/>
-              </a:ext>
-            </a:extLst>
-          </p:cNvPr>
-          <p:cNvSpPr txBox="1"/>
-          <p:nvPr/>
-        </p:nvSpPr>
-        <p:spPr>
-          <a:xfrm>
-            <a:off x="19143825" y="17899750"/>
-            <a:ext cx="545402" cy="430887"/>
-          </a:xfrm>
-          <a:prstGeom prst="rect">
-            <a:avLst/>
-          </a:prstGeom>
-          <a:noFill/>
-        </p:spPr>
-        <p:txBody>
-          <a:bodyPr wrap="square" rtlCol="0">
-            <a:spAutoFit/>
-          </a:bodyPr>
-          <a:lstStyle/>
-          <a:p>
-            <a:pPr algn="ctr"/>
-            <a:r>
-              <a:rPr lang="en-US" sz="2200" dirty="0"/>
-              <a:t>-8</a:t>
-            </a:r>
-          </a:p>
-        </p:txBody>
-      </p:sp>
-      <p:sp>
-        <p:nvSpPr>
-          <p:cNvPr id="146" name="TextBox 145">
-            <a:extLst>
-              <a:ext uri="{FF2B5EF4-FFF2-40B4-BE49-F238E27FC236}">
-                <a16:creationId xmlns:a16="http://schemas.microsoft.com/office/drawing/2014/main" id="{0E615CEC-F571-F444-B8DD-6C225527D40E}"/>
-              </a:ext>
-            </a:extLst>
-          </p:cNvPr>
-          <p:cNvSpPr txBox="1"/>
-          <p:nvPr/>
-        </p:nvSpPr>
-        <p:spPr>
-          <a:xfrm>
-            <a:off x="19634364" y="17899750"/>
-            <a:ext cx="545402" cy="430887"/>
-          </a:xfrm>
-          <a:prstGeom prst="rect">
-            <a:avLst/>
-          </a:prstGeom>
-          <a:noFill/>
-        </p:spPr>
-        <p:txBody>
-          <a:bodyPr wrap="square" rtlCol="0">
-            <a:spAutoFit/>
-          </a:bodyPr>
-          <a:lstStyle/>
-          <a:p>
-            <a:pPr algn="ctr"/>
-            <a:r>
-              <a:rPr lang="en-US" sz="2200" dirty="0"/>
-              <a:t>-6</a:t>
-            </a:r>
-          </a:p>
-        </p:txBody>
-      </p:sp>
-      <p:sp>
-        <p:nvSpPr>
-          <p:cNvPr id="147" name="TextBox 146">
-            <a:extLst>
-              <a:ext uri="{FF2B5EF4-FFF2-40B4-BE49-F238E27FC236}">
-                <a16:creationId xmlns:a16="http://schemas.microsoft.com/office/drawing/2014/main" id="{84295A36-DC7E-47A8-CC99-EA74F283412A}"/>
-              </a:ext>
-            </a:extLst>
-          </p:cNvPr>
-          <p:cNvSpPr txBox="1"/>
-          <p:nvPr/>
-        </p:nvSpPr>
-        <p:spPr>
-          <a:xfrm>
-            <a:off x="20127282" y="17899749"/>
-            <a:ext cx="545402" cy="430887"/>
-          </a:xfrm>
-          <a:prstGeom prst="rect">
-            <a:avLst/>
-          </a:prstGeom>
-          <a:noFill/>
-        </p:spPr>
-        <p:txBody>
-          <a:bodyPr wrap="square" rtlCol="0">
-            <a:spAutoFit/>
-          </a:bodyPr>
-          <a:lstStyle/>
-          <a:p>
-            <a:pPr algn="ctr"/>
-            <a:r>
-              <a:rPr lang="en-US" sz="2200" dirty="0"/>
-              <a:t>-4</a:t>
-            </a:r>
-          </a:p>
-        </p:txBody>
-      </p:sp>
-      <p:sp>
-        <p:nvSpPr>
-          <p:cNvPr id="148" name="TextBox 147">
-            <a:extLst>
-              <a:ext uri="{FF2B5EF4-FFF2-40B4-BE49-F238E27FC236}">
-                <a16:creationId xmlns:a16="http://schemas.microsoft.com/office/drawing/2014/main" id="{BC7F3196-BF3A-D979-3062-0D1ADD306A88}"/>
-              </a:ext>
-            </a:extLst>
-          </p:cNvPr>
-          <p:cNvSpPr txBox="1"/>
-          <p:nvPr/>
-        </p:nvSpPr>
-        <p:spPr>
-          <a:xfrm>
-            <a:off x="20615440" y="17899748"/>
-            <a:ext cx="545402" cy="430887"/>
-          </a:xfrm>
-          <a:prstGeom prst="rect">
-            <a:avLst/>
-          </a:prstGeom>
-          <a:noFill/>
-        </p:spPr>
-        <p:txBody>
-          <a:bodyPr wrap="square" rtlCol="0">
-            <a:spAutoFit/>
-          </a:bodyPr>
-          <a:lstStyle/>
-          <a:p>
-            <a:pPr algn="ctr"/>
-            <a:r>
-              <a:rPr lang="en-US" sz="2200" dirty="0"/>
-              <a:t>-2</a:t>
-            </a:r>
-          </a:p>
-        </p:txBody>
-      </p:sp>
-      <p:sp>
-        <p:nvSpPr>
-          <p:cNvPr id="149" name="TextBox 148">
-            <a:extLst>
-              <a:ext uri="{FF2B5EF4-FFF2-40B4-BE49-F238E27FC236}">
-                <a16:creationId xmlns:a16="http://schemas.microsoft.com/office/drawing/2014/main" id="{D27985B3-99E1-B64B-87CC-D7AB177D2687}"/>
-              </a:ext>
-            </a:extLst>
-          </p:cNvPr>
-          <p:cNvSpPr txBox="1"/>
-          <p:nvPr/>
-        </p:nvSpPr>
-        <p:spPr>
-          <a:xfrm>
-            <a:off x="21105160" y="17899747"/>
-            <a:ext cx="545402" cy="430887"/>
-          </a:xfrm>
-          <a:prstGeom prst="rect">
-            <a:avLst/>
-          </a:prstGeom>
-          <a:noFill/>
-        </p:spPr>
-        <p:txBody>
-          <a:bodyPr wrap="square" rtlCol="0">
-            <a:spAutoFit/>
-          </a:bodyPr>
-          <a:lstStyle/>
-          <a:p>
-            <a:pPr algn="ctr"/>
-            <a:r>
-              <a:rPr lang="en-US" sz="2200" dirty="0"/>
-              <a:t>0</a:t>
-            </a:r>
-          </a:p>
-        </p:txBody>
-      </p:sp>
-      <p:sp>
-        <p:nvSpPr>
-          <p:cNvPr id="150" name="TextBox 149">
-            <a:extLst>
-              <a:ext uri="{FF2B5EF4-FFF2-40B4-BE49-F238E27FC236}">
-                <a16:creationId xmlns:a16="http://schemas.microsoft.com/office/drawing/2014/main" id="{D078ABF6-4026-C414-9BB7-A7312F38671E}"/>
-              </a:ext>
-            </a:extLst>
-          </p:cNvPr>
-          <p:cNvSpPr txBox="1"/>
-          <p:nvPr/>
-        </p:nvSpPr>
-        <p:spPr>
-          <a:xfrm>
-            <a:off x="21594977" y="17899746"/>
-            <a:ext cx="545402" cy="430887"/>
-          </a:xfrm>
-          <a:prstGeom prst="rect">
-            <a:avLst/>
-          </a:prstGeom>
-          <a:noFill/>
-        </p:spPr>
-        <p:txBody>
-          <a:bodyPr wrap="square" rtlCol="0">
-            <a:spAutoFit/>
-          </a:bodyPr>
-          <a:lstStyle/>
-          <a:p>
-            <a:pPr algn="ctr"/>
-            <a:r>
-              <a:rPr lang="en-US" sz="2200" dirty="0"/>
-              <a:t>2</a:t>
-            </a:r>
-          </a:p>
-        </p:txBody>
-      </p:sp>
-      <p:sp>
-        <p:nvSpPr>
-          <p:cNvPr id="151" name="TextBox 150">
-            <a:extLst>
-              <a:ext uri="{FF2B5EF4-FFF2-40B4-BE49-F238E27FC236}">
-                <a16:creationId xmlns:a16="http://schemas.microsoft.com/office/drawing/2014/main" id="{B994D4AC-7815-9318-9A7D-B65E009E7285}"/>
-              </a:ext>
-            </a:extLst>
-          </p:cNvPr>
-          <p:cNvSpPr txBox="1"/>
-          <p:nvPr/>
-        </p:nvSpPr>
-        <p:spPr>
-          <a:xfrm>
-            <a:off x="22416979" y="17899746"/>
-            <a:ext cx="545402" cy="430887"/>
-          </a:xfrm>
-          <a:prstGeom prst="rect">
-            <a:avLst/>
-          </a:prstGeom>
-          <a:noFill/>
-        </p:spPr>
-        <p:txBody>
-          <a:bodyPr wrap="square" rtlCol="0">
-            <a:spAutoFit/>
-          </a:bodyPr>
-          <a:lstStyle/>
-          <a:p>
-            <a:pPr algn="ctr"/>
-            <a:r>
-              <a:rPr lang="en-US" sz="2200" dirty="0"/>
-              <a:t>-8</a:t>
-            </a:r>
-          </a:p>
-        </p:txBody>
-      </p:sp>
-      <p:sp>
-        <p:nvSpPr>
-          <p:cNvPr id="152" name="TextBox 151">
-            <a:extLst>
-              <a:ext uri="{FF2B5EF4-FFF2-40B4-BE49-F238E27FC236}">
-                <a16:creationId xmlns:a16="http://schemas.microsoft.com/office/drawing/2014/main" id="{8D53E06A-609F-BC63-C618-46B5D76B38FB}"/>
-              </a:ext>
-            </a:extLst>
-          </p:cNvPr>
-          <p:cNvSpPr txBox="1"/>
-          <p:nvPr/>
-        </p:nvSpPr>
-        <p:spPr>
-          <a:xfrm>
-            <a:off x="22900375" y="17899746"/>
-            <a:ext cx="545402" cy="430887"/>
-          </a:xfrm>
-          <a:prstGeom prst="rect">
-            <a:avLst/>
-          </a:prstGeom>
-          <a:noFill/>
-        </p:spPr>
-        <p:txBody>
-          <a:bodyPr wrap="square" rtlCol="0">
-            <a:spAutoFit/>
-          </a:bodyPr>
-          <a:lstStyle/>
-          <a:p>
-            <a:pPr algn="ctr"/>
-            <a:r>
-              <a:rPr lang="en-US" sz="2200" dirty="0"/>
-              <a:t>-6</a:t>
-            </a:r>
-          </a:p>
-        </p:txBody>
-      </p:sp>
-      <p:sp>
-        <p:nvSpPr>
-          <p:cNvPr id="153" name="TextBox 152">
-            <a:extLst>
-              <a:ext uri="{FF2B5EF4-FFF2-40B4-BE49-F238E27FC236}">
-                <a16:creationId xmlns:a16="http://schemas.microsoft.com/office/drawing/2014/main" id="{943E971D-3B8B-395E-0AFC-43DDFBA15B55}"/>
-              </a:ext>
-            </a:extLst>
-          </p:cNvPr>
-          <p:cNvSpPr txBox="1"/>
-          <p:nvPr/>
-        </p:nvSpPr>
-        <p:spPr>
-          <a:xfrm>
-            <a:off x="23381385" y="17899745"/>
-            <a:ext cx="545402" cy="430887"/>
-          </a:xfrm>
-          <a:prstGeom prst="rect">
-            <a:avLst/>
-          </a:prstGeom>
-          <a:noFill/>
-        </p:spPr>
-        <p:txBody>
-          <a:bodyPr wrap="square" rtlCol="0">
-            <a:spAutoFit/>
-          </a:bodyPr>
-          <a:lstStyle/>
-          <a:p>
-            <a:pPr algn="ctr"/>
-            <a:r>
-              <a:rPr lang="en-US" sz="2200" dirty="0"/>
-              <a:t>-4</a:t>
-            </a:r>
-          </a:p>
-        </p:txBody>
-      </p:sp>
-      <p:sp>
-        <p:nvSpPr>
-          <p:cNvPr id="154" name="TextBox 153">
-            <a:extLst>
-              <a:ext uri="{FF2B5EF4-FFF2-40B4-BE49-F238E27FC236}">
-                <a16:creationId xmlns:a16="http://schemas.microsoft.com/office/drawing/2014/main" id="{5FC63E18-10E4-C4F8-8F42-104B5F54DA98}"/>
-              </a:ext>
-            </a:extLst>
-          </p:cNvPr>
-          <p:cNvSpPr txBox="1"/>
-          <p:nvPr/>
-        </p:nvSpPr>
-        <p:spPr>
-          <a:xfrm>
-            <a:off x="23862402" y="17899744"/>
-            <a:ext cx="545402" cy="430887"/>
-          </a:xfrm>
-          <a:prstGeom prst="rect">
-            <a:avLst/>
-          </a:prstGeom>
-          <a:noFill/>
-        </p:spPr>
-        <p:txBody>
-          <a:bodyPr wrap="square" rtlCol="0">
-            <a:spAutoFit/>
-          </a:bodyPr>
-          <a:lstStyle/>
-          <a:p>
-            <a:pPr algn="ctr"/>
-            <a:r>
-              <a:rPr lang="en-US" sz="2200" dirty="0"/>
-              <a:t>-2</a:t>
-            </a:r>
-          </a:p>
-        </p:txBody>
-      </p:sp>
-      <p:sp>
-        <p:nvSpPr>
-          <p:cNvPr id="155" name="TextBox 154">
-            <a:extLst>
-              <a:ext uri="{FF2B5EF4-FFF2-40B4-BE49-F238E27FC236}">
-                <a16:creationId xmlns:a16="http://schemas.microsoft.com/office/drawing/2014/main" id="{C4F13E0C-E7CB-CCD3-9257-AC516AC39B95}"/>
-              </a:ext>
-            </a:extLst>
-          </p:cNvPr>
-          <p:cNvSpPr txBox="1"/>
-          <p:nvPr/>
-        </p:nvSpPr>
-        <p:spPr>
-          <a:xfrm>
-            <a:off x="24344977" y="17899743"/>
-            <a:ext cx="545402" cy="430887"/>
-          </a:xfrm>
-          <a:prstGeom prst="rect">
-            <a:avLst/>
-          </a:prstGeom>
-          <a:noFill/>
-        </p:spPr>
-        <p:txBody>
-          <a:bodyPr wrap="square" rtlCol="0">
-            <a:spAutoFit/>
-          </a:bodyPr>
-          <a:lstStyle/>
-          <a:p>
-            <a:pPr algn="ctr"/>
-            <a:r>
-              <a:rPr lang="en-US" sz="2200" dirty="0"/>
-              <a:t>0</a:t>
-            </a:r>
-          </a:p>
-        </p:txBody>
-      </p:sp>
-      <p:sp>
-        <p:nvSpPr>
-          <p:cNvPr id="156" name="TextBox 155">
-            <a:extLst>
-              <a:ext uri="{FF2B5EF4-FFF2-40B4-BE49-F238E27FC236}">
-                <a16:creationId xmlns:a16="http://schemas.microsoft.com/office/drawing/2014/main" id="{DA8D0E22-F70B-6F0D-8E25-D64809EE65D8}"/>
-              </a:ext>
-            </a:extLst>
-          </p:cNvPr>
-          <p:cNvSpPr txBox="1"/>
-          <p:nvPr/>
-        </p:nvSpPr>
-        <p:spPr>
-          <a:xfrm>
-            <a:off x="24830031" y="17899742"/>
-            <a:ext cx="545402" cy="430887"/>
-          </a:xfrm>
-          <a:prstGeom prst="rect">
-            <a:avLst/>
-          </a:prstGeom>
-          <a:noFill/>
-        </p:spPr>
-        <p:txBody>
-          <a:bodyPr wrap="square" rtlCol="0">
-            <a:spAutoFit/>
-          </a:bodyPr>
-          <a:lstStyle/>
-          <a:p>
-            <a:pPr algn="ctr"/>
-            <a:r>
-              <a:rPr lang="en-US" sz="2200" dirty="0"/>
-              <a:t>2</a:t>
-            </a:r>
-          </a:p>
-        </p:txBody>
-      </p:sp>
-      <p:sp>
-        <p:nvSpPr>
-          <p:cNvPr id="157" name="TextBox 156">
-            <a:extLst>
-              <a:ext uri="{FF2B5EF4-FFF2-40B4-BE49-F238E27FC236}">
-                <a16:creationId xmlns:a16="http://schemas.microsoft.com/office/drawing/2014/main" id="{0CE4C0A4-6839-FE5B-75F2-2A04390D35BB}"/>
-              </a:ext>
-            </a:extLst>
-          </p:cNvPr>
-          <p:cNvSpPr txBox="1"/>
-          <p:nvPr/>
-        </p:nvSpPr>
-        <p:spPr>
-          <a:xfrm>
-            <a:off x="10555466" y="17900945"/>
-            <a:ext cx="545402" cy="430887"/>
-          </a:xfrm>
-          <a:prstGeom prst="rect">
-            <a:avLst/>
-          </a:prstGeom>
-          <a:noFill/>
-        </p:spPr>
-        <p:txBody>
-          <a:bodyPr wrap="square" rtlCol="0">
-            <a:spAutoFit/>
-          </a:bodyPr>
-          <a:lstStyle/>
-          <a:p>
-            <a:pPr algn="ctr"/>
-            <a:r>
-              <a:rPr lang="en-US" sz="2200" dirty="0"/>
-              <a:t>-1</a:t>
-            </a:r>
-          </a:p>
-        </p:txBody>
-      </p:sp>
-      <p:sp>
-        <p:nvSpPr>
-          <p:cNvPr id="163" name="TextBox 162">
-            <a:extLst>
-              <a:ext uri="{FF2B5EF4-FFF2-40B4-BE49-F238E27FC236}">
-                <a16:creationId xmlns:a16="http://schemas.microsoft.com/office/drawing/2014/main" id="{7BB03766-D22E-FC8B-DC29-C81D638009DB}"/>
-              </a:ext>
-            </a:extLst>
-          </p:cNvPr>
-          <p:cNvSpPr txBox="1"/>
-          <p:nvPr/>
-        </p:nvSpPr>
-        <p:spPr>
-          <a:xfrm>
-            <a:off x="11318763" y="17899741"/>
-            <a:ext cx="728805" cy="430887"/>
-          </a:xfrm>
-          <a:prstGeom prst="rect">
-            <a:avLst/>
-          </a:prstGeom>
-          <a:noFill/>
-        </p:spPr>
-        <p:txBody>
-          <a:bodyPr wrap="square" rtlCol="0">
-            <a:spAutoFit/>
-          </a:bodyPr>
-          <a:lstStyle/>
-          <a:p>
-            <a:pPr algn="ctr"/>
-            <a:r>
-              <a:rPr lang="en-US" sz="2200" dirty="0"/>
-              <a:t>-0.5</a:t>
-            </a:r>
-          </a:p>
-        </p:txBody>
-      </p:sp>
-      <p:sp>
-        <p:nvSpPr>
-          <p:cNvPr id="164" name="TextBox 163">
-            <a:extLst>
-              <a:ext uri="{FF2B5EF4-FFF2-40B4-BE49-F238E27FC236}">
-                <a16:creationId xmlns:a16="http://schemas.microsoft.com/office/drawing/2014/main" id="{B18C857C-A226-1494-5C6E-BCE85FF346C9}"/>
-              </a:ext>
-            </a:extLst>
-          </p:cNvPr>
-          <p:cNvSpPr txBox="1"/>
-          <p:nvPr/>
-        </p:nvSpPr>
-        <p:spPr>
-          <a:xfrm>
-            <a:off x="12174732" y="17899740"/>
-            <a:ext cx="728805" cy="430887"/>
-          </a:xfrm>
-          <a:prstGeom prst="rect">
-            <a:avLst/>
-          </a:prstGeom>
-          <a:noFill/>
-        </p:spPr>
-        <p:txBody>
-          <a:bodyPr wrap="square" rtlCol="0">
-            <a:spAutoFit/>
-          </a:bodyPr>
-          <a:lstStyle/>
-          <a:p>
-            <a:pPr algn="ctr"/>
-            <a:r>
-              <a:rPr lang="en-US" sz="2200" dirty="0"/>
-              <a:t>0</a:t>
-            </a:r>
-          </a:p>
-        </p:txBody>
-      </p:sp>
-      <p:sp>
-        <p:nvSpPr>
-          <p:cNvPr id="165" name="TextBox 164">
-            <a:extLst>
-              <a:ext uri="{FF2B5EF4-FFF2-40B4-BE49-F238E27FC236}">
-                <a16:creationId xmlns:a16="http://schemas.microsoft.com/office/drawing/2014/main" id="{242B523C-19E5-A72A-5898-A713AA1FAF9E}"/>
-              </a:ext>
-            </a:extLst>
-          </p:cNvPr>
-          <p:cNvSpPr txBox="1"/>
-          <p:nvPr/>
-        </p:nvSpPr>
-        <p:spPr>
-          <a:xfrm>
-            <a:off x="13027992" y="17897358"/>
-            <a:ext cx="728805" cy="430887"/>
-          </a:xfrm>
-          <a:prstGeom prst="rect">
-            <a:avLst/>
-          </a:prstGeom>
-          <a:noFill/>
-        </p:spPr>
-        <p:txBody>
-          <a:bodyPr wrap="square" rtlCol="0">
-            <a:spAutoFit/>
-          </a:bodyPr>
-          <a:lstStyle/>
-          <a:p>
-            <a:pPr algn="ctr"/>
-            <a:r>
-              <a:rPr lang="en-US" sz="2200" dirty="0"/>
-              <a:t>0.5</a:t>
-            </a:r>
-          </a:p>
-        </p:txBody>
-      </p:sp>
-      <p:sp>
-        <p:nvSpPr>
-          <p:cNvPr id="166" name="TextBox 165">
-            <a:extLst>
-              <a:ext uri="{FF2B5EF4-FFF2-40B4-BE49-F238E27FC236}">
-                <a16:creationId xmlns:a16="http://schemas.microsoft.com/office/drawing/2014/main" id="{80D1D589-6028-6CF2-0437-B4EA36450059}"/>
-              </a:ext>
-            </a:extLst>
-          </p:cNvPr>
-          <p:cNvSpPr txBox="1"/>
-          <p:nvPr/>
-        </p:nvSpPr>
-        <p:spPr>
-          <a:xfrm>
-            <a:off x="13825721" y="17899038"/>
-            <a:ext cx="545402" cy="430887"/>
-          </a:xfrm>
-          <a:prstGeom prst="rect">
-            <a:avLst/>
-          </a:prstGeom>
-          <a:noFill/>
-        </p:spPr>
-        <p:txBody>
-          <a:bodyPr wrap="square" rtlCol="0">
-            <a:spAutoFit/>
-          </a:bodyPr>
-          <a:lstStyle/>
-          <a:p>
-            <a:pPr algn="ctr"/>
-            <a:r>
-              <a:rPr lang="en-US" sz="2200" dirty="0"/>
-              <a:t>-1</a:t>
-            </a:r>
-          </a:p>
-        </p:txBody>
-      </p:sp>
-      <p:sp>
-        <p:nvSpPr>
-          <p:cNvPr id="167" name="TextBox 166">
-            <a:extLst>
-              <a:ext uri="{FF2B5EF4-FFF2-40B4-BE49-F238E27FC236}">
-                <a16:creationId xmlns:a16="http://schemas.microsoft.com/office/drawing/2014/main" id="{792900D2-B8AC-C4C2-5AC7-38B58F34F43E}"/>
-              </a:ext>
-            </a:extLst>
-          </p:cNvPr>
-          <p:cNvSpPr txBox="1"/>
-          <p:nvPr/>
-        </p:nvSpPr>
-        <p:spPr>
-          <a:xfrm>
-            <a:off x="14577112" y="17897834"/>
-            <a:ext cx="728805" cy="430887"/>
-          </a:xfrm>
-          <a:prstGeom prst="rect">
-            <a:avLst/>
-          </a:prstGeom>
-          <a:noFill/>
-        </p:spPr>
-        <p:txBody>
-          <a:bodyPr wrap="square" rtlCol="0">
-            <a:spAutoFit/>
-          </a:bodyPr>
-          <a:lstStyle/>
-          <a:p>
-            <a:pPr algn="ctr"/>
-            <a:r>
-              <a:rPr lang="en-US" sz="2200" dirty="0"/>
-              <a:t>-0.5</a:t>
-            </a:r>
-          </a:p>
-        </p:txBody>
-      </p:sp>
-      <p:sp>
-        <p:nvSpPr>
-          <p:cNvPr id="168" name="TextBox 167">
-            <a:extLst>
-              <a:ext uri="{FF2B5EF4-FFF2-40B4-BE49-F238E27FC236}">
-                <a16:creationId xmlns:a16="http://schemas.microsoft.com/office/drawing/2014/main" id="{722FC5D2-F250-A8BC-CE1C-977F33DEC217}"/>
-              </a:ext>
-            </a:extLst>
-          </p:cNvPr>
-          <p:cNvSpPr txBox="1"/>
-          <p:nvPr/>
-        </p:nvSpPr>
-        <p:spPr>
-          <a:xfrm>
-            <a:off x="15416410" y="17897833"/>
-            <a:ext cx="728805" cy="430887"/>
-          </a:xfrm>
-          <a:prstGeom prst="rect">
-            <a:avLst/>
-          </a:prstGeom>
-          <a:noFill/>
-        </p:spPr>
-        <p:txBody>
-          <a:bodyPr wrap="square" rtlCol="0">
-            <a:spAutoFit/>
-          </a:bodyPr>
-          <a:lstStyle/>
-          <a:p>
-            <a:pPr algn="ctr"/>
-            <a:r>
-              <a:rPr lang="en-US" sz="2200" dirty="0"/>
-              <a:t>0</a:t>
-            </a:r>
-          </a:p>
-        </p:txBody>
-      </p:sp>
-      <p:sp>
-        <p:nvSpPr>
-          <p:cNvPr id="169" name="TextBox 168">
-            <a:extLst>
-              <a:ext uri="{FF2B5EF4-FFF2-40B4-BE49-F238E27FC236}">
-                <a16:creationId xmlns:a16="http://schemas.microsoft.com/office/drawing/2014/main" id="{585C5488-6BFB-B2AD-B60A-B2D707250B9B}"/>
-              </a:ext>
-            </a:extLst>
-          </p:cNvPr>
-          <p:cNvSpPr txBox="1"/>
-          <p:nvPr/>
-        </p:nvSpPr>
-        <p:spPr>
-          <a:xfrm>
-            <a:off x="16257764" y="17895451"/>
-            <a:ext cx="728805" cy="430887"/>
-          </a:xfrm>
-          <a:prstGeom prst="rect">
-            <a:avLst/>
-          </a:prstGeom>
-          <a:noFill/>
-        </p:spPr>
-        <p:txBody>
-          <a:bodyPr wrap="square" rtlCol="0">
-            <a:spAutoFit/>
-          </a:bodyPr>
-          <a:lstStyle/>
-          <a:p>
-            <a:pPr algn="ctr"/>
-            <a:r>
-              <a:rPr lang="en-US" sz="2200" dirty="0"/>
-              <a:t>0.5</a:t>
-            </a:r>
-          </a:p>
-        </p:txBody>
-      </p:sp>
-      <p:sp>
-        <p:nvSpPr>
-          <p:cNvPr id="170" name="TextBox 169">
-            <a:extLst>
-              <a:ext uri="{FF2B5EF4-FFF2-40B4-BE49-F238E27FC236}">
-                <a16:creationId xmlns:a16="http://schemas.microsoft.com/office/drawing/2014/main" id="{671291B5-B34A-FF19-2C86-C72DE90CD805}"/>
-              </a:ext>
-            </a:extLst>
-          </p:cNvPr>
-          <p:cNvSpPr txBox="1"/>
-          <p:nvPr/>
-        </p:nvSpPr>
-        <p:spPr>
-          <a:xfrm>
-            <a:off x="10534907" y="12868966"/>
-            <a:ext cx="545402" cy="430887"/>
-          </a:xfrm>
-          <a:prstGeom prst="rect">
-            <a:avLst/>
-          </a:prstGeom>
-          <a:noFill/>
-        </p:spPr>
-        <p:txBody>
-          <a:bodyPr wrap="square" rtlCol="0">
-            <a:spAutoFit/>
-          </a:bodyPr>
-          <a:lstStyle/>
-          <a:p>
-            <a:pPr algn="ctr"/>
-            <a:r>
-              <a:rPr lang="en-US" sz="2200" dirty="0"/>
-              <a:t>-3</a:t>
-            </a:r>
-          </a:p>
-        </p:txBody>
-      </p:sp>
-      <p:sp>
-        <p:nvSpPr>
-          <p:cNvPr id="171" name="TextBox 170">
-            <a:extLst>
-              <a:ext uri="{FF2B5EF4-FFF2-40B4-BE49-F238E27FC236}">
-                <a16:creationId xmlns:a16="http://schemas.microsoft.com/office/drawing/2014/main" id="{210FFA48-3B37-237D-CECA-DE748F0013FF}"/>
-              </a:ext>
-            </a:extLst>
-          </p:cNvPr>
-          <p:cNvSpPr txBox="1"/>
-          <p:nvPr/>
-        </p:nvSpPr>
-        <p:spPr>
-          <a:xfrm>
-            <a:off x="10930194" y="12868966"/>
-            <a:ext cx="545402" cy="430887"/>
-          </a:xfrm>
-          <a:prstGeom prst="rect">
-            <a:avLst/>
-          </a:prstGeom>
-          <a:noFill/>
-        </p:spPr>
-        <p:txBody>
-          <a:bodyPr wrap="square" rtlCol="0">
-            <a:spAutoFit/>
-          </a:bodyPr>
-          <a:lstStyle/>
-          <a:p>
-            <a:pPr algn="ctr"/>
-            <a:r>
-              <a:rPr lang="en-US" sz="2200" dirty="0"/>
-              <a:t>-2</a:t>
-            </a:r>
-          </a:p>
-        </p:txBody>
-      </p:sp>
-      <p:sp>
-        <p:nvSpPr>
-          <p:cNvPr id="172" name="TextBox 171">
-            <a:extLst>
-              <a:ext uri="{FF2B5EF4-FFF2-40B4-BE49-F238E27FC236}">
-                <a16:creationId xmlns:a16="http://schemas.microsoft.com/office/drawing/2014/main" id="{5EE07892-CD5A-B309-7318-DC6393997328}"/>
-              </a:ext>
-            </a:extLst>
-          </p:cNvPr>
-          <p:cNvSpPr txBox="1"/>
-          <p:nvPr/>
-        </p:nvSpPr>
-        <p:spPr>
-          <a:xfrm>
-            <a:off x="11326637" y="12867981"/>
-            <a:ext cx="545402" cy="430887"/>
-          </a:xfrm>
-          <a:prstGeom prst="rect">
-            <a:avLst/>
-          </a:prstGeom>
-          <a:noFill/>
-        </p:spPr>
-        <p:txBody>
-          <a:bodyPr wrap="square" rtlCol="0">
-            <a:spAutoFit/>
-          </a:bodyPr>
-          <a:lstStyle/>
-          <a:p>
-            <a:pPr algn="ctr"/>
-            <a:r>
-              <a:rPr lang="en-US" sz="2200" dirty="0"/>
-              <a:t>-1</a:t>
-            </a:r>
-          </a:p>
-        </p:txBody>
-      </p:sp>
-      <p:sp>
-        <p:nvSpPr>
-          <p:cNvPr id="173" name="TextBox 172">
-            <a:extLst>
-              <a:ext uri="{FF2B5EF4-FFF2-40B4-BE49-F238E27FC236}">
-                <a16:creationId xmlns:a16="http://schemas.microsoft.com/office/drawing/2014/main" id="{7886D208-57BF-FF17-320C-4D7FB836FC38}"/>
-              </a:ext>
-            </a:extLst>
-          </p:cNvPr>
-          <p:cNvSpPr txBox="1"/>
-          <p:nvPr/>
-        </p:nvSpPr>
-        <p:spPr>
-          <a:xfrm>
-            <a:off x="11722986" y="12869377"/>
-            <a:ext cx="545402" cy="430887"/>
-          </a:xfrm>
-          <a:prstGeom prst="rect">
-            <a:avLst/>
-          </a:prstGeom>
-          <a:noFill/>
-        </p:spPr>
-        <p:txBody>
-          <a:bodyPr wrap="square" rtlCol="0">
-            <a:spAutoFit/>
-          </a:bodyPr>
-          <a:lstStyle/>
-          <a:p>
-            <a:pPr algn="ctr"/>
-            <a:r>
-              <a:rPr lang="en-US" sz="2200" dirty="0"/>
-              <a:t>0</a:t>
-            </a:r>
-          </a:p>
-        </p:txBody>
-      </p:sp>
-      <p:sp>
-        <p:nvSpPr>
-          <p:cNvPr id="174" name="TextBox 173">
-            <a:extLst>
-              <a:ext uri="{FF2B5EF4-FFF2-40B4-BE49-F238E27FC236}">
-                <a16:creationId xmlns:a16="http://schemas.microsoft.com/office/drawing/2014/main" id="{59B0E611-C4E0-2011-D003-CE98A3847FCA}"/>
-              </a:ext>
-            </a:extLst>
-          </p:cNvPr>
-          <p:cNvSpPr txBox="1"/>
-          <p:nvPr/>
-        </p:nvSpPr>
-        <p:spPr>
-          <a:xfrm>
-            <a:off x="12120558" y="12867981"/>
-            <a:ext cx="545402" cy="430887"/>
-          </a:xfrm>
-          <a:prstGeom prst="rect">
-            <a:avLst/>
-          </a:prstGeom>
-          <a:noFill/>
-        </p:spPr>
-        <p:txBody>
-          <a:bodyPr wrap="square" rtlCol="0">
-            <a:spAutoFit/>
-          </a:bodyPr>
-          <a:lstStyle/>
-          <a:p>
-            <a:pPr algn="ctr"/>
-            <a:r>
-              <a:rPr lang="en-US" sz="2200" dirty="0"/>
-              <a:t>1</a:t>
-            </a:r>
-          </a:p>
-        </p:txBody>
-      </p:sp>
-      <p:sp>
-        <p:nvSpPr>
-          <p:cNvPr id="175" name="TextBox 174">
-            <a:extLst>
-              <a:ext uri="{FF2B5EF4-FFF2-40B4-BE49-F238E27FC236}">
-                <a16:creationId xmlns:a16="http://schemas.microsoft.com/office/drawing/2014/main" id="{069BCC2E-A5AE-96D7-D1B9-85B132364C37}"/>
-              </a:ext>
-            </a:extLst>
-          </p:cNvPr>
-          <p:cNvSpPr txBox="1"/>
-          <p:nvPr/>
-        </p:nvSpPr>
-        <p:spPr>
-          <a:xfrm>
-            <a:off x="12515412" y="12868966"/>
-            <a:ext cx="545402" cy="430887"/>
-          </a:xfrm>
-          <a:prstGeom prst="rect">
-            <a:avLst/>
-          </a:prstGeom>
-          <a:noFill/>
-        </p:spPr>
-        <p:txBody>
-          <a:bodyPr wrap="square" rtlCol="0">
-            <a:spAutoFit/>
-          </a:bodyPr>
-          <a:lstStyle/>
-          <a:p>
-            <a:pPr algn="ctr"/>
-            <a:r>
-              <a:rPr lang="en-US" sz="2200" dirty="0"/>
-              <a:t>2</a:t>
-            </a:r>
-          </a:p>
-        </p:txBody>
-      </p:sp>
-      <p:sp>
-        <p:nvSpPr>
-          <p:cNvPr id="176" name="TextBox 175">
-            <a:extLst>
-              <a:ext uri="{FF2B5EF4-FFF2-40B4-BE49-F238E27FC236}">
-                <a16:creationId xmlns:a16="http://schemas.microsoft.com/office/drawing/2014/main" id="{53692F83-AC3D-59B2-277C-EBE24F826BA5}"/>
-              </a:ext>
-            </a:extLst>
-          </p:cNvPr>
-          <p:cNvSpPr txBox="1"/>
-          <p:nvPr/>
-        </p:nvSpPr>
-        <p:spPr>
-          <a:xfrm>
-            <a:off x="12912984" y="12867408"/>
-            <a:ext cx="545402" cy="430887"/>
-          </a:xfrm>
-          <a:prstGeom prst="rect">
-            <a:avLst/>
-          </a:prstGeom>
-          <a:noFill/>
-        </p:spPr>
-        <p:txBody>
-          <a:bodyPr wrap="square" rtlCol="0">
-            <a:spAutoFit/>
-          </a:bodyPr>
-          <a:lstStyle/>
-          <a:p>
-            <a:pPr algn="ctr"/>
-            <a:r>
-              <a:rPr lang="en-US" sz="2200" dirty="0"/>
-              <a:t>3</a:t>
-            </a:r>
-          </a:p>
-        </p:txBody>
-      </p:sp>
-      <p:sp>
-        <p:nvSpPr>
-          <p:cNvPr id="177" name="TextBox 176">
-            <a:extLst>
-              <a:ext uri="{FF2B5EF4-FFF2-40B4-BE49-F238E27FC236}">
-                <a16:creationId xmlns:a16="http://schemas.microsoft.com/office/drawing/2014/main" id="{6C2C6834-7BD4-7EB3-10F0-93FB23104A44}"/>
-              </a:ext>
-            </a:extLst>
-          </p:cNvPr>
-          <p:cNvSpPr txBox="1"/>
-          <p:nvPr/>
-        </p:nvSpPr>
-        <p:spPr>
-          <a:xfrm>
-            <a:off x="13805681" y="12866424"/>
-            <a:ext cx="545402" cy="430887"/>
-          </a:xfrm>
-          <a:prstGeom prst="rect">
-            <a:avLst/>
-          </a:prstGeom>
-          <a:noFill/>
-        </p:spPr>
-        <p:txBody>
-          <a:bodyPr wrap="square" rtlCol="0">
-            <a:spAutoFit/>
-          </a:bodyPr>
-          <a:lstStyle/>
-          <a:p>
-            <a:pPr algn="ctr"/>
-            <a:r>
-              <a:rPr lang="en-US" sz="2200" dirty="0"/>
-              <a:t>-3</a:t>
-            </a:r>
-          </a:p>
-        </p:txBody>
-      </p:sp>
-      <p:sp>
-        <p:nvSpPr>
-          <p:cNvPr id="178" name="TextBox 177">
-            <a:extLst>
-              <a:ext uri="{FF2B5EF4-FFF2-40B4-BE49-F238E27FC236}">
-                <a16:creationId xmlns:a16="http://schemas.microsoft.com/office/drawing/2014/main" id="{84990DB9-C8D2-CE2D-64B3-AE79B63894B7}"/>
-              </a:ext>
-            </a:extLst>
-          </p:cNvPr>
-          <p:cNvSpPr txBox="1"/>
-          <p:nvPr/>
-        </p:nvSpPr>
-        <p:spPr>
-          <a:xfrm>
-            <a:off x="14193825" y="12866424"/>
-            <a:ext cx="545402" cy="430887"/>
-          </a:xfrm>
-          <a:prstGeom prst="rect">
-            <a:avLst/>
-          </a:prstGeom>
-          <a:noFill/>
-        </p:spPr>
-        <p:txBody>
-          <a:bodyPr wrap="square" rtlCol="0">
-            <a:spAutoFit/>
-          </a:bodyPr>
-          <a:lstStyle/>
-          <a:p>
-            <a:pPr algn="ctr"/>
-            <a:r>
-              <a:rPr lang="en-US" sz="2200" dirty="0"/>
-              <a:t>-2</a:t>
-            </a:r>
-          </a:p>
-        </p:txBody>
-      </p:sp>
-      <p:sp>
-        <p:nvSpPr>
-          <p:cNvPr id="179" name="TextBox 178">
-            <a:extLst>
-              <a:ext uri="{FF2B5EF4-FFF2-40B4-BE49-F238E27FC236}">
-                <a16:creationId xmlns:a16="http://schemas.microsoft.com/office/drawing/2014/main" id="{1A4B73AF-FADD-00CE-FA57-FF37B0081E84}"/>
-              </a:ext>
-            </a:extLst>
-          </p:cNvPr>
-          <p:cNvSpPr txBox="1"/>
-          <p:nvPr/>
-        </p:nvSpPr>
-        <p:spPr>
-          <a:xfrm>
-            <a:off x="14583124" y="12865439"/>
-            <a:ext cx="545402" cy="430887"/>
-          </a:xfrm>
-          <a:prstGeom prst="rect">
-            <a:avLst/>
-          </a:prstGeom>
-          <a:noFill/>
-        </p:spPr>
-        <p:txBody>
-          <a:bodyPr wrap="square" rtlCol="0">
-            <a:spAutoFit/>
-          </a:bodyPr>
-          <a:lstStyle/>
-          <a:p>
-            <a:pPr algn="ctr"/>
-            <a:r>
-              <a:rPr lang="en-US" sz="2200" dirty="0"/>
-              <a:t>-1</a:t>
-            </a:r>
-          </a:p>
-        </p:txBody>
-      </p:sp>
-      <p:sp>
-        <p:nvSpPr>
-          <p:cNvPr id="180" name="TextBox 179">
-            <a:extLst>
-              <a:ext uri="{FF2B5EF4-FFF2-40B4-BE49-F238E27FC236}">
-                <a16:creationId xmlns:a16="http://schemas.microsoft.com/office/drawing/2014/main" id="{99ADD6DC-88DE-0928-781B-FBEA4AD07B92}"/>
-              </a:ext>
-            </a:extLst>
-          </p:cNvPr>
-          <p:cNvSpPr txBox="1"/>
-          <p:nvPr/>
-        </p:nvSpPr>
-        <p:spPr>
-          <a:xfrm>
-            <a:off x="14972329" y="12866835"/>
-            <a:ext cx="545402" cy="430887"/>
-          </a:xfrm>
-          <a:prstGeom prst="rect">
-            <a:avLst/>
-          </a:prstGeom>
-          <a:noFill/>
-        </p:spPr>
-        <p:txBody>
-          <a:bodyPr wrap="square" rtlCol="0">
-            <a:spAutoFit/>
-          </a:bodyPr>
-          <a:lstStyle/>
-          <a:p>
-            <a:pPr algn="ctr"/>
-            <a:r>
-              <a:rPr lang="en-US" sz="2200" dirty="0"/>
-              <a:t>0</a:t>
-            </a:r>
-          </a:p>
-        </p:txBody>
-      </p:sp>
-      <p:sp>
-        <p:nvSpPr>
-          <p:cNvPr id="181" name="TextBox 180">
-            <a:extLst>
-              <a:ext uri="{FF2B5EF4-FFF2-40B4-BE49-F238E27FC236}">
-                <a16:creationId xmlns:a16="http://schemas.microsoft.com/office/drawing/2014/main" id="{D4E4679B-F9A6-46B3-D925-FFD6580DFFAE}"/>
-              </a:ext>
-            </a:extLst>
-          </p:cNvPr>
-          <p:cNvSpPr txBox="1"/>
-          <p:nvPr/>
-        </p:nvSpPr>
-        <p:spPr>
-          <a:xfrm>
-            <a:off x="15362756" y="12865439"/>
-            <a:ext cx="545402" cy="430887"/>
-          </a:xfrm>
-          <a:prstGeom prst="rect">
-            <a:avLst/>
-          </a:prstGeom>
-          <a:noFill/>
-        </p:spPr>
-        <p:txBody>
-          <a:bodyPr wrap="square" rtlCol="0">
-            <a:spAutoFit/>
-          </a:bodyPr>
-          <a:lstStyle/>
-          <a:p>
-            <a:pPr algn="ctr"/>
-            <a:r>
-              <a:rPr lang="en-US" sz="2200" dirty="0"/>
-              <a:t>1</a:t>
-            </a:r>
-          </a:p>
-        </p:txBody>
-      </p:sp>
-      <p:sp>
-        <p:nvSpPr>
-          <p:cNvPr id="182" name="TextBox 181">
-            <a:extLst>
-              <a:ext uri="{FF2B5EF4-FFF2-40B4-BE49-F238E27FC236}">
-                <a16:creationId xmlns:a16="http://schemas.microsoft.com/office/drawing/2014/main" id="{9055745F-B6CD-C39F-0AFB-8BE4F7FDD2BD}"/>
-              </a:ext>
-            </a:extLst>
-          </p:cNvPr>
-          <p:cNvSpPr txBox="1"/>
-          <p:nvPr/>
-        </p:nvSpPr>
-        <p:spPr>
-          <a:xfrm>
-            <a:off x="15757610" y="12866424"/>
-            <a:ext cx="545402" cy="430887"/>
-          </a:xfrm>
-          <a:prstGeom prst="rect">
-            <a:avLst/>
-          </a:prstGeom>
-          <a:noFill/>
-        </p:spPr>
-        <p:txBody>
-          <a:bodyPr wrap="square" rtlCol="0">
-            <a:spAutoFit/>
-          </a:bodyPr>
-          <a:lstStyle/>
-          <a:p>
-            <a:pPr algn="ctr"/>
-            <a:r>
-              <a:rPr lang="en-US" sz="2200" dirty="0"/>
-              <a:t>2</a:t>
-            </a:r>
-          </a:p>
-        </p:txBody>
-      </p:sp>
-      <p:sp>
-        <p:nvSpPr>
-          <p:cNvPr id="183" name="TextBox 182">
-            <a:extLst>
-              <a:ext uri="{FF2B5EF4-FFF2-40B4-BE49-F238E27FC236}">
-                <a16:creationId xmlns:a16="http://schemas.microsoft.com/office/drawing/2014/main" id="{98CAE64E-41B7-444C-22D8-DA955C1EC38C}"/>
-              </a:ext>
-            </a:extLst>
-          </p:cNvPr>
-          <p:cNvSpPr txBox="1"/>
-          <p:nvPr/>
-        </p:nvSpPr>
-        <p:spPr>
-          <a:xfrm>
-            <a:off x="16148039" y="12864866"/>
-            <a:ext cx="545402" cy="430887"/>
-          </a:xfrm>
-          <a:prstGeom prst="rect">
-            <a:avLst/>
-          </a:prstGeom>
-          <a:noFill/>
-        </p:spPr>
-        <p:txBody>
-          <a:bodyPr wrap="square" rtlCol="0">
-            <a:spAutoFit/>
-          </a:bodyPr>
-          <a:lstStyle/>
-          <a:p>
-            <a:pPr algn="ctr"/>
-            <a:r>
-              <a:rPr lang="en-US" sz="2200" dirty="0"/>
-              <a:t>3</a:t>
-            </a:r>
-          </a:p>
-        </p:txBody>
-      </p:sp>
-      <p:sp>
-        <p:nvSpPr>
-          <p:cNvPr id="184" name="TextBox 183">
-            <a:extLst>
-              <a:ext uri="{FF2B5EF4-FFF2-40B4-BE49-F238E27FC236}">
-                <a16:creationId xmlns:a16="http://schemas.microsoft.com/office/drawing/2014/main" id="{67A64FB2-52AB-85C8-DBB2-58C3AED7F343}"/>
-              </a:ext>
-            </a:extLst>
-          </p:cNvPr>
-          <p:cNvSpPr txBox="1"/>
-          <p:nvPr/>
-        </p:nvSpPr>
-        <p:spPr>
-          <a:xfrm>
-            <a:off x="10485616" y="8758704"/>
-            <a:ext cx="2942389" cy="400110"/>
-          </a:xfrm>
-          <a:prstGeom prst="rect">
-            <a:avLst/>
-          </a:prstGeom>
-          <a:noFill/>
-        </p:spPr>
-        <p:txBody>
-          <a:bodyPr wrap="square" rtlCol="0">
-            <a:spAutoFit/>
-          </a:bodyPr>
-          <a:lstStyle/>
-          <a:p>
-            <a:pPr algn="ctr"/>
-            <a:r>
-              <a:rPr lang="en-US" sz="2000" dirty="0"/>
-              <a:t>Main model set</a:t>
-            </a:r>
-          </a:p>
-        </p:txBody>
-      </p:sp>
-      <p:sp>
-        <p:nvSpPr>
-          <p:cNvPr id="185" name="TextBox 184">
-            <a:extLst>
-              <a:ext uri="{FF2B5EF4-FFF2-40B4-BE49-F238E27FC236}">
-                <a16:creationId xmlns:a16="http://schemas.microsoft.com/office/drawing/2014/main" id="{0677EE2E-09BD-A85A-8A47-6EEFA6CAB494}"/>
-              </a:ext>
-            </a:extLst>
-          </p:cNvPr>
-          <p:cNvSpPr txBox="1"/>
-          <p:nvPr/>
-        </p:nvSpPr>
-        <p:spPr>
-          <a:xfrm>
-            <a:off x="13771052" y="8761184"/>
-            <a:ext cx="2869123" cy="400110"/>
-          </a:xfrm>
-          <a:prstGeom prst="rect">
-            <a:avLst/>
-          </a:prstGeom>
-          <a:noFill/>
-        </p:spPr>
-        <p:txBody>
-          <a:bodyPr wrap="square" rtlCol="0">
-            <a:spAutoFit/>
-          </a:bodyPr>
-          <a:lstStyle/>
-          <a:p>
-            <a:pPr algn="ctr"/>
-            <a:r>
-              <a:rPr lang="en-US" sz="2000" dirty="0"/>
-              <a:t>All repeats</a:t>
-            </a:r>
-          </a:p>
-        </p:txBody>
-      </p:sp>
-      <p:sp>
-        <p:nvSpPr>
-          <p:cNvPr id="186" name="TextBox 185">
-            <a:extLst>
-              <a:ext uri="{FF2B5EF4-FFF2-40B4-BE49-F238E27FC236}">
-                <a16:creationId xmlns:a16="http://schemas.microsoft.com/office/drawing/2014/main" id="{E4113106-342D-310C-DCA8-FC6CE61C75EE}"/>
-              </a:ext>
-            </a:extLst>
-          </p:cNvPr>
-          <p:cNvSpPr txBox="1"/>
-          <p:nvPr/>
-        </p:nvSpPr>
-        <p:spPr>
-          <a:xfrm>
-            <a:off x="10488791" y="13791079"/>
-            <a:ext cx="2942389" cy="400110"/>
-          </a:xfrm>
-          <a:prstGeom prst="rect">
-            <a:avLst/>
-          </a:prstGeom>
-          <a:noFill/>
-        </p:spPr>
-        <p:txBody>
-          <a:bodyPr wrap="square" rtlCol="0">
-            <a:spAutoFit/>
-          </a:bodyPr>
-          <a:lstStyle/>
-          <a:p>
-            <a:pPr algn="ctr"/>
-            <a:r>
-              <a:rPr lang="en-US" sz="2000" dirty="0"/>
-              <a:t>Main model set</a:t>
-            </a:r>
-          </a:p>
-        </p:txBody>
-      </p:sp>
-      <p:sp>
-        <p:nvSpPr>
-          <p:cNvPr id="187" name="TextBox 186">
-            <a:extLst>
-              <a:ext uri="{FF2B5EF4-FFF2-40B4-BE49-F238E27FC236}">
-                <a16:creationId xmlns:a16="http://schemas.microsoft.com/office/drawing/2014/main" id="{B5D71632-1ADA-8DD4-AF59-890121E4E9DC}"/>
-              </a:ext>
-            </a:extLst>
-          </p:cNvPr>
-          <p:cNvSpPr txBox="1"/>
-          <p:nvPr/>
-        </p:nvSpPr>
-        <p:spPr>
-          <a:xfrm>
-            <a:off x="13774227" y="13793559"/>
-            <a:ext cx="2869123" cy="400110"/>
-          </a:xfrm>
-          <a:prstGeom prst="rect">
-            <a:avLst/>
-          </a:prstGeom>
-          <a:noFill/>
-        </p:spPr>
-        <p:txBody>
-          <a:bodyPr wrap="square" rtlCol="0">
-            <a:spAutoFit/>
-          </a:bodyPr>
-          <a:lstStyle/>
-          <a:p>
-            <a:pPr algn="ctr"/>
-            <a:r>
-              <a:rPr lang="en-US" sz="2000" dirty="0"/>
-              <a:t>All repeats</a:t>
-            </a:r>
-          </a:p>
-        </p:txBody>
-      </p:sp>
-      <p:sp>
-        <p:nvSpPr>
-          <p:cNvPr id="188" name="TextBox 187">
-            <a:extLst>
-              <a:ext uri="{FF2B5EF4-FFF2-40B4-BE49-F238E27FC236}">
-                <a16:creationId xmlns:a16="http://schemas.microsoft.com/office/drawing/2014/main" id="{AC631CD0-6E3D-6D4B-4A16-59E3C6996265}"/>
-              </a:ext>
-            </a:extLst>
-          </p:cNvPr>
-          <p:cNvSpPr txBox="1"/>
-          <p:nvPr/>
-        </p:nvSpPr>
-        <p:spPr>
-          <a:xfrm>
-            <a:off x="19362574" y="8762180"/>
-            <a:ext cx="2942389" cy="400110"/>
-          </a:xfrm>
-          <a:prstGeom prst="rect">
-            <a:avLst/>
-          </a:prstGeom>
-          <a:noFill/>
-        </p:spPr>
-        <p:txBody>
-          <a:bodyPr wrap="square" rtlCol="0">
-            <a:spAutoFit/>
-          </a:bodyPr>
-          <a:lstStyle/>
-          <a:p>
-            <a:pPr algn="ctr"/>
-            <a:r>
-              <a:rPr lang="en-US" sz="2000" dirty="0"/>
-              <a:t>Main model set</a:t>
-            </a:r>
-          </a:p>
-        </p:txBody>
-      </p:sp>
-      <p:sp>
-        <p:nvSpPr>
-          <p:cNvPr id="189" name="TextBox 188">
-            <a:extLst>
-              <a:ext uri="{FF2B5EF4-FFF2-40B4-BE49-F238E27FC236}">
-                <a16:creationId xmlns:a16="http://schemas.microsoft.com/office/drawing/2014/main" id="{A7D3C8D3-4F9B-C3EA-1962-1D6A58392910}"/>
-              </a:ext>
-            </a:extLst>
-          </p:cNvPr>
-          <p:cNvSpPr txBox="1"/>
-          <p:nvPr/>
-        </p:nvSpPr>
-        <p:spPr>
-          <a:xfrm>
-            <a:off x="22648010" y="8764660"/>
-            <a:ext cx="2869123" cy="400110"/>
-          </a:xfrm>
-          <a:prstGeom prst="rect">
-            <a:avLst/>
-          </a:prstGeom>
-          <a:noFill/>
-        </p:spPr>
-        <p:txBody>
-          <a:bodyPr wrap="square" rtlCol="0">
-            <a:spAutoFit/>
-          </a:bodyPr>
-          <a:lstStyle/>
-          <a:p>
-            <a:pPr algn="ctr"/>
-            <a:r>
-              <a:rPr lang="en-US" sz="2000" dirty="0"/>
-              <a:t>All repeats</a:t>
-            </a:r>
-          </a:p>
-        </p:txBody>
-      </p:sp>
-      <p:sp>
-        <p:nvSpPr>
-          <p:cNvPr id="190" name="TextBox 189">
-            <a:extLst>
-              <a:ext uri="{FF2B5EF4-FFF2-40B4-BE49-F238E27FC236}">
-                <a16:creationId xmlns:a16="http://schemas.microsoft.com/office/drawing/2014/main" id="{9A7146D8-1CC1-36B6-7FA0-CA13588FACBA}"/>
-              </a:ext>
-            </a:extLst>
-          </p:cNvPr>
-          <p:cNvSpPr txBox="1"/>
-          <p:nvPr/>
-        </p:nvSpPr>
-        <p:spPr>
-          <a:xfrm>
-            <a:off x="19362571" y="13791474"/>
-            <a:ext cx="2942389" cy="400110"/>
-          </a:xfrm>
-          <a:prstGeom prst="rect">
-            <a:avLst/>
-          </a:prstGeom>
-          <a:noFill/>
-        </p:spPr>
-        <p:txBody>
-          <a:bodyPr wrap="square" rtlCol="0">
-            <a:spAutoFit/>
-          </a:bodyPr>
-          <a:lstStyle/>
-          <a:p>
-            <a:pPr algn="ctr"/>
-            <a:r>
-              <a:rPr lang="en-US" sz="2000" dirty="0"/>
-              <a:t>Main model set</a:t>
-            </a:r>
-          </a:p>
-        </p:txBody>
-      </p:sp>
-      <p:sp>
-        <p:nvSpPr>
-          <p:cNvPr id="191" name="TextBox 190">
-            <a:extLst>
-              <a:ext uri="{FF2B5EF4-FFF2-40B4-BE49-F238E27FC236}">
-                <a16:creationId xmlns:a16="http://schemas.microsoft.com/office/drawing/2014/main" id="{9B6D8E01-81F6-F97D-683D-A5E1D4D02200}"/>
-              </a:ext>
-            </a:extLst>
-          </p:cNvPr>
-          <p:cNvSpPr txBox="1"/>
-          <p:nvPr/>
-        </p:nvSpPr>
-        <p:spPr>
-          <a:xfrm>
-            <a:off x="22648007" y="13793954"/>
-            <a:ext cx="2869123" cy="400110"/>
-          </a:xfrm>
-          <a:prstGeom prst="rect">
-            <a:avLst/>
-          </a:prstGeom>
-          <a:noFill/>
-        </p:spPr>
-        <p:txBody>
-          <a:bodyPr wrap="square" rtlCol="0">
-            <a:spAutoFit/>
-          </a:bodyPr>
-          <a:lstStyle/>
-          <a:p>
-            <a:pPr algn="ctr"/>
-            <a:r>
-              <a:rPr lang="en-US" sz="2000" dirty="0"/>
-              <a:t>All repeats</a:t>
+              <a:rPr lang="en-US" dirty="0"/>
+              <a:t>All repeats predictors</a:t>
             </a:r>
           </a:p>
         </p:txBody>
       </p:sp>
     </p:spTree>
+    <p:extLst>
+      <p:ext uri="{BB962C8B-B14F-4D97-AF65-F5344CB8AC3E}">
+        <p14:creationId xmlns:p14="http://schemas.microsoft.com/office/powerpoint/2010/main" val="3009099826"/>
+      </p:ext>
+    </p:extLst>
   </p:cSld>
   <p:clrMapOvr>
     <a:masterClrMapping/>

</xml_diff>